<commit_message>
Update README, report and slides with World Bank and model-family results
</commit_message>
<xml_diff>
--- a/deliverables/Olympic_Medal_Momentum_Slides.pptx
+++ b/deliverables/Olympic_Medal_Momentum_Slides.pptx
@@ -20,9 +20,10 @@
     <p:sldId id="268" r:id="rId14"/>
     <p:sldId id="269" r:id="rId15"/>
     <p:sldId id="270" r:id="rId16"/>
+    <p:sldId id="271" r:id="rId17"/>
   </p:sldIdLst>
   <p:notesMasterIdLst>
-    <p:notesMasterId r:id="rId17"/>
+    <p:notesMasterId r:id="rId18"/>
   </p:notesMasterIdLst>
   <p:sldSz cx="12192000" cy="6858000"/>
   <p:notesSz cx="6858000" cy="12192000"/>
@@ -121,13 +122,13 @@
   <p:extLst>
     <p:ext uri="{521415D9-36F7-43E2-AB2F-B90AF26B5E84}">
       <p14:sectionLst xmlns:p14="http://schemas.microsoft.com/office/powerpoint/2010/main">
-        <p14:section name="Introduction" id="{89542341-66df-f991-63f7-c767b398bf5a}">
+        <p14:section name="Introduction" id="{12b5dc41-7222-9d0e-f0b3-78748c1d72e6}">
           <p14:sldIdLst>
             <p14:sldId id="256"/>
             <p14:sldId id="257"/>
           </p14:sldIdLst>
         </p14:section>
-        <p14:section name="Data and method" id="{7f0356b4-5c36-509c-dfa1-a1c639f12d3b}">
+        <p14:section name="Data and method" id="{43f382e0-772b-6274-545e-4ac914da8b4c}">
           <p14:sldIdLst>
             <p14:sldId id="258"/>
             <p14:sldId id="259"/>
@@ -135,25 +136,26 @@
             <p14:sldId id="261"/>
           </p14:sldIdLst>
         </p14:section>
-        <p14:section name="Novelty" id="{0f9c344c-a02f-d715-9c1f-05dd9999e117}">
+        <p14:section name="Novelty" id="{c7ab8d55-6342-9713-661f-af745313a0f4}">
           <p14:sldIdLst>
             <p14:sldId id="262"/>
             <p14:sldId id="263"/>
           </p14:sldIdLst>
         </p14:section>
-        <p14:section name="Results" id="{12e65a83-8714-3ddc-866f-ac8a3cff4f4e}">
+        <p14:section name="Results" id="{6a0d89e2-90bc-8fa8-544f-ed971772c9c5}">
           <p14:sldIdLst>
             <p14:sldId id="264"/>
             <p14:sldId id="265"/>
             <p14:sldId id="266"/>
             <p14:sldId id="267"/>
+            <p14:sldId id="268"/>
           </p14:sldIdLst>
         </p14:section>
-        <p14:section name="Conclusion" id="{698f0f96-2622-06c3-bc7b-20a572e8ba52}">
+        <p14:section name="Conclusion" id="{af2bb3c6-bb71-4985-7f5c-f6121afb754a}">
           <p14:sldIdLst>
-            <p14:sldId id="268"/>
             <p14:sldId id="269"/>
             <p14:sldId id="270"/>
+            <p14:sldId id="271"/>
           </p14:sldIdLst>
         </p14:section>
       </p14:sectionLst>
@@ -279,7 +281,7 @@
             <c:bubble3D val="0"/>
             <c:spPr>
               <a:solidFill>
-                <a:srgbClr val="C4CAD4"/>
+                <a:srgbClr val="8F99A9"/>
               </a:solidFill>
               <a:effectLst/>
             </c:spPr>
@@ -290,7 +292,7 @@
             <c:bubble3D val="0"/>
             <c:spPr>
               <a:solidFill>
-                <a:srgbClr val="8F99A9"/>
+                <a:srgbClr val="C4CAD4"/>
               </a:solidFill>
               <a:effectLst/>
             </c:spPr>
@@ -301,7 +303,7 @@
             <c:bubble3D val="0"/>
             <c:spPr>
               <a:solidFill>
-                <a:srgbClr val="C8962E"/>
+                <a:srgbClr val="C4CAD4"/>
               </a:solidFill>
               <a:effectLst/>
             </c:spPr>
@@ -317,11 +319,33 @@
               <a:effectLst/>
             </c:spPr>
           </c:dPt>
+          <c:dPt>
+            <c:idx val="6"/>
+            <c:invertIfNegative val="0"/>
+            <c:bubble3D val="0"/>
+            <c:spPr>
+              <a:solidFill>
+                <a:srgbClr val="C8962E"/>
+              </a:solidFill>
+              <a:effectLst/>
+            </c:spPr>
+          </c:dPt>
+          <c:dPt>
+            <c:idx val="7"/>
+            <c:invertIfNegative val="0"/>
+            <c:bubble3D val="0"/>
+            <c:spPr>
+              <a:solidFill>
+                <a:srgbClr val="C4CAD4"/>
+              </a:solidFill>
+              <a:effectLst/>
+            </c:spPr>
+          </c:dPt>
           <c:cat>
             <c:multiLvlStrRef>
-              <c:f>Sheet1!$A$2:$A$7</c:f>
+              <c:f>Sheet1!$A$2:$A$9</c:f>
               <c:multiLvlStrCache>
-                <c:ptCount val="6"/>
+                <c:ptCount val="8"/>
                 <c:lvl>
                   <c:pt idx="0">
                     <c:v>Baseline</c:v>
@@ -330,15 +354,21 @@
                     <c:v>Historical + Momentum Score</c:v>
                   </c:pt>
                   <c:pt idx="2">
+                    <c:v>Historical Features</c:v>
+                  </c:pt>
+                  <c:pt idx="3">
+                    <c:v>Historical + Economic</c:v>
+                  </c:pt>
+                  <c:pt idx="4">
                     <c:v>Paper Two-Stage</c:v>
                   </c:pt>
-                  <c:pt idx="3">
-                    <c:v>Historical Features</c:v>
+                  <c:pt idx="5">
+                    <c:v>Momentum Target + Economic</c:v>
                   </c:pt>
-                  <c:pt idx="4">
+                  <c:pt idx="6">
                     <c:v>Momentum Target</c:v>
                   </c:pt>
-                  <c:pt idx="5">
+                  <c:pt idx="7">
                     <c:v>Momentum Target + Score</c:v>
                   </c:pt>
                 </c:lvl>
@@ -347,10 +377,10 @@
           </c:cat>
           <c:val>
             <c:numRef>
-              <c:f>Sheet1!$B$2:$B$7</c:f>
+              <c:f>Sheet1!$B$2:$B$9</c:f>
               <c:numCache>
                 <c:formatCode>General</c:formatCode>
-                <c:ptCount val="6"/>
+                <c:ptCount val="8"/>
                 <c:pt idx="0">
                   <c:v>1.606</c:v>
                 </c:pt>
@@ -358,15 +388,21 @@
                   <c:v>1.501</c:v>
                 </c:pt>
                 <c:pt idx="2">
-                  <c:v>1.49</c:v>
+                  <c:v>1.474</c:v>
                 </c:pt>
                 <c:pt idx="3">
-                  <c:v>1.474</c:v>
+                  <c:v>1.461</c:v>
                 </c:pt>
                 <c:pt idx="4">
+                  <c:v>1.442</c:v>
+                </c:pt>
+                <c:pt idx="5">
+                  <c:v>1.307</c:v>
+                </c:pt>
+                <c:pt idx="6">
                   <c:v>1.298</c:v>
                 </c:pt>
-                <c:pt idx="5">
+                <c:pt idx="7">
                   <c:v>1.296</c:v>
                 </c:pt>
               </c:numCache>
@@ -428,7 +464,7 @@
           <a:lstStyle/>
           <a:p>
             <a:pPr>
-              <a:defRPr sz="1300" b="0" i="0" u="none" strike="noStrike">
+              <a:defRPr sz="1200" b="0" i="0" u="none" strike="noStrike">
                 <a:solidFill>
                   <a:srgbClr val="13223A"/>
                 </a:solidFill>
@@ -916,22 +952,22 @@
                 <c:formatCode>General</c:formatCode>
                 <c:ptCount val="6"/>
                 <c:pt idx="0">
-                  <c:v>1.856</c:v>
+                  <c:v>1.867</c:v>
                 </c:pt>
                 <c:pt idx="1">
-                  <c:v>1.628</c:v>
+                  <c:v>1.675</c:v>
                 </c:pt>
                 <c:pt idx="2">
-                  <c:v>1.376</c:v>
+                  <c:v>1.321</c:v>
                 </c:pt>
                 <c:pt idx="3">
-                  <c:v>1.629</c:v>
+                  <c:v>1.649</c:v>
                 </c:pt>
                 <c:pt idx="4">
-                  <c:v>1.369</c:v>
+                  <c:v>1.388</c:v>
                 </c:pt>
                 <c:pt idx="5">
-                  <c:v>1.49</c:v>
+                  <c:v>1.442</c:v>
                 </c:pt>
               </c:numCache>
             </c:numRef>
@@ -1232,6 +1268,417 @@
 </file>
 
 <file path=ppt/charts/chart3.xml><?xml version="1.0" encoding="utf-8"?>
+<c:chartSpace xmlns:c="http://schemas.openxmlformats.org/drawingml/2006/chart" xmlns:a="http://schemas.openxmlformats.org/drawingml/2006/main" xmlns:r="http://schemas.openxmlformats.org/officeDocument/2006/relationships">
+  <c:date1904 val="0"/>
+  <c:roundedCorners val="1"/>
+  <c:chart>
+    <c:title>
+      <c:tx>
+        <c:rich>
+          <a:bodyPr/>
+          <a:lstStyle/>
+          <a:p>
+            <a:pPr>
+              <a:defRPr sz="1300" b="0" i="0" u="none" strike="noStrike">
+                <a:solidFill>
+                  <a:srgbClr val="4A5872"/>
+                </a:solidFill>
+                <a:latin typeface="+mn-lt"/>
+              </a:defRPr>
+            </a:pPr>
+            <a:r>
+              <a:rPr sz="1300" b="0" i="0" u="none" strike="noStrike">
+                <a:solidFill>
+                  <a:srgbClr val="4A5872"/>
+                </a:solidFill>
+                <a:latin typeface="+mn-lt"/>
+              </a:rPr>
+              <a:t>Rio 2016 MAE by model family</a:t>
+            </a:r>
+          </a:p>
+        </c:rich>
+      </c:tx>
+      <c:layout/>
+      <c:overlay val="0"/>
+    </c:title>
+    <c:autoTitleDeleted val="0"/>
+    <c:plotArea>
+      <c:layout/>
+      <c:barChart>
+        <c:barDir val="bar"/>
+        <c:grouping val="clustered"/>
+        <c:varyColors val="0"/>
+        <c:ser>
+          <c:idx val="0"/>
+          <c:order val="0"/>
+          <c:tx>
+            <c:strRef>
+              <c:f>Sheet1!$B$1</c:f>
+              <c:strCache>
+                <c:ptCount val="1"/>
+                <c:pt idx="0">
+                  <c:v>Predict the count</c:v>
+                </c:pt>
+              </c:strCache>
+            </c:strRef>
+          </c:tx>
+          <c:spPr>
+            <a:solidFill>
+              <a:srgbClr val="C4CAD4"/>
+            </a:solidFill>
+            <a:effectLst/>
+          </c:spPr>
+          <c:invertIfNegative val="0"/>
+          <c:dLbls>
+            <c:numFmt formatCode="0.00;;" sourceLinked="0"/>
+            <c:txPr>
+              <a:bodyPr/>
+              <a:lstStyle/>
+              <a:p>
+                <a:pPr>
+                  <a:defRPr b="0" i="0" strike="noStrike" sz="1100" u="none">
+                    <a:solidFill>
+                      <a:srgbClr val="13223A"/>
+                    </a:solidFill>
+                    <a:latin typeface="+mn-lt"/>
+                  </a:defRPr>
+                </a:pPr>
+              </a:p>
+            </c:txPr>
+            <c:showLegendKey val="0"/>
+            <c:showVal val="1"/>
+            <c:showCatName val="0"/>
+            <c:showSerName val="0"/>
+            <c:showPercent val="0"/>
+            <c:showBubbleSize val="0"/>
+            <c:showLeaderLines val="0"/>
+          </c:dLbls>
+          <c:cat>
+            <c:multiLvlStrRef>
+              <c:f>Sheet1!$A$2:$A$7</c:f>
+              <c:multiLvlStrCache>
+                <c:ptCount val="6"/>
+                <c:lvl>
+                  <c:pt idx="0">
+                    <c:v>Linear Regression</c:v>
+                  </c:pt>
+                  <c:pt idx="1">
+                    <c:v>Ridge</c:v>
+                  </c:pt>
+                  <c:pt idx="2">
+                    <c:v>Lasso</c:v>
+                  </c:pt>
+                  <c:pt idx="3">
+                    <c:v>Poisson Regression</c:v>
+                  </c:pt>
+                  <c:pt idx="4">
+                    <c:v>SVR (RBF kernel)</c:v>
+                  </c:pt>
+                  <c:pt idx="5">
+                    <c:v>Random Forest</c:v>
+                  </c:pt>
+                </c:lvl>
+              </c:multiLvlStrCache>
+            </c:multiLvlStrRef>
+          </c:cat>
+          <c:val>
+            <c:numRef>
+              <c:f>Sheet1!$B$2:$B$7</c:f>
+              <c:numCache>
+                <c:formatCode>General</c:formatCode>
+                <c:ptCount val="6"/>
+                <c:pt idx="0">
+                  <c:v>2.22</c:v>
+                </c:pt>
+                <c:pt idx="1">
+                  <c:v>2.2</c:v>
+                </c:pt>
+                <c:pt idx="2">
+                  <c:v>2.21</c:v>
+                </c:pt>
+                <c:pt idx="3">
+                  <c:v>1.66</c:v>
+                </c:pt>
+                <c:pt idx="4">
+                  <c:v>1.32</c:v>
+                </c:pt>
+                <c:pt idx="5">
+                  <c:v>1.48</c:v>
+                </c:pt>
+              </c:numCache>
+            </c:numRef>
+          </c:val>
+        </c:ser>
+        <c:ser>
+          <c:idx val="1"/>
+          <c:order val="1"/>
+          <c:tx>
+            <c:strRef>
+              <c:f>Sheet1!$C$1</c:f>
+              <c:strCache>
+                <c:ptCount val="1"/>
+                <c:pt idx="0">
+                  <c:v>Predict momentum</c:v>
+                </c:pt>
+              </c:strCache>
+            </c:strRef>
+          </c:tx>
+          <c:spPr>
+            <a:solidFill>
+              <a:srgbClr val="C8962E"/>
+            </a:solidFill>
+            <a:effectLst/>
+          </c:spPr>
+          <c:invertIfNegative val="0"/>
+          <c:dLbls>
+            <c:numFmt formatCode="0.00;;" sourceLinked="0"/>
+            <c:txPr>
+              <a:bodyPr/>
+              <a:lstStyle/>
+              <a:p>
+                <a:pPr>
+                  <a:defRPr b="0" i="0" strike="noStrike" sz="1100" u="none">
+                    <a:solidFill>
+                      <a:srgbClr val="13223A"/>
+                    </a:solidFill>
+                    <a:latin typeface="+mn-lt"/>
+                  </a:defRPr>
+                </a:pPr>
+              </a:p>
+            </c:txPr>
+            <c:showLegendKey val="0"/>
+            <c:showVal val="1"/>
+            <c:showCatName val="0"/>
+            <c:showSerName val="0"/>
+            <c:showPercent val="0"/>
+            <c:showBubbleSize val="0"/>
+            <c:showLeaderLines val="0"/>
+          </c:dLbls>
+          <c:cat>
+            <c:multiLvlStrRef>
+              <c:f>Sheet1!$A$2:$A$7</c:f>
+              <c:multiLvlStrCache>
+                <c:ptCount val="6"/>
+                <c:lvl>
+                  <c:pt idx="0">
+                    <c:v>Linear Regression</c:v>
+                  </c:pt>
+                  <c:pt idx="1">
+                    <c:v>Ridge</c:v>
+                  </c:pt>
+                  <c:pt idx="2">
+                    <c:v>Lasso</c:v>
+                  </c:pt>
+                  <c:pt idx="3">
+                    <c:v>Poisson Regression</c:v>
+                  </c:pt>
+                  <c:pt idx="4">
+                    <c:v>SVR (RBF kernel)</c:v>
+                  </c:pt>
+                  <c:pt idx="5">
+                    <c:v>Random Forest</c:v>
+                  </c:pt>
+                </c:lvl>
+              </c:multiLvlStrCache>
+            </c:multiLvlStrRef>
+          </c:cat>
+          <c:val>
+            <c:numRef>
+              <c:f>Sheet1!$C$2:$C$7</c:f>
+              <c:numCache>
+                <c:formatCode>General</c:formatCode>
+                <c:ptCount val="6"/>
+                <c:pt idx="0">
+                  <c:v>1.38</c:v>
+                </c:pt>
+                <c:pt idx="1">
+                  <c:v>1.35</c:v>
+                </c:pt>
+                <c:pt idx="2">
+                  <c:v>1.31</c:v>
+                </c:pt>
+                <c:pt idx="3">
+                  <c:v>0</c:v>
+                </c:pt>
+                <c:pt idx="4">
+                  <c:v>1.58</c:v>
+                </c:pt>
+                <c:pt idx="5">
+                  <c:v>1.31</c:v>
+                </c:pt>
+              </c:numCache>
+            </c:numRef>
+          </c:val>
+        </c:ser>
+        <c:dLbls>
+          <c:numFmt formatCode="0.00;;" sourceLinked="0"/>
+          <c:txPr>
+            <a:bodyPr/>
+            <a:lstStyle/>
+            <a:p>
+              <a:pPr>
+                <a:defRPr b="0" i="0" strike="noStrike" sz="1100" u="none">
+                  <a:solidFill>
+                    <a:srgbClr val="13223A"/>
+                  </a:solidFill>
+                  <a:latin typeface="+mn-lt"/>
+                </a:defRPr>
+              </a:pPr>
+            </a:p>
+          </c:txPr>
+          <c:showLegendKey val="0"/>
+          <c:showVal val="1"/>
+          <c:showCatName val="0"/>
+          <c:showSerName val="0"/>
+          <c:showPercent val="0"/>
+          <c:showBubbleSize val="0"/>
+          <c:showLeaderLines val="0"/>
+        </c:dLbls>
+        <c:gapWidth val="40"/>
+        <c:overlap val="0"/>
+        <c:axId val="2094734554"/>
+        <c:axId val="2094734552"/>
+        <c:axId val="2094734556"/>
+      </c:barChart>
+      <c:catAx>
+        <c:axId val="2094734554"/>
+        <c:scaling>
+          <c:orientation val="maxMin"/>
+        </c:scaling>
+        <c:delete val="0"/>
+        <c:axPos val="l"/>
+        <c:numFmt formatCode="General" sourceLinked="1"/>
+        <c:majorTickMark val="out"/>
+        <c:minorTickMark val="none"/>
+        <c:tickLblPos val="nextTo"/>
+        <c:spPr>
+          <a:ln w="12700" cap="flat">
+            <a:solidFill>
+              <a:srgbClr val="888888"/>
+            </a:solidFill>
+            <a:prstDash val="solid"/>
+            <a:round/>
+          </a:ln>
+        </c:spPr>
+        <c:txPr>
+          <a:bodyPr/>
+          <a:lstStyle/>
+          <a:p>
+            <a:pPr>
+              <a:defRPr sz="1200" b="0" i="0" u="none" strike="noStrike">
+                <a:solidFill>
+                  <a:srgbClr val="13223A"/>
+                </a:solidFill>
+                <a:latin typeface="+mn-lt"/>
+              </a:defRPr>
+            </a:pPr>
+            <a:endParaRPr lang="en-US"/>
+          </a:p>
+        </c:txPr>
+        <c:crossAx val="2094734552"/>
+        <c:crosses val="autoZero"/>
+        <c:auto val="1"/>
+        <c:lblAlgn val="ctr"/>
+        <c:noMultiLvlLbl val="1"/>
+      </c:catAx>
+      <c:valAx>
+        <c:axId val="2094734552"/>
+        <c:scaling>
+          <c:orientation val="minMax"/>
+          <c:max val="2.5"/>
+          <c:min val="0"/>
+        </c:scaling>
+        <c:delete val="0"/>
+        <c:axPos val="b"/>
+        <c:majorGridlines>
+          <c:spPr>
+            <a:ln w="9525" cap="flat">
+              <a:solidFill>
+                <a:srgbClr val="D3DAE3"/>
+              </a:solidFill>
+              <a:prstDash val="solid"/>
+              <a:round/>
+            </a:ln>
+          </c:spPr>
+        </c:majorGridlines>
+        <c:numFmt formatCode="General" sourceLinked="0"/>
+        <c:majorTickMark val="out"/>
+        <c:minorTickMark val="none"/>
+        <c:tickLblPos val="low"/>
+        <c:spPr>
+          <a:ln w="12700" cap="flat">
+            <a:solidFill>
+              <a:srgbClr val="888888"/>
+            </a:solidFill>
+            <a:prstDash val="solid"/>
+            <a:round/>
+          </a:ln>
+        </c:spPr>
+        <c:txPr>
+          <a:bodyPr/>
+          <a:lstStyle/>
+          <a:p>
+            <a:pPr>
+              <a:defRPr sz="1100" b="0" i="0" u="none" strike="noStrike">
+                <a:solidFill>
+                  <a:srgbClr val="4A5872"/>
+                </a:solidFill>
+                <a:latin typeface="+mn-lt"/>
+              </a:defRPr>
+            </a:pPr>
+            <a:endParaRPr lang="en-US"/>
+          </a:p>
+        </c:txPr>
+        <c:crossAx val="2094734554"/>
+        <c:crosses val="autoZero"/>
+        <c:crossBetween val="between"/>
+        <c:majorUnit val="0.5"/>
+      </c:valAx>
+      <c:spPr>
+        <a:noFill/>
+        <a:ln>
+          <a:noFill/>
+        </a:ln>
+        <a:effectLst/>
+      </c:spPr>
+    </c:plotArea>
+    <c:legend>
+      <c:legendPos val="b"/>
+      <c:overlay val="0"/>
+      <c:txPr>
+        <a:bodyPr/>
+        <a:lstStyle/>
+        <a:p>
+          <a:pPr>
+            <a:defRPr sz="1200">
+              <a:solidFill>
+                <a:srgbClr val="13223A"/>
+              </a:solidFill>
+              <a:latin typeface="+mn-lt"/>
+              <a:cs typeface="+mn-lt"/>
+            </a:defRPr>
+          </a:pPr>
+          <a:endParaRPr lang="en-US"/>
+        </a:p>
+      </c:txPr>
+    </c:legend>
+    <c:plotVisOnly val="1"/>
+    <c:dispBlanksAs val="span"/>
+  </c:chart>
+  <c:spPr>
+    <a:noFill/>
+    <a:ln>
+      <a:noFill/>
+    </a:ln>
+    <a:effectLst/>
+  </c:spPr>
+  <c:externalData r:id="rId1">
+    <c:autoUpdate val="0"/>
+  </c:externalData>
+</c:chartSpace>
+</file>
+
+<file path=ppt/charts/chart4.xml><?xml version="1.0" encoding="utf-8"?>
 <c:chartSpace xmlns:c="http://schemas.openxmlformats.org/drawingml/2006/chart" xmlns:a="http://schemas.openxmlformats.org/drawingml/2006/main" xmlns:r="http://schemas.openxmlformats.org/officeDocument/2006/relationships">
   <c:date1904 val="0"/>
   <c:roundedCorners val="1"/>
@@ -1664,7 +2111,7 @@
 </c:chartSpace>
 </file>
 
-<file path=ppt/charts/chart4.xml><?xml version="1.0" encoding="utf-8"?>
+<file path=ppt/charts/chart5.xml><?xml version="1.0" encoding="utf-8"?>
 <c:chartSpace xmlns:c="http://schemas.openxmlformats.org/drawingml/2006/chart" xmlns:a="http://schemas.openxmlformats.org/drawingml/2006/main" xmlns:r="http://schemas.openxmlformats.org/officeDocument/2006/relationships">
   <c:date1904 val="0"/>
   <c:roundedCorners val="1"/>
@@ -2528,7 +2975,7 @@
           <a:p>
             <a:r>
               <a:rPr lang="en-US" dirty="0"/>
-              <a:t>The dataset stops at 2016, so this is a true out-of-sample test. Tokyo was postponed by COVID and hosted by Japan (58 medals, up from 41). All models that go beyond last Games' count tie at about 1.56 MAE: the momentum edge did not carry over. We report this honestly as a limitation.</a:t>
+              <a:t>Each regressor uses history plus World Bank features, is tuned on 2012 (trained 1964-2008), refitted on 1964-2012 and tested once on Rio 2016. Poisson needs a count target so it has no momentum version. SVR predicting the count is the exception: it has the best RMSE and top-10 error, but this is one test year. The classifier accuracies match the paper's own table (85.5-89.1%).</a:t>
             </a:r>
             <a:endParaRPr lang="en-US" dirty="0"/>
           </a:p>
@@ -2616,7 +3063,7 @@
           <a:p>
             <a:r>
               <a:rPr lang="en-US" dirty="0"/>
-              <a:t>Permutation importance: how much the Rio 2016 MAE rises when one feature is shuffled. Last Games' medals dominates, followed by medal efficiency. The scatter shows actual vs predicted medals for Rio 2016; the largest misses are hosts and nations with sudden swings.</a:t>
+              <a:t>The dataset stops at 2016, so this is a true out-of-sample test. Tokyo was postponed by COVID and hosted by Japan (58 medals, up from 41). Here the World Bank models do best: the paper's two-stage design has the lowest MAE and the economic models are much better on the top 10. The momentum model lands mid-pack. We report this as a limitation.</a:t>
             </a:r>
             <a:endParaRPr lang="en-US" dirty="0"/>
           </a:p>
@@ -2704,7 +3151,7 @@
           <a:p>
             <a:r>
               <a:rPr lang="en-US" dirty="0"/>
-              <a:t>Be upfront about the negative results: the composite score on its own did not help, and Tokyo 2020 showed no edge. These make the main finding more credible.</a:t>
+              <a:t>Permutation importance: how much the Rio 2016 MAE rises when one feature is shuffled. Last Games' medals dominates, followed by medal efficiency. The scatter shows actual vs predicted medals for Rio 2016; the largest misses are hosts and nations with sudden swings.</a:t>
             </a:r>
             <a:endParaRPr lang="en-US" dirty="0"/>
           </a:p>
@@ -2792,7 +3239,7 @@
           <a:p>
             <a:r>
               <a:rPr lang="en-US" dirty="0"/>
-              <a:t>Close with the one-sentence takeaway: how you frame the target matters more than adding another feature. Then switch to the live demo.</a:t>
+              <a:t>Be upfront about the negative results: the composite score on its own did not help, and Tokyo 2020 showed no edge. These make the main finding more credible.</a:t>
             </a:r>
             <a:endParaRPr lang="en-US" dirty="0"/>
           </a:p>
@@ -2880,7 +3327,7 @@
           <a:p>
             <a:r>
               <a:rPr lang="en-US" dirty="0"/>
-              <a:t>Demo order: 1) run the quick pipeline (about 30 seconds), 2) open the notebook and walk through features, momentum and the Rio results, 3) open the website and use the country explorer.</a:t>
+              <a:t>Close with the one-sentence takeaway: how you frame the target matters more than adding another feature. Then switch to the live demo.</a:t>
             </a:r>
             <a:endParaRPr lang="en-US" dirty="0"/>
           </a:p>
@@ -2904,6 +3351,94 @@
             <a:fld id="{F7021451-1387-4CA6-816F-3879F97B5CBC}" type="slidenum">
               <a:rPr lang="en-US"/>
               <a:t>15</a:t>
+            </a:fld>
+            <a:endParaRPr lang="en-US"/>
+          </a:p>
+        </p:txBody>
+      </p:sp>
+    </p:spTree>
+    <p:extLst>
+      <p:ext uri="{BB962C8B-B14F-4D97-AF65-F5344CB8AC3E}">
+        <p14:creationId xmlns:p14="http://schemas.microsoft.com/office/powerpoint/2010/main" val="1024086991"/>
+      </p:ext>
+    </p:extLst>
+  </p:cSld>
+  <p:clrMapOvr>
+    <a:masterClrMapping/>
+  </p:clrMapOvr>
+</p:notes>
+</file>
+
+<file path=ppt/notesSlides/notesSlide16.xml><?xml version="1.0" encoding="utf-8"?>
+<p:notes xmlns:a="http://schemas.openxmlformats.org/drawingml/2006/main" xmlns:r="http://schemas.openxmlformats.org/officeDocument/2006/relationships" xmlns:p="http://schemas.openxmlformats.org/presentationml/2006/main">
+  <p:cSld>
+    <p:spTree>
+      <p:nvGrpSpPr>
+        <p:cNvPr id="1" name=""/>
+        <p:cNvGrpSpPr/>
+        <p:nvPr/>
+      </p:nvGrpSpPr>
+      <p:grpSpPr>
+        <a:xfrm>
+          <a:off x="0" y="0"/>
+          <a:ext cx="0" cy="0"/>
+          <a:chOff x="0" y="0"/>
+          <a:chExt cx="0" cy="0"/>
+        </a:xfrm>
+      </p:grpSpPr>
+      <p:sp>
+        <p:nvSpPr>
+          <p:cNvPr id="2" name="Slide Image Placeholder 1"/>
+          <p:cNvSpPr>
+            <a:spLocks noGrp="1" noRot="1" noChangeAspect="1"/>
+          </p:cNvSpPr>
+          <p:nvPr>
+            <p:ph type="sldImg"/>
+          </p:nvPr>
+        </p:nvSpPr>
+        <p:spPr/>
+      </p:sp>
+      <p:sp>
+        <p:nvSpPr>
+          <p:cNvPr id="3" name="Notes Placeholder 2"/>
+          <p:cNvSpPr>
+            <a:spLocks noGrp="1"/>
+          </p:cNvSpPr>
+          <p:nvPr>
+            <p:ph type="body" idx="1"/>
+          </p:nvPr>
+        </p:nvSpPr>
+        <p:spPr/>
+        <p:txBody>
+          <a:bodyPr/>
+          <a:lstStyle/>
+          <a:p>
+            <a:r>
+              <a:rPr lang="en-US" dirty="0"/>
+              <a:t>Demo order: 1) run the quick pipeline (about 30 seconds), 2) open the notebook and walk through features, momentum and the Rio results, 3) open the website and use the country explorer.</a:t>
+            </a:r>
+            <a:endParaRPr lang="en-US" dirty="0"/>
+          </a:p>
+        </p:txBody>
+      </p:sp>
+      <p:sp>
+        <p:nvSpPr>
+          <p:cNvPr id="4" name="Slide Number Placeholder 3"/>
+          <p:cNvSpPr>
+            <a:spLocks noGrp="1"/>
+          </p:cNvSpPr>
+          <p:nvPr>
+            <p:ph type="sldNum" sz="quarter" idx="10"/>
+          </p:nvPr>
+        </p:nvSpPr>
+        <p:spPr/>
+        <p:txBody>
+          <a:bodyPr/>
+          <a:lstStyle/>
+          <a:p>
+            <a:fld id="{F7021451-1387-4CA6-816F-3879F97B5CBC}" type="slidenum">
+              <a:rPr lang="en-US"/>
+              <a:t>16</a:t>
             </a:fld>
             <a:endParaRPr lang="en-US"/>
           </a:p>
@@ -3496,7 +4031,7 @@
           <a:p>
             <a:r>
               <a:rPr lang="en-US" dirty="0"/>
-              <a:t>Grid: min_samples_leaf in {1,3,5,10} and max_features in {0.6,1.0}, chosen by mean 2012 validation MAE across all six models. Selected: leaf 10, max_features 0.6, 300 trees. Five random seeds.</a:t>
+              <a:t>Grid: min_samples_leaf in {1,3,5,10} and max_features in {0.6,1.0}, chosen by mean 2012 validation MAE across all eight models. Selected: leaf 10, max_features 0.6, 300 trees. Five random seeds.</a:t>
             </a:r>
             <a:endParaRPr lang="en-US" dirty="0"/>
           </a:p>
@@ -5065,6 +5600,1490 @@
                   <a:schemeClr val="tx1"/>
                 </a:solidFill>
               </a:rPr>
+              <a:t>The paper’s models, re-run: momentum helps four of five</a:t>
+            </a:r>
+            <a:endParaRPr lang="en-US" sz="3400" dirty="0"/>
+          </a:p>
+        </p:txBody>
+      </p:sp>
+      <p:graphicFrame>
+        <p:nvGraphicFramePr>
+          <p:cNvPr id="4" name="Model family chart" descr=""/>
+          <p:cNvGraphicFramePr/>
+          <p:nvPr/>
+        </p:nvGraphicFramePr>
+        <p:xfrm>
+          <a:off x="548640" y="1371600"/>
+          <a:ext cx="6400800" cy="4663440"/>
+        </p:xfrm>
+        <a:graphic xmlns:a="http://schemas.openxmlformats.org/drawingml/2006/main">
+          <a:graphicData uri="http://schemas.openxmlformats.org/drawingml/2006/chart">
+            <c:chart xmlns:c="http://schemas.openxmlformats.org/drawingml/2006/chart" r:id="rId1"/>
+          </a:graphicData>
+        </a:graphic>
+      </p:graphicFrame>
+      <p:graphicFrame>
+        <p:nvGraphicFramePr>
+          <p:cNvPr id="12" name="Classifier table"/>
+          <p:cNvGraphicFramePr>
+            <a:graphicFrameLocks noGrp="1"/>
+          </p:cNvGraphicFramePr>
+          <p:nvPr>
+            <p:extLst>
+              <p:ext uri="{D42A27DB-BD31-4B8C-83A1-F6EECF244321}">
+                <p14:modId xmlns:p14="http://schemas.microsoft.com/office/powerpoint/2010/main" val="1579011935"/>
+              </p:ext>
+            </p:extLst>
+          </p:nvPr>
+        </p:nvGraphicFramePr>
+        <p:xfrm>
+          <a:off x="7269480" y="1463040"/>
+          <a:ext cx="4389120" cy="914400"/>
+        </p:xfrm>
+        <a:graphic>
+          <a:graphicData uri="http://schemas.openxmlformats.org/drawingml/2006/table">
+            <a:tbl>
+              <a:tblPr/>
+              <a:tblGrid>
+                <a:gridCol w="2377440"/>
+                <a:gridCol w="1005840"/>
+                <a:gridCol w="1005840"/>
+              </a:tblGrid>
+              <a:tr h="365760">
+                <a:tc>
+                  <a:txBody>
+                    <a:bodyPr/>
+                    <a:lstStyle/>
+                    <a:p>
+                      <a:pPr indent="0" marL="0">
+                        <a:buNone/>
+                      </a:pPr>
+                      <a:r>
+                        <a:rPr lang="en-US" sz="1200" b="1" dirty="0">
+                          <a:solidFill>
+                            <a:schemeClr val="bg1"/>
+                          </a:solidFill>
+                        </a:rPr>
+                        <a:t>Classifier</a:t>
+                      </a:r>
+                      <a:endParaRPr lang="en-US" sz="1200" dirty="0"/>
+                    </a:p>
+                  </a:txBody>
+                  <a:tcPr marL="73152" marR="73152" marT="0" marB="0" anchor="ctr">
+                    <a:lnL w="6350" cap="flat" cmpd="sng" algn="ctr">
+                      <a:solidFill>
+                        <a:srgbClr val="D3DAE3"/>
+                      </a:solidFill>
+                      <a:prstDash val="solid"/>
+                      <a:round/>
+                      <a:headEnd type="none" w="med" len="med"/>
+                      <a:tailEnd type="none" w="med" len="med"/>
+                    </a:lnL>
+                    <a:lnR w="6350" cap="flat" cmpd="sng" algn="ctr">
+                      <a:solidFill>
+                        <a:srgbClr val="D3DAE3"/>
+                      </a:solidFill>
+                      <a:prstDash val="solid"/>
+                      <a:round/>
+                      <a:headEnd type="none" w="med" len="med"/>
+                      <a:tailEnd type="none" w="med" len="med"/>
+                    </a:lnR>
+                    <a:lnT w="6350" cap="flat" cmpd="sng" algn="ctr">
+                      <a:solidFill>
+                        <a:srgbClr val="D3DAE3"/>
+                      </a:solidFill>
+                      <a:prstDash val="solid"/>
+                      <a:round/>
+                      <a:headEnd type="none" w="med" len="med"/>
+                      <a:tailEnd type="none" w="med" len="med"/>
+                    </a:lnT>
+                    <a:lnB w="6350" cap="flat" cmpd="sng" algn="ctr">
+                      <a:solidFill>
+                        <a:srgbClr val="D3DAE3"/>
+                      </a:solidFill>
+                      <a:prstDash val="solid"/>
+                      <a:round/>
+                      <a:headEnd type="none" w="med" len="med"/>
+                      <a:tailEnd type="none" w="med" len="med"/>
+                    </a:lnB>
+                    <a:solidFill>
+                      <a:srgbClr val="13223A"/>
+                    </a:solidFill>
+                  </a:tcPr>
+                </a:tc>
+                <a:tc>
+                  <a:txBody>
+                    <a:bodyPr/>
+                    <a:lstStyle/>
+                    <a:p>
+                      <a:pPr indent="0" marL="0">
+                        <a:buNone/>
+                      </a:pPr>
+                      <a:r>
+                        <a:rPr lang="en-US" sz="1200" b="1" dirty="0">
+                          <a:solidFill>
+                            <a:schemeClr val="bg1"/>
+                          </a:solidFill>
+                        </a:rPr>
+                        <a:t>Acc. 2012</a:t>
+                      </a:r>
+                      <a:endParaRPr lang="en-US" sz="1200" dirty="0"/>
+                    </a:p>
+                  </a:txBody>
+                  <a:tcPr marL="73152" marR="73152" marT="0" marB="0" anchor="ctr">
+                    <a:lnL w="6350" cap="flat" cmpd="sng" algn="ctr">
+                      <a:solidFill>
+                        <a:srgbClr val="D3DAE3"/>
+                      </a:solidFill>
+                      <a:prstDash val="solid"/>
+                      <a:round/>
+                      <a:headEnd type="none" w="med" len="med"/>
+                      <a:tailEnd type="none" w="med" len="med"/>
+                    </a:lnL>
+                    <a:lnR w="6350" cap="flat" cmpd="sng" algn="ctr">
+                      <a:solidFill>
+                        <a:srgbClr val="D3DAE3"/>
+                      </a:solidFill>
+                      <a:prstDash val="solid"/>
+                      <a:round/>
+                      <a:headEnd type="none" w="med" len="med"/>
+                      <a:tailEnd type="none" w="med" len="med"/>
+                    </a:lnR>
+                    <a:lnT w="6350" cap="flat" cmpd="sng" algn="ctr">
+                      <a:solidFill>
+                        <a:srgbClr val="D3DAE3"/>
+                      </a:solidFill>
+                      <a:prstDash val="solid"/>
+                      <a:round/>
+                      <a:headEnd type="none" w="med" len="med"/>
+                      <a:tailEnd type="none" w="med" len="med"/>
+                    </a:lnT>
+                    <a:lnB w="6350" cap="flat" cmpd="sng" algn="ctr">
+                      <a:solidFill>
+                        <a:srgbClr val="D3DAE3"/>
+                      </a:solidFill>
+                      <a:prstDash val="solid"/>
+                      <a:round/>
+                      <a:headEnd type="none" w="med" len="med"/>
+                      <a:tailEnd type="none" w="med" len="med"/>
+                    </a:lnB>
+                    <a:solidFill>
+                      <a:srgbClr val="13223A"/>
+                    </a:solidFill>
+                  </a:tcPr>
+                </a:tc>
+                <a:tc>
+                  <a:txBody>
+                    <a:bodyPr/>
+                    <a:lstStyle/>
+                    <a:p>
+                      <a:pPr indent="0" marL="0">
+                        <a:buNone/>
+                      </a:pPr>
+                      <a:r>
+                        <a:rPr lang="en-US" sz="1200" b="1" dirty="0">
+                          <a:solidFill>
+                            <a:schemeClr val="bg1"/>
+                          </a:solidFill>
+                        </a:rPr>
+                        <a:t>Acc. 2016</a:t>
+                      </a:r>
+                      <a:endParaRPr lang="en-US" sz="1200" dirty="0"/>
+                    </a:p>
+                  </a:txBody>
+                  <a:tcPr marL="73152" marR="73152" marT="0" marB="0" anchor="ctr">
+                    <a:lnL w="6350" cap="flat" cmpd="sng" algn="ctr">
+                      <a:solidFill>
+                        <a:srgbClr val="D3DAE3"/>
+                      </a:solidFill>
+                      <a:prstDash val="solid"/>
+                      <a:round/>
+                      <a:headEnd type="none" w="med" len="med"/>
+                      <a:tailEnd type="none" w="med" len="med"/>
+                    </a:lnL>
+                    <a:lnR w="6350" cap="flat" cmpd="sng" algn="ctr">
+                      <a:solidFill>
+                        <a:srgbClr val="D3DAE3"/>
+                      </a:solidFill>
+                      <a:prstDash val="solid"/>
+                      <a:round/>
+                      <a:headEnd type="none" w="med" len="med"/>
+                      <a:tailEnd type="none" w="med" len="med"/>
+                    </a:lnR>
+                    <a:lnT w="6350" cap="flat" cmpd="sng" algn="ctr">
+                      <a:solidFill>
+                        <a:srgbClr val="D3DAE3"/>
+                      </a:solidFill>
+                      <a:prstDash val="solid"/>
+                      <a:round/>
+                      <a:headEnd type="none" w="med" len="med"/>
+                      <a:tailEnd type="none" w="med" len="med"/>
+                    </a:lnT>
+                    <a:lnB w="6350" cap="flat" cmpd="sng" algn="ctr">
+                      <a:solidFill>
+                        <a:srgbClr val="D3DAE3"/>
+                      </a:solidFill>
+                      <a:prstDash val="solid"/>
+                      <a:round/>
+                      <a:headEnd type="none" w="med" len="med"/>
+                      <a:tailEnd type="none" w="med" len="med"/>
+                    </a:lnB>
+                    <a:solidFill>
+                      <a:srgbClr val="13223A"/>
+                    </a:solidFill>
+                  </a:tcPr>
+                </a:tc>
+              </a:tr>
+              <a:tr h="365760">
+                <a:tc>
+                  <a:txBody>
+                    <a:bodyPr/>
+                    <a:lstStyle/>
+                    <a:p>
+                      <a:pPr indent="0" marL="0">
+                        <a:buNone/>
+                      </a:pPr>
+                      <a:r>
+                        <a:rPr lang="en-US" sz="1200" dirty="0">
+                          <a:solidFill>
+                            <a:schemeClr val="tx1"/>
+                          </a:solidFill>
+                        </a:rPr>
+                        <a:t>Logistic Regression</a:t>
+                      </a:r>
+                      <a:endParaRPr lang="en-US" sz="1200" dirty="0"/>
+                    </a:p>
+                  </a:txBody>
+                  <a:tcPr marL="73152" marR="73152" marT="0" marB="0" anchor="ctr">
+                    <a:lnL w="6350" cap="flat" cmpd="sng" algn="ctr">
+                      <a:solidFill>
+                        <a:srgbClr val="D3DAE3"/>
+                      </a:solidFill>
+                      <a:prstDash val="solid"/>
+                      <a:round/>
+                      <a:headEnd type="none" w="med" len="med"/>
+                      <a:tailEnd type="none" w="med" len="med"/>
+                    </a:lnL>
+                    <a:lnR w="6350" cap="flat" cmpd="sng" algn="ctr">
+                      <a:solidFill>
+                        <a:srgbClr val="D3DAE3"/>
+                      </a:solidFill>
+                      <a:prstDash val="solid"/>
+                      <a:round/>
+                      <a:headEnd type="none" w="med" len="med"/>
+                      <a:tailEnd type="none" w="med" len="med"/>
+                    </a:lnR>
+                    <a:lnT w="6350" cap="flat" cmpd="sng" algn="ctr">
+                      <a:solidFill>
+                        <a:srgbClr val="D3DAE3"/>
+                      </a:solidFill>
+                      <a:prstDash val="solid"/>
+                      <a:round/>
+                      <a:headEnd type="none" w="med" len="med"/>
+                      <a:tailEnd type="none" w="med" len="med"/>
+                    </a:lnT>
+                    <a:lnB w="6350" cap="flat" cmpd="sng" algn="ctr">
+                      <a:solidFill>
+                        <a:srgbClr val="D3DAE3"/>
+                      </a:solidFill>
+                      <a:prstDash val="solid"/>
+                      <a:round/>
+                      <a:headEnd type="none" w="med" len="med"/>
+                      <a:tailEnd type="none" w="med" len="med"/>
+                    </a:lnB>
+                    <a:solidFill>
+                      <a:srgbClr val="FFFFFF"/>
+                    </a:solidFill>
+                  </a:tcPr>
+                </a:tc>
+                <a:tc>
+                  <a:txBody>
+                    <a:bodyPr/>
+                    <a:lstStyle/>
+                    <a:p>
+                      <a:pPr indent="0" marL="0">
+                        <a:buNone/>
+                      </a:pPr>
+                      <a:r>
+                        <a:rPr lang="en-US" sz="1200" dirty="0">
+                          <a:solidFill>
+                            <a:schemeClr val="tx1"/>
+                          </a:solidFill>
+                        </a:rPr>
+                        <a:t>87.8%</a:t>
+                      </a:r>
+                      <a:endParaRPr lang="en-US" sz="1200" dirty="0"/>
+                    </a:p>
+                  </a:txBody>
+                  <a:tcPr marL="73152" marR="73152" marT="0" marB="0" anchor="ctr">
+                    <a:lnL w="6350" cap="flat" cmpd="sng" algn="ctr">
+                      <a:solidFill>
+                        <a:srgbClr val="D3DAE3"/>
+                      </a:solidFill>
+                      <a:prstDash val="solid"/>
+                      <a:round/>
+                      <a:headEnd type="none" w="med" len="med"/>
+                      <a:tailEnd type="none" w="med" len="med"/>
+                    </a:lnL>
+                    <a:lnR w="6350" cap="flat" cmpd="sng" algn="ctr">
+                      <a:solidFill>
+                        <a:srgbClr val="D3DAE3"/>
+                      </a:solidFill>
+                      <a:prstDash val="solid"/>
+                      <a:round/>
+                      <a:headEnd type="none" w="med" len="med"/>
+                      <a:tailEnd type="none" w="med" len="med"/>
+                    </a:lnR>
+                    <a:lnT w="6350" cap="flat" cmpd="sng" algn="ctr">
+                      <a:solidFill>
+                        <a:srgbClr val="D3DAE3"/>
+                      </a:solidFill>
+                      <a:prstDash val="solid"/>
+                      <a:round/>
+                      <a:headEnd type="none" w="med" len="med"/>
+                      <a:tailEnd type="none" w="med" len="med"/>
+                    </a:lnT>
+                    <a:lnB w="6350" cap="flat" cmpd="sng" algn="ctr">
+                      <a:solidFill>
+                        <a:srgbClr val="D3DAE3"/>
+                      </a:solidFill>
+                      <a:prstDash val="solid"/>
+                      <a:round/>
+                      <a:headEnd type="none" w="med" len="med"/>
+                      <a:tailEnd type="none" w="med" len="med"/>
+                    </a:lnB>
+                    <a:solidFill>
+                      <a:srgbClr val="FFFFFF"/>
+                    </a:solidFill>
+                  </a:tcPr>
+                </a:tc>
+                <a:tc>
+                  <a:txBody>
+                    <a:bodyPr/>
+                    <a:lstStyle/>
+                    <a:p>
+                      <a:pPr indent="0" marL="0">
+                        <a:buNone/>
+                      </a:pPr>
+                      <a:r>
+                        <a:rPr lang="en-US" sz="1200" dirty="0">
+                          <a:solidFill>
+                            <a:schemeClr val="tx1"/>
+                          </a:solidFill>
+                        </a:rPr>
+                        <a:t>90.3%</a:t>
+                      </a:r>
+                      <a:endParaRPr lang="en-US" sz="1200" dirty="0"/>
+                    </a:p>
+                  </a:txBody>
+                  <a:tcPr marL="73152" marR="73152" marT="0" marB="0" anchor="ctr">
+                    <a:lnL w="6350" cap="flat" cmpd="sng" algn="ctr">
+                      <a:solidFill>
+                        <a:srgbClr val="D3DAE3"/>
+                      </a:solidFill>
+                      <a:prstDash val="solid"/>
+                      <a:round/>
+                      <a:headEnd type="none" w="med" len="med"/>
+                      <a:tailEnd type="none" w="med" len="med"/>
+                    </a:lnL>
+                    <a:lnR w="6350" cap="flat" cmpd="sng" algn="ctr">
+                      <a:solidFill>
+                        <a:srgbClr val="D3DAE3"/>
+                      </a:solidFill>
+                      <a:prstDash val="solid"/>
+                      <a:round/>
+                      <a:headEnd type="none" w="med" len="med"/>
+                      <a:tailEnd type="none" w="med" len="med"/>
+                    </a:lnR>
+                    <a:lnT w="6350" cap="flat" cmpd="sng" algn="ctr">
+                      <a:solidFill>
+                        <a:srgbClr val="D3DAE3"/>
+                      </a:solidFill>
+                      <a:prstDash val="solid"/>
+                      <a:round/>
+                      <a:headEnd type="none" w="med" len="med"/>
+                      <a:tailEnd type="none" w="med" len="med"/>
+                    </a:lnT>
+                    <a:lnB w="6350" cap="flat" cmpd="sng" algn="ctr">
+                      <a:solidFill>
+                        <a:srgbClr val="D3DAE3"/>
+                      </a:solidFill>
+                      <a:prstDash val="solid"/>
+                      <a:round/>
+                      <a:headEnd type="none" w="med" len="med"/>
+                      <a:tailEnd type="none" w="med" len="med"/>
+                    </a:lnB>
+                    <a:solidFill>
+                      <a:srgbClr val="FFFFFF"/>
+                    </a:solidFill>
+                  </a:tcPr>
+                </a:tc>
+              </a:tr>
+              <a:tr h="365760">
+                <a:tc>
+                  <a:txBody>
+                    <a:bodyPr/>
+                    <a:lstStyle/>
+                    <a:p>
+                      <a:pPr indent="0" marL="0">
+                        <a:buNone/>
+                      </a:pPr>
+                      <a:r>
+                        <a:rPr lang="en-US" sz="1200" dirty="0">
+                          <a:solidFill>
+                            <a:schemeClr val="tx1"/>
+                          </a:solidFill>
+                        </a:rPr>
+                        <a:t>SVM (RBF kernel)</a:t>
+                      </a:r>
+                      <a:endParaRPr lang="en-US" sz="1200" dirty="0"/>
+                    </a:p>
+                  </a:txBody>
+                  <a:tcPr marL="73152" marR="73152" marT="0" marB="0" anchor="ctr">
+                    <a:lnL w="6350" cap="flat" cmpd="sng" algn="ctr">
+                      <a:solidFill>
+                        <a:srgbClr val="D3DAE3"/>
+                      </a:solidFill>
+                      <a:prstDash val="solid"/>
+                      <a:round/>
+                      <a:headEnd type="none" w="med" len="med"/>
+                      <a:tailEnd type="none" w="med" len="med"/>
+                    </a:lnL>
+                    <a:lnR w="6350" cap="flat" cmpd="sng" algn="ctr">
+                      <a:solidFill>
+                        <a:srgbClr val="D3DAE3"/>
+                      </a:solidFill>
+                      <a:prstDash val="solid"/>
+                      <a:round/>
+                      <a:headEnd type="none" w="med" len="med"/>
+                      <a:tailEnd type="none" w="med" len="med"/>
+                    </a:lnR>
+                    <a:lnT w="6350" cap="flat" cmpd="sng" algn="ctr">
+                      <a:solidFill>
+                        <a:srgbClr val="D3DAE3"/>
+                      </a:solidFill>
+                      <a:prstDash val="solid"/>
+                      <a:round/>
+                      <a:headEnd type="none" w="med" len="med"/>
+                      <a:tailEnd type="none" w="med" len="med"/>
+                    </a:lnT>
+                    <a:lnB w="6350" cap="flat" cmpd="sng" algn="ctr">
+                      <a:solidFill>
+                        <a:srgbClr val="D3DAE3"/>
+                      </a:solidFill>
+                      <a:prstDash val="solid"/>
+                      <a:round/>
+                      <a:headEnd type="none" w="med" len="med"/>
+                      <a:tailEnd type="none" w="med" len="med"/>
+                    </a:lnB>
+                    <a:solidFill>
+                      <a:srgbClr val="FFFFFF"/>
+                    </a:solidFill>
+                  </a:tcPr>
+                </a:tc>
+                <a:tc>
+                  <a:txBody>
+                    <a:bodyPr/>
+                    <a:lstStyle/>
+                    <a:p>
+                      <a:pPr indent="0" marL="0">
+                        <a:buNone/>
+                      </a:pPr>
+                      <a:r>
+                        <a:rPr lang="en-US" sz="1200" dirty="0">
+                          <a:solidFill>
+                            <a:schemeClr val="tx1"/>
+                          </a:solidFill>
+                        </a:rPr>
+                        <a:t>87.3%</a:t>
+                      </a:r>
+                      <a:endParaRPr lang="en-US" sz="1200" dirty="0"/>
+                    </a:p>
+                  </a:txBody>
+                  <a:tcPr marL="73152" marR="73152" marT="0" marB="0" anchor="ctr">
+                    <a:lnL w="6350" cap="flat" cmpd="sng" algn="ctr">
+                      <a:solidFill>
+                        <a:srgbClr val="D3DAE3"/>
+                      </a:solidFill>
+                      <a:prstDash val="solid"/>
+                      <a:round/>
+                      <a:headEnd type="none" w="med" len="med"/>
+                      <a:tailEnd type="none" w="med" len="med"/>
+                    </a:lnL>
+                    <a:lnR w="6350" cap="flat" cmpd="sng" algn="ctr">
+                      <a:solidFill>
+                        <a:srgbClr val="D3DAE3"/>
+                      </a:solidFill>
+                      <a:prstDash val="solid"/>
+                      <a:round/>
+                      <a:headEnd type="none" w="med" len="med"/>
+                      <a:tailEnd type="none" w="med" len="med"/>
+                    </a:lnR>
+                    <a:lnT w="6350" cap="flat" cmpd="sng" algn="ctr">
+                      <a:solidFill>
+                        <a:srgbClr val="D3DAE3"/>
+                      </a:solidFill>
+                      <a:prstDash val="solid"/>
+                      <a:round/>
+                      <a:headEnd type="none" w="med" len="med"/>
+                      <a:tailEnd type="none" w="med" len="med"/>
+                    </a:lnT>
+                    <a:lnB w="6350" cap="flat" cmpd="sng" algn="ctr">
+                      <a:solidFill>
+                        <a:srgbClr val="D3DAE3"/>
+                      </a:solidFill>
+                      <a:prstDash val="solid"/>
+                      <a:round/>
+                      <a:headEnd type="none" w="med" len="med"/>
+                      <a:tailEnd type="none" w="med" len="med"/>
+                    </a:lnB>
+                    <a:solidFill>
+                      <a:srgbClr val="FFFFFF"/>
+                    </a:solidFill>
+                  </a:tcPr>
+                </a:tc>
+                <a:tc>
+                  <a:txBody>
+                    <a:bodyPr/>
+                    <a:lstStyle/>
+                    <a:p>
+                      <a:pPr indent="0" marL="0">
+                        <a:buNone/>
+                      </a:pPr>
+                      <a:r>
+                        <a:rPr lang="en-US" sz="1200" dirty="0">
+                          <a:solidFill>
+                            <a:schemeClr val="tx1"/>
+                          </a:solidFill>
+                        </a:rPr>
+                        <a:t>91.3%</a:t>
+                      </a:r>
+                      <a:endParaRPr lang="en-US" sz="1200" dirty="0"/>
+                    </a:p>
+                  </a:txBody>
+                  <a:tcPr marL="73152" marR="73152" marT="0" marB="0" anchor="ctr">
+                    <a:lnL w="6350" cap="flat" cmpd="sng" algn="ctr">
+                      <a:solidFill>
+                        <a:srgbClr val="D3DAE3"/>
+                      </a:solidFill>
+                      <a:prstDash val="solid"/>
+                      <a:round/>
+                      <a:headEnd type="none" w="med" len="med"/>
+                      <a:tailEnd type="none" w="med" len="med"/>
+                    </a:lnL>
+                    <a:lnR w="6350" cap="flat" cmpd="sng" algn="ctr">
+                      <a:solidFill>
+                        <a:srgbClr val="D3DAE3"/>
+                      </a:solidFill>
+                      <a:prstDash val="solid"/>
+                      <a:round/>
+                      <a:headEnd type="none" w="med" len="med"/>
+                      <a:tailEnd type="none" w="med" len="med"/>
+                    </a:lnR>
+                    <a:lnT w="6350" cap="flat" cmpd="sng" algn="ctr">
+                      <a:solidFill>
+                        <a:srgbClr val="D3DAE3"/>
+                      </a:solidFill>
+                      <a:prstDash val="solid"/>
+                      <a:round/>
+                      <a:headEnd type="none" w="med" len="med"/>
+                      <a:tailEnd type="none" w="med" len="med"/>
+                    </a:lnT>
+                    <a:lnB w="6350" cap="flat" cmpd="sng" algn="ctr">
+                      <a:solidFill>
+                        <a:srgbClr val="D3DAE3"/>
+                      </a:solidFill>
+                      <a:prstDash val="solid"/>
+                      <a:round/>
+                      <a:headEnd type="none" w="med" len="med"/>
+                      <a:tailEnd type="none" w="med" len="med"/>
+                    </a:lnB>
+                    <a:solidFill>
+                      <a:srgbClr val="FFFFFF"/>
+                    </a:solidFill>
+                  </a:tcPr>
+                </a:tc>
+              </a:tr>
+              <a:tr h="365760">
+                <a:tc>
+                  <a:txBody>
+                    <a:bodyPr/>
+                    <a:lstStyle/>
+                    <a:p>
+                      <a:pPr indent="0" marL="0">
+                        <a:buNone/>
+                      </a:pPr>
+                      <a:r>
+                        <a:rPr lang="en-US" sz="1200" dirty="0">
+                          <a:solidFill>
+                            <a:schemeClr val="tx1"/>
+                          </a:solidFill>
+                        </a:rPr>
+                        <a:t>Gaussian Naive Bayes</a:t>
+                      </a:r>
+                      <a:endParaRPr lang="en-US" sz="1200" dirty="0"/>
+                    </a:p>
+                  </a:txBody>
+                  <a:tcPr marL="73152" marR="73152" marT="0" marB="0" anchor="ctr">
+                    <a:lnL w="6350" cap="flat" cmpd="sng" algn="ctr">
+                      <a:solidFill>
+                        <a:srgbClr val="D3DAE3"/>
+                      </a:solidFill>
+                      <a:prstDash val="solid"/>
+                      <a:round/>
+                      <a:headEnd type="none" w="med" len="med"/>
+                      <a:tailEnd type="none" w="med" len="med"/>
+                    </a:lnL>
+                    <a:lnR w="6350" cap="flat" cmpd="sng" algn="ctr">
+                      <a:solidFill>
+                        <a:srgbClr val="D3DAE3"/>
+                      </a:solidFill>
+                      <a:prstDash val="solid"/>
+                      <a:round/>
+                      <a:headEnd type="none" w="med" len="med"/>
+                      <a:tailEnd type="none" w="med" len="med"/>
+                    </a:lnR>
+                    <a:lnT w="6350" cap="flat" cmpd="sng" algn="ctr">
+                      <a:solidFill>
+                        <a:srgbClr val="D3DAE3"/>
+                      </a:solidFill>
+                      <a:prstDash val="solid"/>
+                      <a:round/>
+                      <a:headEnd type="none" w="med" len="med"/>
+                      <a:tailEnd type="none" w="med" len="med"/>
+                    </a:lnT>
+                    <a:lnB w="6350" cap="flat" cmpd="sng" algn="ctr">
+                      <a:solidFill>
+                        <a:srgbClr val="D3DAE3"/>
+                      </a:solidFill>
+                      <a:prstDash val="solid"/>
+                      <a:round/>
+                      <a:headEnd type="none" w="med" len="med"/>
+                      <a:tailEnd type="none" w="med" len="med"/>
+                    </a:lnB>
+                    <a:solidFill>
+                      <a:srgbClr val="FFFFFF"/>
+                    </a:solidFill>
+                  </a:tcPr>
+                </a:tc>
+                <a:tc>
+                  <a:txBody>
+                    <a:bodyPr/>
+                    <a:lstStyle/>
+                    <a:p>
+                      <a:pPr indent="0" marL="0">
+                        <a:buNone/>
+                      </a:pPr>
+                      <a:r>
+                        <a:rPr lang="en-US" sz="1200" dirty="0">
+                          <a:solidFill>
+                            <a:schemeClr val="tx1"/>
+                          </a:solidFill>
+                        </a:rPr>
+                        <a:t>86.8%</a:t>
+                      </a:r>
+                      <a:endParaRPr lang="en-US" sz="1200" dirty="0"/>
+                    </a:p>
+                  </a:txBody>
+                  <a:tcPr marL="73152" marR="73152" marT="0" marB="0" anchor="ctr">
+                    <a:lnL w="6350" cap="flat" cmpd="sng" algn="ctr">
+                      <a:solidFill>
+                        <a:srgbClr val="D3DAE3"/>
+                      </a:solidFill>
+                      <a:prstDash val="solid"/>
+                      <a:round/>
+                      <a:headEnd type="none" w="med" len="med"/>
+                      <a:tailEnd type="none" w="med" len="med"/>
+                    </a:lnL>
+                    <a:lnR w="6350" cap="flat" cmpd="sng" algn="ctr">
+                      <a:solidFill>
+                        <a:srgbClr val="D3DAE3"/>
+                      </a:solidFill>
+                      <a:prstDash val="solid"/>
+                      <a:round/>
+                      <a:headEnd type="none" w="med" len="med"/>
+                      <a:tailEnd type="none" w="med" len="med"/>
+                    </a:lnR>
+                    <a:lnT w="6350" cap="flat" cmpd="sng" algn="ctr">
+                      <a:solidFill>
+                        <a:srgbClr val="D3DAE3"/>
+                      </a:solidFill>
+                      <a:prstDash val="solid"/>
+                      <a:round/>
+                      <a:headEnd type="none" w="med" len="med"/>
+                      <a:tailEnd type="none" w="med" len="med"/>
+                    </a:lnT>
+                    <a:lnB w="6350" cap="flat" cmpd="sng" algn="ctr">
+                      <a:solidFill>
+                        <a:srgbClr val="D3DAE3"/>
+                      </a:solidFill>
+                      <a:prstDash val="solid"/>
+                      <a:round/>
+                      <a:headEnd type="none" w="med" len="med"/>
+                      <a:tailEnd type="none" w="med" len="med"/>
+                    </a:lnB>
+                    <a:solidFill>
+                      <a:srgbClr val="FFFFFF"/>
+                    </a:solidFill>
+                  </a:tcPr>
+                </a:tc>
+                <a:tc>
+                  <a:txBody>
+                    <a:bodyPr/>
+                    <a:lstStyle/>
+                    <a:p>
+                      <a:pPr indent="0" marL="0">
+                        <a:buNone/>
+                      </a:pPr>
+                      <a:r>
+                        <a:rPr lang="en-US" sz="1200" dirty="0">
+                          <a:solidFill>
+                            <a:schemeClr val="tx1"/>
+                          </a:solidFill>
+                        </a:rPr>
+                        <a:t>90.3%</a:t>
+                      </a:r>
+                      <a:endParaRPr lang="en-US" sz="1200" dirty="0"/>
+                    </a:p>
+                  </a:txBody>
+                  <a:tcPr marL="73152" marR="73152" marT="0" marB="0" anchor="ctr">
+                    <a:lnL w="6350" cap="flat" cmpd="sng" algn="ctr">
+                      <a:solidFill>
+                        <a:srgbClr val="D3DAE3"/>
+                      </a:solidFill>
+                      <a:prstDash val="solid"/>
+                      <a:round/>
+                      <a:headEnd type="none" w="med" len="med"/>
+                      <a:tailEnd type="none" w="med" len="med"/>
+                    </a:lnL>
+                    <a:lnR w="6350" cap="flat" cmpd="sng" algn="ctr">
+                      <a:solidFill>
+                        <a:srgbClr val="D3DAE3"/>
+                      </a:solidFill>
+                      <a:prstDash val="solid"/>
+                      <a:round/>
+                      <a:headEnd type="none" w="med" len="med"/>
+                      <a:tailEnd type="none" w="med" len="med"/>
+                    </a:lnR>
+                    <a:lnT w="6350" cap="flat" cmpd="sng" algn="ctr">
+                      <a:solidFill>
+                        <a:srgbClr val="D3DAE3"/>
+                      </a:solidFill>
+                      <a:prstDash val="solid"/>
+                      <a:round/>
+                      <a:headEnd type="none" w="med" len="med"/>
+                      <a:tailEnd type="none" w="med" len="med"/>
+                    </a:lnT>
+                    <a:lnB w="6350" cap="flat" cmpd="sng" algn="ctr">
+                      <a:solidFill>
+                        <a:srgbClr val="D3DAE3"/>
+                      </a:solidFill>
+                      <a:prstDash val="solid"/>
+                      <a:round/>
+                      <a:headEnd type="none" w="med" len="med"/>
+                      <a:tailEnd type="none" w="med" len="med"/>
+                    </a:lnB>
+                    <a:solidFill>
+                      <a:srgbClr val="FFFFFF"/>
+                    </a:solidFill>
+                  </a:tcPr>
+                </a:tc>
+              </a:tr>
+              <a:tr h="365760">
+                <a:tc>
+                  <a:txBody>
+                    <a:bodyPr/>
+                    <a:lstStyle/>
+                    <a:p>
+                      <a:pPr indent="0" marL="0">
+                        <a:buNone/>
+                      </a:pPr>
+                      <a:r>
+                        <a:rPr lang="en-US" sz="1200" dirty="0">
+                          <a:solidFill>
+                            <a:schemeClr val="tx1"/>
+                          </a:solidFill>
+                        </a:rPr>
+                        <a:t>Multilayer Perceptron</a:t>
+                      </a:r>
+                      <a:endParaRPr lang="en-US" sz="1200" dirty="0"/>
+                    </a:p>
+                  </a:txBody>
+                  <a:tcPr marL="73152" marR="73152" marT="0" marB="0" anchor="ctr">
+                    <a:lnL w="6350" cap="flat" cmpd="sng" algn="ctr">
+                      <a:solidFill>
+                        <a:srgbClr val="D3DAE3"/>
+                      </a:solidFill>
+                      <a:prstDash val="solid"/>
+                      <a:round/>
+                      <a:headEnd type="none" w="med" len="med"/>
+                      <a:tailEnd type="none" w="med" len="med"/>
+                    </a:lnL>
+                    <a:lnR w="6350" cap="flat" cmpd="sng" algn="ctr">
+                      <a:solidFill>
+                        <a:srgbClr val="D3DAE3"/>
+                      </a:solidFill>
+                      <a:prstDash val="solid"/>
+                      <a:round/>
+                      <a:headEnd type="none" w="med" len="med"/>
+                      <a:tailEnd type="none" w="med" len="med"/>
+                    </a:lnR>
+                    <a:lnT w="6350" cap="flat" cmpd="sng" algn="ctr">
+                      <a:solidFill>
+                        <a:srgbClr val="D3DAE3"/>
+                      </a:solidFill>
+                      <a:prstDash val="solid"/>
+                      <a:round/>
+                      <a:headEnd type="none" w="med" len="med"/>
+                      <a:tailEnd type="none" w="med" len="med"/>
+                    </a:lnT>
+                    <a:lnB w="6350" cap="flat" cmpd="sng" algn="ctr">
+                      <a:solidFill>
+                        <a:srgbClr val="D3DAE3"/>
+                      </a:solidFill>
+                      <a:prstDash val="solid"/>
+                      <a:round/>
+                      <a:headEnd type="none" w="med" len="med"/>
+                      <a:tailEnd type="none" w="med" len="med"/>
+                    </a:lnB>
+                    <a:solidFill>
+                      <a:srgbClr val="FFFFFF"/>
+                    </a:solidFill>
+                  </a:tcPr>
+                </a:tc>
+                <a:tc>
+                  <a:txBody>
+                    <a:bodyPr/>
+                    <a:lstStyle/>
+                    <a:p>
+                      <a:pPr indent="0" marL="0">
+                        <a:buNone/>
+                      </a:pPr>
+                      <a:r>
+                        <a:rPr lang="en-US" sz="1200" dirty="0">
+                          <a:solidFill>
+                            <a:schemeClr val="tx1"/>
+                          </a:solidFill>
+                        </a:rPr>
+                        <a:t>86.3%</a:t>
+                      </a:r>
+                      <a:endParaRPr lang="en-US" sz="1200" dirty="0"/>
+                    </a:p>
+                  </a:txBody>
+                  <a:tcPr marL="73152" marR="73152" marT="0" marB="0" anchor="ctr">
+                    <a:lnL w="6350" cap="flat" cmpd="sng" algn="ctr">
+                      <a:solidFill>
+                        <a:srgbClr val="D3DAE3"/>
+                      </a:solidFill>
+                      <a:prstDash val="solid"/>
+                      <a:round/>
+                      <a:headEnd type="none" w="med" len="med"/>
+                      <a:tailEnd type="none" w="med" len="med"/>
+                    </a:lnL>
+                    <a:lnR w="6350" cap="flat" cmpd="sng" algn="ctr">
+                      <a:solidFill>
+                        <a:srgbClr val="D3DAE3"/>
+                      </a:solidFill>
+                      <a:prstDash val="solid"/>
+                      <a:round/>
+                      <a:headEnd type="none" w="med" len="med"/>
+                      <a:tailEnd type="none" w="med" len="med"/>
+                    </a:lnR>
+                    <a:lnT w="6350" cap="flat" cmpd="sng" algn="ctr">
+                      <a:solidFill>
+                        <a:srgbClr val="D3DAE3"/>
+                      </a:solidFill>
+                      <a:prstDash val="solid"/>
+                      <a:round/>
+                      <a:headEnd type="none" w="med" len="med"/>
+                      <a:tailEnd type="none" w="med" len="med"/>
+                    </a:lnT>
+                    <a:lnB w="6350" cap="flat" cmpd="sng" algn="ctr">
+                      <a:solidFill>
+                        <a:srgbClr val="D3DAE3"/>
+                      </a:solidFill>
+                      <a:prstDash val="solid"/>
+                      <a:round/>
+                      <a:headEnd type="none" w="med" len="med"/>
+                      <a:tailEnd type="none" w="med" len="med"/>
+                    </a:lnB>
+                    <a:solidFill>
+                      <a:srgbClr val="FFFFFF"/>
+                    </a:solidFill>
+                  </a:tcPr>
+                </a:tc>
+                <a:tc>
+                  <a:txBody>
+                    <a:bodyPr/>
+                    <a:lstStyle/>
+                    <a:p>
+                      <a:pPr indent="0" marL="0">
+                        <a:buNone/>
+                      </a:pPr>
+                      <a:r>
+                        <a:rPr lang="en-US" sz="1200" dirty="0">
+                          <a:solidFill>
+                            <a:schemeClr val="tx1"/>
+                          </a:solidFill>
+                        </a:rPr>
+                        <a:t>89.3%</a:t>
+                      </a:r>
+                      <a:endParaRPr lang="en-US" sz="1200" dirty="0"/>
+                    </a:p>
+                  </a:txBody>
+                  <a:tcPr marL="73152" marR="73152" marT="0" marB="0" anchor="ctr">
+                    <a:lnL w="6350" cap="flat" cmpd="sng" algn="ctr">
+                      <a:solidFill>
+                        <a:srgbClr val="D3DAE3"/>
+                      </a:solidFill>
+                      <a:prstDash val="solid"/>
+                      <a:round/>
+                      <a:headEnd type="none" w="med" len="med"/>
+                      <a:tailEnd type="none" w="med" len="med"/>
+                    </a:lnL>
+                    <a:lnR w="6350" cap="flat" cmpd="sng" algn="ctr">
+                      <a:solidFill>
+                        <a:srgbClr val="D3DAE3"/>
+                      </a:solidFill>
+                      <a:prstDash val="solid"/>
+                      <a:round/>
+                      <a:headEnd type="none" w="med" len="med"/>
+                      <a:tailEnd type="none" w="med" len="med"/>
+                    </a:lnR>
+                    <a:lnT w="6350" cap="flat" cmpd="sng" algn="ctr">
+                      <a:solidFill>
+                        <a:srgbClr val="D3DAE3"/>
+                      </a:solidFill>
+                      <a:prstDash val="solid"/>
+                      <a:round/>
+                      <a:headEnd type="none" w="med" len="med"/>
+                      <a:tailEnd type="none" w="med" len="med"/>
+                    </a:lnT>
+                    <a:lnB w="6350" cap="flat" cmpd="sng" algn="ctr">
+                      <a:solidFill>
+                        <a:srgbClr val="D3DAE3"/>
+                      </a:solidFill>
+                      <a:prstDash val="solid"/>
+                      <a:round/>
+                      <a:headEnd type="none" w="med" len="med"/>
+                      <a:tailEnd type="none" w="med" len="med"/>
+                    </a:lnB>
+                    <a:solidFill>
+                      <a:srgbClr val="FFFFFF"/>
+                    </a:solidFill>
+                  </a:tcPr>
+                </a:tc>
+              </a:tr>
+              <a:tr h="365760">
+                <a:tc>
+                  <a:txBody>
+                    <a:bodyPr/>
+                    <a:lstStyle/>
+                    <a:p>
+                      <a:pPr indent="0" marL="0">
+                        <a:buNone/>
+                      </a:pPr>
+                      <a:r>
+                        <a:rPr lang="en-US" sz="1200" dirty="0">
+                          <a:solidFill>
+                            <a:schemeClr val="tx1"/>
+                          </a:solidFill>
+                        </a:rPr>
+                        <a:t>Random Forest</a:t>
+                      </a:r>
+                      <a:endParaRPr lang="en-US" sz="1200" dirty="0"/>
+                    </a:p>
+                  </a:txBody>
+                  <a:tcPr marL="73152" marR="73152" marT="0" marB="0" anchor="ctr">
+                    <a:lnL w="6350" cap="flat" cmpd="sng" algn="ctr">
+                      <a:solidFill>
+                        <a:srgbClr val="D3DAE3"/>
+                      </a:solidFill>
+                      <a:prstDash val="solid"/>
+                      <a:round/>
+                      <a:headEnd type="none" w="med" len="med"/>
+                      <a:tailEnd type="none" w="med" len="med"/>
+                    </a:lnL>
+                    <a:lnR w="6350" cap="flat" cmpd="sng" algn="ctr">
+                      <a:solidFill>
+                        <a:srgbClr val="D3DAE3"/>
+                      </a:solidFill>
+                      <a:prstDash val="solid"/>
+                      <a:round/>
+                      <a:headEnd type="none" w="med" len="med"/>
+                      <a:tailEnd type="none" w="med" len="med"/>
+                    </a:lnR>
+                    <a:lnT w="6350" cap="flat" cmpd="sng" algn="ctr">
+                      <a:solidFill>
+                        <a:srgbClr val="D3DAE3"/>
+                      </a:solidFill>
+                      <a:prstDash val="solid"/>
+                      <a:round/>
+                      <a:headEnd type="none" w="med" len="med"/>
+                      <a:tailEnd type="none" w="med" len="med"/>
+                    </a:lnT>
+                    <a:lnB w="6350" cap="flat" cmpd="sng" algn="ctr">
+                      <a:solidFill>
+                        <a:srgbClr val="D3DAE3"/>
+                      </a:solidFill>
+                      <a:prstDash val="solid"/>
+                      <a:round/>
+                      <a:headEnd type="none" w="med" len="med"/>
+                      <a:tailEnd type="none" w="med" len="med"/>
+                    </a:lnB>
+                    <a:solidFill>
+                      <a:srgbClr val="FFFFFF"/>
+                    </a:solidFill>
+                  </a:tcPr>
+                </a:tc>
+                <a:tc>
+                  <a:txBody>
+                    <a:bodyPr/>
+                    <a:lstStyle/>
+                    <a:p>
+                      <a:pPr indent="0" marL="0">
+                        <a:buNone/>
+                      </a:pPr>
+                      <a:r>
+                        <a:rPr lang="en-US" sz="1200" dirty="0">
+                          <a:solidFill>
+                            <a:schemeClr val="tx1"/>
+                          </a:solidFill>
+                        </a:rPr>
+                        <a:t>89.2%</a:t>
+                      </a:r>
+                      <a:endParaRPr lang="en-US" sz="1200" dirty="0"/>
+                    </a:p>
+                  </a:txBody>
+                  <a:tcPr marL="73152" marR="73152" marT="0" marB="0" anchor="ctr">
+                    <a:lnL w="6350" cap="flat" cmpd="sng" algn="ctr">
+                      <a:solidFill>
+                        <a:srgbClr val="D3DAE3"/>
+                      </a:solidFill>
+                      <a:prstDash val="solid"/>
+                      <a:round/>
+                      <a:headEnd type="none" w="med" len="med"/>
+                      <a:tailEnd type="none" w="med" len="med"/>
+                    </a:lnL>
+                    <a:lnR w="6350" cap="flat" cmpd="sng" algn="ctr">
+                      <a:solidFill>
+                        <a:srgbClr val="D3DAE3"/>
+                      </a:solidFill>
+                      <a:prstDash val="solid"/>
+                      <a:round/>
+                      <a:headEnd type="none" w="med" len="med"/>
+                      <a:tailEnd type="none" w="med" len="med"/>
+                    </a:lnR>
+                    <a:lnT w="6350" cap="flat" cmpd="sng" algn="ctr">
+                      <a:solidFill>
+                        <a:srgbClr val="D3DAE3"/>
+                      </a:solidFill>
+                      <a:prstDash val="solid"/>
+                      <a:round/>
+                      <a:headEnd type="none" w="med" len="med"/>
+                      <a:tailEnd type="none" w="med" len="med"/>
+                    </a:lnT>
+                    <a:lnB w="6350" cap="flat" cmpd="sng" algn="ctr">
+                      <a:solidFill>
+                        <a:srgbClr val="D3DAE3"/>
+                      </a:solidFill>
+                      <a:prstDash val="solid"/>
+                      <a:round/>
+                      <a:headEnd type="none" w="med" len="med"/>
+                      <a:tailEnd type="none" w="med" len="med"/>
+                    </a:lnB>
+                    <a:solidFill>
+                      <a:srgbClr val="FFFFFF"/>
+                    </a:solidFill>
+                  </a:tcPr>
+                </a:tc>
+                <a:tc>
+                  <a:txBody>
+                    <a:bodyPr/>
+                    <a:lstStyle/>
+                    <a:p>
+                      <a:pPr indent="0" marL="0">
+                        <a:buNone/>
+                      </a:pPr>
+                      <a:r>
+                        <a:rPr lang="en-US" sz="1200" dirty="0">
+                          <a:solidFill>
+                            <a:schemeClr val="tx1"/>
+                          </a:solidFill>
+                        </a:rPr>
+                        <a:t>91.3%</a:t>
+                      </a:r>
+                      <a:endParaRPr lang="en-US" sz="1200" dirty="0"/>
+                    </a:p>
+                  </a:txBody>
+                  <a:tcPr marL="73152" marR="73152" marT="0" marB="0" anchor="ctr">
+                    <a:lnL w="6350" cap="flat" cmpd="sng" algn="ctr">
+                      <a:solidFill>
+                        <a:srgbClr val="D3DAE3"/>
+                      </a:solidFill>
+                      <a:prstDash val="solid"/>
+                      <a:round/>
+                      <a:headEnd type="none" w="med" len="med"/>
+                      <a:tailEnd type="none" w="med" len="med"/>
+                    </a:lnL>
+                    <a:lnR w="6350" cap="flat" cmpd="sng" algn="ctr">
+                      <a:solidFill>
+                        <a:srgbClr val="D3DAE3"/>
+                      </a:solidFill>
+                      <a:prstDash val="solid"/>
+                      <a:round/>
+                      <a:headEnd type="none" w="med" len="med"/>
+                      <a:tailEnd type="none" w="med" len="med"/>
+                    </a:lnR>
+                    <a:lnT w="6350" cap="flat" cmpd="sng" algn="ctr">
+                      <a:solidFill>
+                        <a:srgbClr val="D3DAE3"/>
+                      </a:solidFill>
+                      <a:prstDash val="solid"/>
+                      <a:round/>
+                      <a:headEnd type="none" w="med" len="med"/>
+                      <a:tailEnd type="none" w="med" len="med"/>
+                    </a:lnT>
+                    <a:lnB w="6350" cap="flat" cmpd="sng" algn="ctr">
+                      <a:solidFill>
+                        <a:srgbClr val="D3DAE3"/>
+                      </a:solidFill>
+                      <a:prstDash val="solid"/>
+                      <a:round/>
+                      <a:headEnd type="none" w="med" len="med"/>
+                      <a:tailEnd type="none" w="med" len="med"/>
+                    </a:lnB>
+                    <a:solidFill>
+                      <a:srgbClr val="FFFFFF"/>
+                    </a:solidFill>
+                  </a:tcPr>
+                </a:tc>
+              </a:tr>
+              <a:tr h="365760">
+                <a:tc>
+                  <a:txBody>
+                    <a:bodyPr/>
+                    <a:lstStyle/>
+                    <a:p>
+                      <a:pPr indent="0" marL="0">
+                        <a:buNone/>
+                      </a:pPr>
+                      <a:r>
+                        <a:rPr lang="en-US" sz="1200" dirty="0">
+                          <a:solidFill>
+                            <a:schemeClr val="tx1"/>
+                          </a:solidFill>
+                        </a:rPr>
+                        <a:t>Rule: medalled last time</a:t>
+                      </a:r>
+                      <a:endParaRPr lang="en-US" sz="1200" dirty="0"/>
+                    </a:p>
+                  </a:txBody>
+                  <a:tcPr marL="73152" marR="73152" marT="0" marB="0" anchor="ctr">
+                    <a:lnL w="6350" cap="flat" cmpd="sng" algn="ctr">
+                      <a:solidFill>
+                        <a:srgbClr val="D3DAE3"/>
+                      </a:solidFill>
+                      <a:prstDash val="solid"/>
+                      <a:round/>
+                      <a:headEnd type="none" w="med" len="med"/>
+                      <a:tailEnd type="none" w="med" len="med"/>
+                    </a:lnL>
+                    <a:lnR w="6350" cap="flat" cmpd="sng" algn="ctr">
+                      <a:solidFill>
+                        <a:srgbClr val="D3DAE3"/>
+                      </a:solidFill>
+                      <a:prstDash val="solid"/>
+                      <a:round/>
+                      <a:headEnd type="none" w="med" len="med"/>
+                      <a:tailEnd type="none" w="med" len="med"/>
+                    </a:lnR>
+                    <a:lnT w="6350" cap="flat" cmpd="sng" algn="ctr">
+                      <a:solidFill>
+                        <a:srgbClr val="D3DAE3"/>
+                      </a:solidFill>
+                      <a:prstDash val="solid"/>
+                      <a:round/>
+                      <a:headEnd type="none" w="med" len="med"/>
+                      <a:tailEnd type="none" w="med" len="med"/>
+                    </a:lnT>
+                    <a:lnB w="6350" cap="flat" cmpd="sng" algn="ctr">
+                      <a:solidFill>
+                        <a:srgbClr val="D3DAE3"/>
+                      </a:solidFill>
+                      <a:prstDash val="solid"/>
+                      <a:round/>
+                      <a:headEnd type="none" w="med" len="med"/>
+                      <a:tailEnd type="none" w="med" len="med"/>
+                    </a:lnB>
+                    <a:solidFill>
+                      <a:srgbClr val="FFFFFF"/>
+                    </a:solidFill>
+                  </a:tcPr>
+                </a:tc>
+                <a:tc>
+                  <a:txBody>
+                    <a:bodyPr/>
+                    <a:lstStyle/>
+                    <a:p>
+                      <a:pPr indent="0" marL="0">
+                        <a:buNone/>
+                      </a:pPr>
+                      <a:r>
+                        <a:rPr lang="en-US" sz="1200" dirty="0">
+                          <a:solidFill>
+                            <a:schemeClr val="tx1"/>
+                          </a:solidFill>
+                        </a:rPr>
+                        <a:t>87.3%</a:t>
+                      </a:r>
+                      <a:endParaRPr lang="en-US" sz="1200" dirty="0"/>
+                    </a:p>
+                  </a:txBody>
+                  <a:tcPr marL="73152" marR="73152" marT="0" marB="0" anchor="ctr">
+                    <a:lnL w="6350" cap="flat" cmpd="sng" algn="ctr">
+                      <a:solidFill>
+                        <a:srgbClr val="D3DAE3"/>
+                      </a:solidFill>
+                      <a:prstDash val="solid"/>
+                      <a:round/>
+                      <a:headEnd type="none" w="med" len="med"/>
+                      <a:tailEnd type="none" w="med" len="med"/>
+                    </a:lnL>
+                    <a:lnR w="6350" cap="flat" cmpd="sng" algn="ctr">
+                      <a:solidFill>
+                        <a:srgbClr val="D3DAE3"/>
+                      </a:solidFill>
+                      <a:prstDash val="solid"/>
+                      <a:round/>
+                      <a:headEnd type="none" w="med" len="med"/>
+                      <a:tailEnd type="none" w="med" len="med"/>
+                    </a:lnR>
+                    <a:lnT w="6350" cap="flat" cmpd="sng" algn="ctr">
+                      <a:solidFill>
+                        <a:srgbClr val="D3DAE3"/>
+                      </a:solidFill>
+                      <a:prstDash val="solid"/>
+                      <a:round/>
+                      <a:headEnd type="none" w="med" len="med"/>
+                      <a:tailEnd type="none" w="med" len="med"/>
+                    </a:lnT>
+                    <a:lnB w="6350" cap="flat" cmpd="sng" algn="ctr">
+                      <a:solidFill>
+                        <a:srgbClr val="D3DAE3"/>
+                      </a:solidFill>
+                      <a:prstDash val="solid"/>
+                      <a:round/>
+                      <a:headEnd type="none" w="med" len="med"/>
+                      <a:tailEnd type="none" w="med" len="med"/>
+                    </a:lnB>
+                    <a:solidFill>
+                      <a:srgbClr val="FFFFFF"/>
+                    </a:solidFill>
+                  </a:tcPr>
+                </a:tc>
+                <a:tc>
+                  <a:txBody>
+                    <a:bodyPr/>
+                    <a:lstStyle/>
+                    <a:p>
+                      <a:pPr indent="0" marL="0">
+                        <a:buNone/>
+                      </a:pPr>
+                      <a:r>
+                        <a:rPr lang="en-US" sz="1200" dirty="0">
+                          <a:solidFill>
+                            <a:schemeClr val="tx1"/>
+                          </a:solidFill>
+                        </a:rPr>
+                        <a:t>88.8%</a:t>
+                      </a:r>
+                      <a:endParaRPr lang="en-US" sz="1200" dirty="0"/>
+                    </a:p>
+                  </a:txBody>
+                  <a:tcPr marL="73152" marR="73152" marT="0" marB="0" anchor="ctr">
+                    <a:lnL w="6350" cap="flat" cmpd="sng" algn="ctr">
+                      <a:solidFill>
+                        <a:srgbClr val="D3DAE3"/>
+                      </a:solidFill>
+                      <a:prstDash val="solid"/>
+                      <a:round/>
+                      <a:headEnd type="none" w="med" len="med"/>
+                      <a:tailEnd type="none" w="med" len="med"/>
+                    </a:lnL>
+                    <a:lnR w="6350" cap="flat" cmpd="sng" algn="ctr">
+                      <a:solidFill>
+                        <a:srgbClr val="D3DAE3"/>
+                      </a:solidFill>
+                      <a:prstDash val="solid"/>
+                      <a:round/>
+                      <a:headEnd type="none" w="med" len="med"/>
+                      <a:tailEnd type="none" w="med" len="med"/>
+                    </a:lnR>
+                    <a:lnT w="6350" cap="flat" cmpd="sng" algn="ctr">
+                      <a:solidFill>
+                        <a:srgbClr val="D3DAE3"/>
+                      </a:solidFill>
+                      <a:prstDash val="solid"/>
+                      <a:round/>
+                      <a:headEnd type="none" w="med" len="med"/>
+                      <a:tailEnd type="none" w="med" len="med"/>
+                    </a:lnT>
+                    <a:lnB w="6350" cap="flat" cmpd="sng" algn="ctr">
+                      <a:solidFill>
+                        <a:srgbClr val="D3DAE3"/>
+                      </a:solidFill>
+                      <a:prstDash val="solid"/>
+                      <a:round/>
+                      <a:headEnd type="none" w="med" len="med"/>
+                      <a:tailEnd type="none" w="med" len="med"/>
+                    </a:lnB>
+                    <a:solidFill>
+                      <a:srgbClr val="FFFFFF"/>
+                    </a:solidFill>
+                  </a:tcPr>
+                </a:tc>
+              </a:tr>
+            </a:tbl>
+          </a:graphicData>
+        </a:graphic>
+      </p:graphicFrame>
+      <p:sp>
+        <p:nvSpPr>
+          <p:cNvPr id="6" name="Text 1"/>
+          <p:cNvSpPr txBox="1"/>
+          <p:nvPr/>
+        </p:nvSpPr>
+        <p:spPr>
+          <a:xfrm>
+            <a:off x="7269480" y="4251960"/>
+            <a:ext cx="4389120" cy="1097280"/>
+          </a:xfrm>
+          <a:prstGeom prst="rect">
+            <a:avLst/>
+          </a:prstGeom>
+          <a:noFill/>
+          <a:ln/>
+        </p:spPr>
+        <p:txBody>
+          <a:bodyPr wrap="square" lIns="0" tIns="0" rIns="0" bIns="0" rtlCol="0" anchor="t"/>
+          <a:lstStyle/>
+          <a:p>
+            <a:pPr indent="0" marL="0">
+              <a:buNone/>
+            </a:pPr>
+            <a:r>
+              <a:rPr lang="en-US" sz="1400" dirty="0">
+                <a:solidFill>
+                  <a:schemeClr val="accent6"/>
+                </a:solidFill>
+              </a:rPr>
+              <a:t>Paper’s first stage: will a country win any medal? Every classifier lands within a few points of the simple rule “it medalled last time”.</a:t>
+            </a:r>
+            <a:endParaRPr lang="en-US" sz="1400" dirty="0"/>
+          </a:p>
+        </p:txBody>
+      </p:sp>
+      <p:sp>
+        <p:nvSpPr>
+          <p:cNvPr id="25" name="Slide Number Placeholder 0"/>
+          <p:cNvSpPr>
+            <a:spLocks noGrp="1"/>
+          </p:cNvSpPr>
+          <p:nvPr>
+            <p:ph type="sldNum" sz="quarter" idx="4294967295"/>
+          </p:nvPr>
+        </p:nvSpPr>
+        <p:spPr>
+          <a:xfrm>
+            <a:off x="11155680" y="6400800"/>
+            <a:ext cx="457200" cy="274320"/>
+          </a:xfrm>
+          <a:prstGeom prst="rect">
+            <a:avLst/>
+          </a:prstGeom>
+          <a:extLst>
+            <a:ext uri="{C572A759-6A51-4108-AA02-DFA0A04FC94B}">
+              <ma14:wrappingTextBoxFlag xmlns:ma14="http://schemas.microsoft.com/office/mac/drawingml/2011/main" val="0"/>
+            </a:ext>
+          </a:extLst>
+        </p:spPr>
+        <p:txBody>
+          <a:bodyPr/>
+          <a:lstStyle>
+            <a:lvl1pPr>
+              <a:defRPr sz="1000">
+                <a:solidFill>
+                  <a:srgbClr val="4A5872"/>
+                </a:solidFill>
+              </a:defRPr>
+            </a:lvl1pPr>
+          </a:lstStyle>
+          <a:p>
+            <a:pPr algn="r"/>
+            <a:fld id="{F7021451-1387-4CA6-816F-3879F97B5CBC}" type="slidenum">
+              <a:rPr b="0" lang="en-US"/>
+              <a:t>11</a:t>
+            </a:fld>
+            <a:endParaRPr lang="en-US"/>
+          </a:p>
+        </p:txBody>
+      </p:sp>
+    </p:spTree>
+  </p:cSld>
+  <p:clrMapOvr>
+    <a:masterClrMapping/>
+  </p:clrMapOvr>
+</p:sld>
+</file>
+
+<file path=ppt/slides/slide12.xml><?xml version="1.0" encoding="utf-8"?>
+<p:sld xmlns:a="http://schemas.openxmlformats.org/drawingml/2006/main" xmlns:r="http://schemas.openxmlformats.org/officeDocument/2006/relationships" xmlns:p="http://schemas.openxmlformats.org/presentationml/2006/main">
+  <p:cSld name="Slide 12">
+    <p:spTree>
+      <p:nvGrpSpPr>
+        <p:cNvPr id="1" name=""/>
+        <p:cNvGrpSpPr/>
+        <p:nvPr/>
+      </p:nvGrpSpPr>
+      <p:grpSpPr>
+        <a:xfrm>
+          <a:off x="0" y="0"/>
+          <a:ext cx="0" cy="0"/>
+          <a:chOff x="0" y="0"/>
+          <a:chExt cx="0" cy="0"/>
+        </a:xfrm>
+      </p:grpSpPr>
+      <p:sp>
+        <p:nvSpPr>
+          <p:cNvPr id="2" name="Title"/>
+          <p:cNvSpPr txBox="1"/>
+          <p:nvPr/>
+        </p:nvSpPr>
+        <p:spPr>
+          <a:xfrm>
+            <a:off x="548640" y="365760"/>
+            <a:ext cx="11064240" cy="822960"/>
+          </a:xfrm>
+          <a:prstGeom prst="rect">
+            <a:avLst/>
+          </a:prstGeom>
+          <a:noFill/>
+          <a:ln/>
+        </p:spPr>
+        <p:txBody>
+          <a:bodyPr wrap="square" lIns="0" tIns="0" rIns="0" bIns="0" rtlCol="0" anchor="t"/>
+          <a:lstStyle/>
+          <a:p>
+            <a:pPr indent="0" marL="0">
+              <a:buNone/>
+            </a:pPr>
+            <a:r>
+              <a:rPr lang="en-US" sz="3400" b="1" dirty="0">
+                <a:solidFill>
+                  <a:schemeClr val="tx1"/>
+                </a:solidFill>
+              </a:rPr>
               <a:t>A real forecast: Tokyo 2020, made from data up to 2016</a:t>
             </a:r>
             <a:endParaRPr lang="en-US" sz="3400" dirty="0"/>
@@ -5073,7 +7092,7 @@
       </p:sp>
       <p:graphicFrame>
         <p:nvGraphicFramePr>
-          <p:cNvPr id="12" name="Tokyo table"/>
+          <p:cNvPr id="13" name="Tokyo table"/>
           <p:cNvGraphicFramePr>
             <a:graphicFrameLocks noGrp="1"/>
           </p:cNvGraphicFramePr>
@@ -5852,7 +7871,7 @@
                             <a:schemeClr val="tx1"/>
                           </a:solidFill>
                         </a:rPr>
-                        <a:t>Historical + Momentum Score</a:t>
+                        <a:t>Historical + Economic</a:t>
                       </a:r>
                       <a:endParaRPr lang="en-US" sz="1400" dirty="0"/>
                     </a:p>
@@ -5913,7 +7932,7 @@
                             <a:schemeClr val="tx1"/>
                           </a:solidFill>
                         </a:rPr>
-                        <a:t>1.556</a:t>
+                        <a:t>1.538</a:t>
                       </a:r>
                       <a:endParaRPr lang="en-US" sz="1400" dirty="0"/>
                     </a:p>
@@ -5974,7 +7993,7 @@
                             <a:schemeClr val="tx1"/>
                           </a:solidFill>
                         </a:rPr>
-                        <a:t>3.34</a:t>
+                        <a:t>3.10</a:t>
                       </a:r>
                       <a:endParaRPr lang="en-US" sz="1400" dirty="0"/>
                     </a:p>
@@ -6035,7 +8054,499 @@
                             <a:schemeClr val="tx1"/>
                           </a:solidFill>
                         </a:rPr>
-                        <a:t>0.945</a:t>
+                        <a:t>0.952</a:t>
+                      </a:r>
+                      <a:endParaRPr lang="en-US" sz="1400" dirty="0"/>
+                    </a:p>
+                  </a:txBody>
+                  <a:tcPr marL="91440" marR="91440" marT="0" marB="0" anchor="ctr">
+                    <a:lnL w="6350" cap="flat" cmpd="sng" algn="ctr">
+                      <a:solidFill>
+                        <a:srgbClr val="D3DAE3"/>
+                      </a:solidFill>
+                      <a:prstDash val="solid"/>
+                      <a:round/>
+                      <a:headEnd type="none" w="med" len="med"/>
+                      <a:tailEnd type="none" w="med" len="med"/>
+                    </a:lnL>
+                    <a:lnR w="6350" cap="flat" cmpd="sng" algn="ctr">
+                      <a:solidFill>
+                        <a:srgbClr val="D3DAE3"/>
+                      </a:solidFill>
+                      <a:prstDash val="solid"/>
+                      <a:round/>
+                      <a:headEnd type="none" w="med" len="med"/>
+                      <a:tailEnd type="none" w="med" len="med"/>
+                    </a:lnR>
+                    <a:lnT w="6350" cap="flat" cmpd="sng" algn="ctr">
+                      <a:solidFill>
+                        <a:srgbClr val="D3DAE3"/>
+                      </a:solidFill>
+                      <a:prstDash val="solid"/>
+                      <a:round/>
+                      <a:headEnd type="none" w="med" len="med"/>
+                      <a:tailEnd type="none" w="med" len="med"/>
+                    </a:lnT>
+                    <a:lnB w="6350" cap="flat" cmpd="sng" algn="ctr">
+                      <a:solidFill>
+                        <a:srgbClr val="D3DAE3"/>
+                      </a:solidFill>
+                      <a:prstDash val="solid"/>
+                      <a:round/>
+                      <a:headEnd type="none" w="med" len="med"/>
+                      <a:tailEnd type="none" w="med" len="med"/>
+                    </a:lnB>
+                    <a:solidFill>
+                      <a:srgbClr val="FFFFFF"/>
+                    </a:solidFill>
+                  </a:tcPr>
+                </a:tc>
+              </a:tr>
+              <a:tr h="438912">
+                <a:tc>
+                  <a:txBody>
+                    <a:bodyPr/>
+                    <a:lstStyle/>
+                    <a:p>
+                      <a:pPr indent="0" marL="0">
+                        <a:buNone/>
+                      </a:pPr>
+                      <a:r>
+                        <a:rPr lang="en-US" sz="1400" b="1" dirty="0">
+                          <a:solidFill>
+                            <a:schemeClr val="tx1"/>
+                          </a:solidFill>
+                        </a:rPr>
+                        <a:t>Paper Two-Stage</a:t>
+                      </a:r>
+                      <a:endParaRPr lang="en-US" sz="1400" dirty="0"/>
+                    </a:p>
+                  </a:txBody>
+                  <a:tcPr marL="91440" marR="91440" marT="0" marB="0" anchor="ctr">
+                    <a:lnL w="6350" cap="flat" cmpd="sng" algn="ctr">
+                      <a:solidFill>
+                        <a:srgbClr val="D3DAE3"/>
+                      </a:solidFill>
+                      <a:prstDash val="solid"/>
+                      <a:round/>
+                      <a:headEnd type="none" w="med" len="med"/>
+                      <a:tailEnd type="none" w="med" len="med"/>
+                    </a:lnL>
+                    <a:lnR w="6350" cap="flat" cmpd="sng" algn="ctr">
+                      <a:solidFill>
+                        <a:srgbClr val="D3DAE3"/>
+                      </a:solidFill>
+                      <a:prstDash val="solid"/>
+                      <a:round/>
+                      <a:headEnd type="none" w="med" len="med"/>
+                      <a:tailEnd type="none" w="med" len="med"/>
+                    </a:lnR>
+                    <a:lnT w="6350" cap="flat" cmpd="sng" algn="ctr">
+                      <a:solidFill>
+                        <a:srgbClr val="D3DAE3"/>
+                      </a:solidFill>
+                      <a:prstDash val="solid"/>
+                      <a:round/>
+                      <a:headEnd type="none" w="med" len="med"/>
+                      <a:tailEnd type="none" w="med" len="med"/>
+                    </a:lnT>
+                    <a:lnB w="6350" cap="flat" cmpd="sng" algn="ctr">
+                      <a:solidFill>
+                        <a:srgbClr val="D3DAE3"/>
+                      </a:solidFill>
+                      <a:prstDash val="solid"/>
+                      <a:round/>
+                      <a:headEnd type="none" w="med" len="med"/>
+                      <a:tailEnd type="none" w="med" len="med"/>
+                    </a:lnB>
+                    <a:solidFill>
+                      <a:srgbClr val="FBF3DF"/>
+                    </a:solidFill>
+                  </a:tcPr>
+                </a:tc>
+                <a:tc>
+                  <a:txBody>
+                    <a:bodyPr/>
+                    <a:lstStyle/>
+                    <a:p>
+                      <a:pPr indent="0" marL="0">
+                        <a:buNone/>
+                      </a:pPr>
+                      <a:r>
+                        <a:rPr lang="en-US" sz="1400" b="1" dirty="0">
+                          <a:solidFill>
+                            <a:schemeClr val="tx1"/>
+                          </a:solidFill>
+                        </a:rPr>
+                        <a:t>1.506</a:t>
+                      </a:r>
+                      <a:endParaRPr lang="en-US" sz="1400" dirty="0"/>
+                    </a:p>
+                  </a:txBody>
+                  <a:tcPr marL="91440" marR="91440" marT="0" marB="0" anchor="ctr">
+                    <a:lnL w="6350" cap="flat" cmpd="sng" algn="ctr">
+                      <a:solidFill>
+                        <a:srgbClr val="D3DAE3"/>
+                      </a:solidFill>
+                      <a:prstDash val="solid"/>
+                      <a:round/>
+                      <a:headEnd type="none" w="med" len="med"/>
+                      <a:tailEnd type="none" w="med" len="med"/>
+                    </a:lnL>
+                    <a:lnR w="6350" cap="flat" cmpd="sng" algn="ctr">
+                      <a:solidFill>
+                        <a:srgbClr val="D3DAE3"/>
+                      </a:solidFill>
+                      <a:prstDash val="solid"/>
+                      <a:round/>
+                      <a:headEnd type="none" w="med" len="med"/>
+                      <a:tailEnd type="none" w="med" len="med"/>
+                    </a:lnR>
+                    <a:lnT w="6350" cap="flat" cmpd="sng" algn="ctr">
+                      <a:solidFill>
+                        <a:srgbClr val="D3DAE3"/>
+                      </a:solidFill>
+                      <a:prstDash val="solid"/>
+                      <a:round/>
+                      <a:headEnd type="none" w="med" len="med"/>
+                      <a:tailEnd type="none" w="med" len="med"/>
+                    </a:lnT>
+                    <a:lnB w="6350" cap="flat" cmpd="sng" algn="ctr">
+                      <a:solidFill>
+                        <a:srgbClr val="D3DAE3"/>
+                      </a:solidFill>
+                      <a:prstDash val="solid"/>
+                      <a:round/>
+                      <a:headEnd type="none" w="med" len="med"/>
+                      <a:tailEnd type="none" w="med" len="med"/>
+                    </a:lnB>
+                    <a:solidFill>
+                      <a:srgbClr val="FBF3DF"/>
+                    </a:solidFill>
+                  </a:tcPr>
+                </a:tc>
+                <a:tc>
+                  <a:txBody>
+                    <a:bodyPr/>
+                    <a:lstStyle/>
+                    <a:p>
+                      <a:pPr indent="0" marL="0">
+                        <a:buNone/>
+                      </a:pPr>
+                      <a:r>
+                        <a:rPr lang="en-US" sz="1400" b="1" dirty="0">
+                          <a:solidFill>
+                            <a:schemeClr val="tx1"/>
+                          </a:solidFill>
+                        </a:rPr>
+                        <a:t>3.12</a:t>
+                      </a:r>
+                      <a:endParaRPr lang="en-US" sz="1400" dirty="0"/>
+                    </a:p>
+                  </a:txBody>
+                  <a:tcPr marL="91440" marR="91440" marT="0" marB="0" anchor="ctr">
+                    <a:lnL w="6350" cap="flat" cmpd="sng" algn="ctr">
+                      <a:solidFill>
+                        <a:srgbClr val="D3DAE3"/>
+                      </a:solidFill>
+                      <a:prstDash val="solid"/>
+                      <a:round/>
+                      <a:headEnd type="none" w="med" len="med"/>
+                      <a:tailEnd type="none" w="med" len="med"/>
+                    </a:lnL>
+                    <a:lnR w="6350" cap="flat" cmpd="sng" algn="ctr">
+                      <a:solidFill>
+                        <a:srgbClr val="D3DAE3"/>
+                      </a:solidFill>
+                      <a:prstDash val="solid"/>
+                      <a:round/>
+                      <a:headEnd type="none" w="med" len="med"/>
+                      <a:tailEnd type="none" w="med" len="med"/>
+                    </a:lnR>
+                    <a:lnT w="6350" cap="flat" cmpd="sng" algn="ctr">
+                      <a:solidFill>
+                        <a:srgbClr val="D3DAE3"/>
+                      </a:solidFill>
+                      <a:prstDash val="solid"/>
+                      <a:round/>
+                      <a:headEnd type="none" w="med" len="med"/>
+                      <a:tailEnd type="none" w="med" len="med"/>
+                    </a:lnT>
+                    <a:lnB w="6350" cap="flat" cmpd="sng" algn="ctr">
+                      <a:solidFill>
+                        <a:srgbClr val="D3DAE3"/>
+                      </a:solidFill>
+                      <a:prstDash val="solid"/>
+                      <a:round/>
+                      <a:headEnd type="none" w="med" len="med"/>
+                      <a:tailEnd type="none" w="med" len="med"/>
+                    </a:lnB>
+                    <a:solidFill>
+                      <a:srgbClr val="FBF3DF"/>
+                    </a:solidFill>
+                  </a:tcPr>
+                </a:tc>
+                <a:tc>
+                  <a:txBody>
+                    <a:bodyPr/>
+                    <a:lstStyle/>
+                    <a:p>
+                      <a:pPr indent="0" marL="0">
+                        <a:buNone/>
+                      </a:pPr>
+                      <a:r>
+                        <a:rPr lang="en-US" sz="1400" b="1" dirty="0">
+                          <a:solidFill>
+                            <a:schemeClr val="tx1"/>
+                          </a:solidFill>
+                        </a:rPr>
+                        <a:t>0.952</a:t>
+                      </a:r>
+                      <a:endParaRPr lang="en-US" sz="1400" dirty="0"/>
+                    </a:p>
+                  </a:txBody>
+                  <a:tcPr marL="91440" marR="91440" marT="0" marB="0" anchor="ctr">
+                    <a:lnL w="6350" cap="flat" cmpd="sng" algn="ctr">
+                      <a:solidFill>
+                        <a:srgbClr val="D3DAE3"/>
+                      </a:solidFill>
+                      <a:prstDash val="solid"/>
+                      <a:round/>
+                      <a:headEnd type="none" w="med" len="med"/>
+                      <a:tailEnd type="none" w="med" len="med"/>
+                    </a:lnL>
+                    <a:lnR w="6350" cap="flat" cmpd="sng" algn="ctr">
+                      <a:solidFill>
+                        <a:srgbClr val="D3DAE3"/>
+                      </a:solidFill>
+                      <a:prstDash val="solid"/>
+                      <a:round/>
+                      <a:headEnd type="none" w="med" len="med"/>
+                      <a:tailEnd type="none" w="med" len="med"/>
+                    </a:lnR>
+                    <a:lnT w="6350" cap="flat" cmpd="sng" algn="ctr">
+                      <a:solidFill>
+                        <a:srgbClr val="D3DAE3"/>
+                      </a:solidFill>
+                      <a:prstDash val="solid"/>
+                      <a:round/>
+                      <a:headEnd type="none" w="med" len="med"/>
+                      <a:tailEnd type="none" w="med" len="med"/>
+                    </a:lnT>
+                    <a:lnB w="6350" cap="flat" cmpd="sng" algn="ctr">
+                      <a:solidFill>
+                        <a:srgbClr val="D3DAE3"/>
+                      </a:solidFill>
+                      <a:prstDash val="solid"/>
+                      <a:round/>
+                      <a:headEnd type="none" w="med" len="med"/>
+                      <a:tailEnd type="none" w="med" len="med"/>
+                    </a:lnB>
+                    <a:solidFill>
+                      <a:srgbClr val="FBF3DF"/>
+                    </a:solidFill>
+                  </a:tcPr>
+                </a:tc>
+              </a:tr>
+              <a:tr h="438912">
+                <a:tc>
+                  <a:txBody>
+                    <a:bodyPr/>
+                    <a:lstStyle/>
+                    <a:p>
+                      <a:pPr indent="0" marL="0">
+                        <a:buNone/>
+                      </a:pPr>
+                      <a:r>
+                        <a:rPr lang="en-US" sz="1400" dirty="0">
+                          <a:solidFill>
+                            <a:schemeClr val="tx1"/>
+                          </a:solidFill>
+                        </a:rPr>
+                        <a:t>Momentum Target</a:t>
+                      </a:r>
+                      <a:endParaRPr lang="en-US" sz="1400" dirty="0"/>
+                    </a:p>
+                  </a:txBody>
+                  <a:tcPr marL="91440" marR="91440" marT="0" marB="0" anchor="ctr">
+                    <a:lnL w="6350" cap="flat" cmpd="sng" algn="ctr">
+                      <a:solidFill>
+                        <a:srgbClr val="D3DAE3"/>
+                      </a:solidFill>
+                      <a:prstDash val="solid"/>
+                      <a:round/>
+                      <a:headEnd type="none" w="med" len="med"/>
+                      <a:tailEnd type="none" w="med" len="med"/>
+                    </a:lnL>
+                    <a:lnR w="6350" cap="flat" cmpd="sng" algn="ctr">
+                      <a:solidFill>
+                        <a:srgbClr val="D3DAE3"/>
+                      </a:solidFill>
+                      <a:prstDash val="solid"/>
+                      <a:round/>
+                      <a:headEnd type="none" w="med" len="med"/>
+                      <a:tailEnd type="none" w="med" len="med"/>
+                    </a:lnR>
+                    <a:lnT w="6350" cap="flat" cmpd="sng" algn="ctr">
+                      <a:solidFill>
+                        <a:srgbClr val="D3DAE3"/>
+                      </a:solidFill>
+                      <a:prstDash val="solid"/>
+                      <a:round/>
+                      <a:headEnd type="none" w="med" len="med"/>
+                      <a:tailEnd type="none" w="med" len="med"/>
+                    </a:lnT>
+                    <a:lnB w="6350" cap="flat" cmpd="sng" algn="ctr">
+                      <a:solidFill>
+                        <a:srgbClr val="D3DAE3"/>
+                      </a:solidFill>
+                      <a:prstDash val="solid"/>
+                      <a:round/>
+                      <a:headEnd type="none" w="med" len="med"/>
+                      <a:tailEnd type="none" w="med" len="med"/>
+                    </a:lnB>
+                    <a:solidFill>
+                      <a:srgbClr val="FFFFFF"/>
+                    </a:solidFill>
+                  </a:tcPr>
+                </a:tc>
+                <a:tc>
+                  <a:txBody>
+                    <a:bodyPr/>
+                    <a:lstStyle/>
+                    <a:p>
+                      <a:pPr indent="0" marL="0">
+                        <a:buNone/>
+                      </a:pPr>
+                      <a:r>
+                        <a:rPr lang="en-US" sz="1400" dirty="0">
+                          <a:solidFill>
+                            <a:schemeClr val="tx1"/>
+                          </a:solidFill>
+                        </a:rPr>
+                        <a:t>1.557</a:t>
+                      </a:r>
+                      <a:endParaRPr lang="en-US" sz="1400" dirty="0"/>
+                    </a:p>
+                  </a:txBody>
+                  <a:tcPr marL="91440" marR="91440" marT="0" marB="0" anchor="ctr">
+                    <a:lnL w="6350" cap="flat" cmpd="sng" algn="ctr">
+                      <a:solidFill>
+                        <a:srgbClr val="D3DAE3"/>
+                      </a:solidFill>
+                      <a:prstDash val="solid"/>
+                      <a:round/>
+                      <a:headEnd type="none" w="med" len="med"/>
+                      <a:tailEnd type="none" w="med" len="med"/>
+                    </a:lnL>
+                    <a:lnR w="6350" cap="flat" cmpd="sng" algn="ctr">
+                      <a:solidFill>
+                        <a:srgbClr val="D3DAE3"/>
+                      </a:solidFill>
+                      <a:prstDash val="solid"/>
+                      <a:round/>
+                      <a:headEnd type="none" w="med" len="med"/>
+                      <a:tailEnd type="none" w="med" len="med"/>
+                    </a:lnR>
+                    <a:lnT w="6350" cap="flat" cmpd="sng" algn="ctr">
+                      <a:solidFill>
+                        <a:srgbClr val="D3DAE3"/>
+                      </a:solidFill>
+                      <a:prstDash val="solid"/>
+                      <a:round/>
+                      <a:headEnd type="none" w="med" len="med"/>
+                      <a:tailEnd type="none" w="med" len="med"/>
+                    </a:lnT>
+                    <a:lnB w="6350" cap="flat" cmpd="sng" algn="ctr">
+                      <a:solidFill>
+                        <a:srgbClr val="D3DAE3"/>
+                      </a:solidFill>
+                      <a:prstDash val="solid"/>
+                      <a:round/>
+                      <a:headEnd type="none" w="med" len="med"/>
+                      <a:tailEnd type="none" w="med" len="med"/>
+                    </a:lnB>
+                    <a:solidFill>
+                      <a:srgbClr val="FFFFFF"/>
+                    </a:solidFill>
+                  </a:tcPr>
+                </a:tc>
+                <a:tc>
+                  <a:txBody>
+                    <a:bodyPr/>
+                    <a:lstStyle/>
+                    <a:p>
+                      <a:pPr indent="0" marL="0">
+                        <a:buNone/>
+                      </a:pPr>
+                      <a:r>
+                        <a:rPr lang="en-US" sz="1400" dirty="0">
+                          <a:solidFill>
+                            <a:schemeClr val="tx1"/>
+                          </a:solidFill>
+                        </a:rPr>
+                        <a:t>3.72</a:t>
+                      </a:r>
+                      <a:endParaRPr lang="en-US" sz="1400" dirty="0"/>
+                    </a:p>
+                  </a:txBody>
+                  <a:tcPr marL="91440" marR="91440" marT="0" marB="0" anchor="ctr">
+                    <a:lnL w="6350" cap="flat" cmpd="sng" algn="ctr">
+                      <a:solidFill>
+                        <a:srgbClr val="D3DAE3"/>
+                      </a:solidFill>
+                      <a:prstDash val="solid"/>
+                      <a:round/>
+                      <a:headEnd type="none" w="med" len="med"/>
+                      <a:tailEnd type="none" w="med" len="med"/>
+                    </a:lnL>
+                    <a:lnR w="6350" cap="flat" cmpd="sng" algn="ctr">
+                      <a:solidFill>
+                        <a:srgbClr val="D3DAE3"/>
+                      </a:solidFill>
+                      <a:prstDash val="solid"/>
+                      <a:round/>
+                      <a:headEnd type="none" w="med" len="med"/>
+                      <a:tailEnd type="none" w="med" len="med"/>
+                    </a:lnR>
+                    <a:lnT w="6350" cap="flat" cmpd="sng" algn="ctr">
+                      <a:solidFill>
+                        <a:srgbClr val="D3DAE3"/>
+                      </a:solidFill>
+                      <a:prstDash val="solid"/>
+                      <a:round/>
+                      <a:headEnd type="none" w="med" len="med"/>
+                      <a:tailEnd type="none" w="med" len="med"/>
+                    </a:lnT>
+                    <a:lnB w="6350" cap="flat" cmpd="sng" algn="ctr">
+                      <a:solidFill>
+                        <a:srgbClr val="D3DAE3"/>
+                      </a:solidFill>
+                      <a:prstDash val="solid"/>
+                      <a:round/>
+                      <a:headEnd type="none" w="med" len="med"/>
+                      <a:tailEnd type="none" w="med" len="med"/>
+                    </a:lnB>
+                    <a:solidFill>
+                      <a:srgbClr val="FFFFFF"/>
+                    </a:solidFill>
+                  </a:tcPr>
+                </a:tc>
+                <a:tc>
+                  <a:txBody>
+                    <a:bodyPr/>
+                    <a:lstStyle/>
+                    <a:p>
+                      <a:pPr indent="0" marL="0">
+                        <a:buNone/>
+                      </a:pPr>
+                      <a:r>
+                        <a:rPr lang="en-US" sz="1400" dirty="0">
+                          <a:solidFill>
+                            <a:schemeClr val="tx1"/>
+                          </a:solidFill>
+                        </a:rPr>
+                        <a:t>0.931</a:t>
                       </a:r>
                       <a:endParaRPr lang="en-US" sz="1400" dirty="0"/>
                     </a:p>
@@ -6098,7 +8609,7 @@
                             <a:schemeClr val="tx1"/>
                           </a:solidFill>
                         </a:rPr>
-                        <a:t>Paper Two-Stage</a:t>
+                        <a:t>Momentum Target + Economic</a:t>
                       </a:r>
                       <a:endParaRPr lang="en-US" sz="1400" dirty="0"/>
                     </a:p>
@@ -6159,7 +8670,7 @@
                             <a:schemeClr val="tx1"/>
                           </a:solidFill>
                         </a:rPr>
-                        <a:t>1.552</a:t>
+                        <a:t>1.596</a:t>
                       </a:r>
                       <a:endParaRPr lang="en-US" sz="1400" dirty="0"/>
                     </a:p>
@@ -6220,7 +8731,7 @@
                             <a:schemeClr val="tx1"/>
                           </a:solidFill>
                         </a:rPr>
-                        <a:t>3.40</a:t>
+                        <a:t>3.60</a:t>
                       </a:r>
                       <a:endParaRPr lang="en-US" sz="1400" dirty="0"/>
                     </a:p>
@@ -6281,7 +8792,7 @@
                             <a:schemeClr val="tx1"/>
                           </a:solidFill>
                         </a:rPr>
-                        <a:t>0.943</a:t>
+                        <a:t>0.936</a:t>
                       </a:r>
                       <a:endParaRPr lang="en-US" sz="1400" dirty="0"/>
                     </a:p>
@@ -6325,252 +8836,6 @@
                     </a:lnB>
                     <a:solidFill>
                       <a:srgbClr val="FFFFFF"/>
-                    </a:solidFill>
-                  </a:tcPr>
-                </a:tc>
-              </a:tr>
-              <a:tr h="438912">
-                <a:tc>
-                  <a:txBody>
-                    <a:bodyPr/>
-                    <a:lstStyle/>
-                    <a:p>
-                      <a:pPr indent="0" marL="0">
-                        <a:buNone/>
-                      </a:pPr>
-                      <a:r>
-                        <a:rPr lang="en-US" sz="1400" b="1" dirty="0">
-                          <a:solidFill>
-                            <a:schemeClr val="tx1"/>
-                          </a:solidFill>
-                        </a:rPr>
-                        <a:t>Momentum Target</a:t>
-                      </a:r>
-                      <a:endParaRPr lang="en-US" sz="1400" dirty="0"/>
-                    </a:p>
-                  </a:txBody>
-                  <a:tcPr marL="91440" marR="91440" marT="0" marB="0" anchor="ctr">
-                    <a:lnL w="6350" cap="flat" cmpd="sng" algn="ctr">
-                      <a:solidFill>
-                        <a:srgbClr val="D3DAE3"/>
-                      </a:solidFill>
-                      <a:prstDash val="solid"/>
-                      <a:round/>
-                      <a:headEnd type="none" w="med" len="med"/>
-                      <a:tailEnd type="none" w="med" len="med"/>
-                    </a:lnL>
-                    <a:lnR w="6350" cap="flat" cmpd="sng" algn="ctr">
-                      <a:solidFill>
-                        <a:srgbClr val="D3DAE3"/>
-                      </a:solidFill>
-                      <a:prstDash val="solid"/>
-                      <a:round/>
-                      <a:headEnd type="none" w="med" len="med"/>
-                      <a:tailEnd type="none" w="med" len="med"/>
-                    </a:lnR>
-                    <a:lnT w="6350" cap="flat" cmpd="sng" algn="ctr">
-                      <a:solidFill>
-                        <a:srgbClr val="D3DAE3"/>
-                      </a:solidFill>
-                      <a:prstDash val="solid"/>
-                      <a:round/>
-                      <a:headEnd type="none" w="med" len="med"/>
-                      <a:tailEnd type="none" w="med" len="med"/>
-                    </a:lnT>
-                    <a:lnB w="6350" cap="flat" cmpd="sng" algn="ctr">
-                      <a:solidFill>
-                        <a:srgbClr val="D3DAE3"/>
-                      </a:solidFill>
-                      <a:prstDash val="solid"/>
-                      <a:round/>
-                      <a:headEnd type="none" w="med" len="med"/>
-                      <a:tailEnd type="none" w="med" len="med"/>
-                    </a:lnB>
-                    <a:solidFill>
-                      <a:srgbClr val="FBF3DF"/>
-                    </a:solidFill>
-                  </a:tcPr>
-                </a:tc>
-                <a:tc>
-                  <a:txBody>
-                    <a:bodyPr/>
-                    <a:lstStyle/>
-                    <a:p>
-                      <a:pPr indent="0" marL="0">
-                        <a:buNone/>
-                      </a:pPr>
-                      <a:r>
-                        <a:rPr lang="en-US" sz="1400" b="1" dirty="0">
-                          <a:solidFill>
-                            <a:schemeClr val="tx1"/>
-                          </a:solidFill>
-                        </a:rPr>
-                        <a:t>1.557</a:t>
-                      </a:r>
-                      <a:endParaRPr lang="en-US" sz="1400" dirty="0"/>
-                    </a:p>
-                  </a:txBody>
-                  <a:tcPr marL="91440" marR="91440" marT="0" marB="0" anchor="ctr">
-                    <a:lnL w="6350" cap="flat" cmpd="sng" algn="ctr">
-                      <a:solidFill>
-                        <a:srgbClr val="D3DAE3"/>
-                      </a:solidFill>
-                      <a:prstDash val="solid"/>
-                      <a:round/>
-                      <a:headEnd type="none" w="med" len="med"/>
-                      <a:tailEnd type="none" w="med" len="med"/>
-                    </a:lnL>
-                    <a:lnR w="6350" cap="flat" cmpd="sng" algn="ctr">
-                      <a:solidFill>
-                        <a:srgbClr val="D3DAE3"/>
-                      </a:solidFill>
-                      <a:prstDash val="solid"/>
-                      <a:round/>
-                      <a:headEnd type="none" w="med" len="med"/>
-                      <a:tailEnd type="none" w="med" len="med"/>
-                    </a:lnR>
-                    <a:lnT w="6350" cap="flat" cmpd="sng" algn="ctr">
-                      <a:solidFill>
-                        <a:srgbClr val="D3DAE3"/>
-                      </a:solidFill>
-                      <a:prstDash val="solid"/>
-                      <a:round/>
-                      <a:headEnd type="none" w="med" len="med"/>
-                      <a:tailEnd type="none" w="med" len="med"/>
-                    </a:lnT>
-                    <a:lnB w="6350" cap="flat" cmpd="sng" algn="ctr">
-                      <a:solidFill>
-                        <a:srgbClr val="D3DAE3"/>
-                      </a:solidFill>
-                      <a:prstDash val="solid"/>
-                      <a:round/>
-                      <a:headEnd type="none" w="med" len="med"/>
-                      <a:tailEnd type="none" w="med" len="med"/>
-                    </a:lnB>
-                    <a:solidFill>
-                      <a:srgbClr val="FBF3DF"/>
-                    </a:solidFill>
-                  </a:tcPr>
-                </a:tc>
-                <a:tc>
-                  <a:txBody>
-                    <a:bodyPr/>
-                    <a:lstStyle/>
-                    <a:p>
-                      <a:pPr indent="0" marL="0">
-                        <a:buNone/>
-                      </a:pPr>
-                      <a:r>
-                        <a:rPr lang="en-US" sz="1400" b="1" dirty="0">
-                          <a:solidFill>
-                            <a:schemeClr val="tx1"/>
-                          </a:solidFill>
-                        </a:rPr>
-                        <a:t>3.72</a:t>
-                      </a:r>
-                      <a:endParaRPr lang="en-US" sz="1400" dirty="0"/>
-                    </a:p>
-                  </a:txBody>
-                  <a:tcPr marL="91440" marR="91440" marT="0" marB="0" anchor="ctr">
-                    <a:lnL w="6350" cap="flat" cmpd="sng" algn="ctr">
-                      <a:solidFill>
-                        <a:srgbClr val="D3DAE3"/>
-                      </a:solidFill>
-                      <a:prstDash val="solid"/>
-                      <a:round/>
-                      <a:headEnd type="none" w="med" len="med"/>
-                      <a:tailEnd type="none" w="med" len="med"/>
-                    </a:lnL>
-                    <a:lnR w="6350" cap="flat" cmpd="sng" algn="ctr">
-                      <a:solidFill>
-                        <a:srgbClr val="D3DAE3"/>
-                      </a:solidFill>
-                      <a:prstDash val="solid"/>
-                      <a:round/>
-                      <a:headEnd type="none" w="med" len="med"/>
-                      <a:tailEnd type="none" w="med" len="med"/>
-                    </a:lnR>
-                    <a:lnT w="6350" cap="flat" cmpd="sng" algn="ctr">
-                      <a:solidFill>
-                        <a:srgbClr val="D3DAE3"/>
-                      </a:solidFill>
-                      <a:prstDash val="solid"/>
-                      <a:round/>
-                      <a:headEnd type="none" w="med" len="med"/>
-                      <a:tailEnd type="none" w="med" len="med"/>
-                    </a:lnT>
-                    <a:lnB w="6350" cap="flat" cmpd="sng" algn="ctr">
-                      <a:solidFill>
-                        <a:srgbClr val="D3DAE3"/>
-                      </a:solidFill>
-                      <a:prstDash val="solid"/>
-                      <a:round/>
-                      <a:headEnd type="none" w="med" len="med"/>
-                      <a:tailEnd type="none" w="med" len="med"/>
-                    </a:lnB>
-                    <a:solidFill>
-                      <a:srgbClr val="FBF3DF"/>
-                    </a:solidFill>
-                  </a:tcPr>
-                </a:tc>
-                <a:tc>
-                  <a:txBody>
-                    <a:bodyPr/>
-                    <a:lstStyle/>
-                    <a:p>
-                      <a:pPr indent="0" marL="0">
-                        <a:buNone/>
-                      </a:pPr>
-                      <a:r>
-                        <a:rPr lang="en-US" sz="1400" b="1" dirty="0">
-                          <a:solidFill>
-                            <a:schemeClr val="tx1"/>
-                          </a:solidFill>
-                        </a:rPr>
-                        <a:t>0.931</a:t>
-                      </a:r>
-                      <a:endParaRPr lang="en-US" sz="1400" dirty="0"/>
-                    </a:p>
-                  </a:txBody>
-                  <a:tcPr marL="91440" marR="91440" marT="0" marB="0" anchor="ctr">
-                    <a:lnL w="6350" cap="flat" cmpd="sng" algn="ctr">
-                      <a:solidFill>
-                        <a:srgbClr val="D3DAE3"/>
-                      </a:solidFill>
-                      <a:prstDash val="solid"/>
-                      <a:round/>
-                      <a:headEnd type="none" w="med" len="med"/>
-                      <a:tailEnd type="none" w="med" len="med"/>
-                    </a:lnL>
-                    <a:lnR w="6350" cap="flat" cmpd="sng" algn="ctr">
-                      <a:solidFill>
-                        <a:srgbClr val="D3DAE3"/>
-                      </a:solidFill>
-                      <a:prstDash val="solid"/>
-                      <a:round/>
-                      <a:headEnd type="none" w="med" len="med"/>
-                      <a:tailEnd type="none" w="med" len="med"/>
-                    </a:lnR>
-                    <a:lnT w="6350" cap="flat" cmpd="sng" algn="ctr">
-                      <a:solidFill>
-                        <a:srgbClr val="D3DAE3"/>
-                      </a:solidFill>
-                      <a:prstDash val="solid"/>
-                      <a:round/>
-                      <a:headEnd type="none" w="med" len="med"/>
-                      <a:tailEnd type="none" w="med" len="med"/>
-                    </a:lnT>
-                    <a:lnB w="6350" cap="flat" cmpd="sng" algn="ctr">
-                      <a:solidFill>
-                        <a:srgbClr val="D3DAE3"/>
-                      </a:solidFill>
-                      <a:prstDash val="solid"/>
-                      <a:round/>
-                      <a:headEnd type="none" w="med" len="med"/>
-                      <a:tailEnd type="none" w="med" len="med"/>
-                    </a:lnB>
-                    <a:solidFill>
-                      <a:srgbClr val="FBF3DF"/>
                     </a:solidFill>
                   </a:tcPr>
                 </a:tc>
@@ -6587,7 +8852,7 @@
         </p:nvSpPr>
         <p:spPr>
           <a:xfrm>
-            <a:off x="548640" y="4343400"/>
+            <a:off x="548640" y="4663440"/>
             <a:ext cx="5486400" cy="1280160"/>
           </a:xfrm>
           <a:prstGeom prst="rect">
@@ -6604,14 +8869,14 @@
               <a:buNone/>
             </a:pPr>
             <a:r>
-              <a:rPr lang="en-US" sz="1600" dirty="0">
+              <a:rPr lang="en-US" sz="1500" dirty="0">
                 <a:solidFill>
                   <a:schemeClr val="accent6"/>
                 </a:solidFill>
               </a:rPr>
-              <a:t>Every model beyond the baseline lands within 0.02 MAE of the others. A home Games and a COVID-disrupted cycle are shocks that Olympic history alone cannot see.</a:t>
+              <a:t>On the real future, World Bank data helps: wealth and population carry signal that last Games’ medals miss when a cycle is disrupted. Our momentum edge from 1996–2016 did not carry over.</a:t>
             </a:r>
-            <a:endParaRPr lang="en-US" sz="1600" dirty="0"/>
+            <a:endParaRPr lang="en-US" sz="1500" dirty="0"/>
           </a:p>
         </p:txBody>
       </p:sp>
@@ -6670,7 +8935,7 @@
             <a:pPr algn="r"/>
             <a:fld id="{F7021451-1387-4CA6-816F-3879F97B5CBC}" type="slidenum">
               <a:rPr b="0" lang="en-US"/>
-              <a:t>11</a:t>
+              <a:t>12</a:t>
             </a:fld>
             <a:endParaRPr lang="en-US"/>
           </a:p>
@@ -6684,9 +8949,9 @@
 </p:sld>
 </file>
 
-<file path=ppt/slides/slide12.xml><?xml version="1.0" encoding="utf-8"?>
+<file path=ppt/slides/slide13.xml><?xml version="1.0" encoding="utf-8"?>
 <p:sld xmlns:a="http://schemas.openxmlformats.org/drawingml/2006/main" xmlns:r="http://schemas.openxmlformats.org/officeDocument/2006/relationships" xmlns:p="http://schemas.openxmlformats.org/presentationml/2006/main">
-  <p:cSld name="Slide 12">
+  <p:cSld name="Slide 13">
     <p:spTree>
       <p:nvGrpSpPr>
         <p:cNvPr id="1" name=""/>
@@ -6852,7 +9117,7 @@
             <a:pPr algn="r"/>
             <a:fld id="{F7021451-1387-4CA6-816F-3879F97B5CBC}" type="slidenum">
               <a:rPr b="0" lang="en-US"/>
-              <a:t>12</a:t>
+              <a:t>13</a:t>
             </a:fld>
             <a:endParaRPr lang="en-US"/>
           </a:p>
@@ -6866,9 +9131,9 @@
 </p:sld>
 </file>
 
-<file path=ppt/slides/slide13.xml><?xml version="1.0" encoding="utf-8"?>
+<file path=ppt/slides/slide14.xml><?xml version="1.0" encoding="utf-8"?>
 <p:sld xmlns:a="http://schemas.openxmlformats.org/drawingml/2006/main" xmlns:r="http://schemas.openxmlformats.org/officeDocument/2006/relationships" xmlns:p="http://schemas.openxmlformats.org/presentationml/2006/main">
-  <p:cSld name="Slide 13">
+  <p:cSld name="Slide 14">
     <p:spTree>
       <p:nvGrpSpPr>
         <p:cNvPr id="1" name=""/>
@@ -7143,7 +9408,7 @@
                   <a:schemeClr val="accent6"/>
                 </a:solidFill>
               </a:rPr>
-              <a:t>All non-baseline models tie (about 1.56 MAE). Host and COVID effects are invisible to history-only features.</a:t>
+              <a:t>The momentum model falls mid-pack; the paper’s two-stage model with World Bank data wins. Host and COVID effects are not in any feature.</a:t>
             </a:r>
             <a:endParaRPr lang="en-US" sz="1500" dirty="0"/>
           </a:p>
@@ -7204,7 +9469,7 @@
                   <a:schemeClr val="tx1"/>
                 </a:solidFill>
               </a:rPr>
-              <a:t>Importance is not cause</a:t>
+              <a:t>World Bank gaps</a:t>
             </a:r>
             <a:endParaRPr lang="en-US" sz="1700" dirty="0"/>
           </a:p>
@@ -7240,7 +9505,7 @@
                   <a:schemeClr val="accent6"/>
                 </a:solidFill>
               </a:rPr>
-              <a:t>Feature importance shows what the model uses, not why countries win.</a:t>
+              <a:t>No data for the USSR, East Germany or Taiwan, so 8% of rows lack economic features.</a:t>
             </a:r>
             <a:endParaRPr lang="en-US" sz="1500" dirty="0"/>
           </a:p>
@@ -7361,7 +9626,7 @@
                   <a:schemeClr val="tx1"/>
                 </a:solidFill>
               </a:rPr>
-              <a:t>Add GDP and population, as in the reference paper</a:t>
+              <a:t>Combine both strengths: momentum target with World Bank data in a tuned SVR or boosting model</a:t>
             </a:r>
             <a:endParaRPr lang="en-US" sz="1700" dirty="0"/>
           </a:p>
@@ -7442,7 +9707,7 @@
             <a:pPr algn="r"/>
             <a:fld id="{F7021451-1387-4CA6-816F-3879F97B5CBC}" type="slidenum">
               <a:rPr b="0" lang="en-US"/>
-              <a:t>13</a:t>
+              <a:t>14</a:t>
             </a:fld>
             <a:endParaRPr lang="en-US"/>
           </a:p>
@@ -7456,9 +9721,9 @@
 </p:sld>
 </file>
 
-<file path=ppt/slides/slide14.xml><?xml version="1.0" encoding="utf-8"?>
+<file path=ppt/slides/slide15.xml><?xml version="1.0" encoding="utf-8"?>
 <p:sld xmlns:a="http://schemas.openxmlformats.org/drawingml/2006/main" xmlns:r="http://schemas.openxmlformats.org/officeDocument/2006/relationships" xmlns:p="http://schemas.openxmlformats.org/presentationml/2006/main">
-  <p:cSld name="Slide 14">
+  <p:cSld name="Slide 15">
     <p:spTree>
       <p:nvGrpSpPr>
         <p:cNvPr id="1" name=""/>
@@ -7686,7 +9951,7 @@
                   <a:schemeClr val="bg1"/>
                 </a:solidFill>
               </a:rPr>
-              <a:t>The composite momentum score alone adds nothing, and Tokyo 2020 shows the limits of history-only models. The contribution is the target design, not a bigger model.</a:t>
+              <a:t>Predicting momentum also helps Linear, Ridge, Lasso and Random Forest models. The momentum score alone adds nothing, and on Tokyo 2020 the paper’s World Bank models win. The contribution is the target design.</a:t>
             </a:r>
             <a:endParaRPr lang="en-US" sz="1900" dirty="0"/>
           </a:p>
@@ -7731,7 +9996,7 @@
             <a:pPr algn="r"/>
             <a:fld id="{F7021451-1387-4CA6-816F-3879F97B5CBC}" type="slidenum">
               <a:rPr b="0" lang="en-US"/>
-              <a:t>14</a:t>
+              <a:t>15</a:t>
             </a:fld>
             <a:endParaRPr lang="en-US"/>
           </a:p>
@@ -7745,9 +10010,9 @@
 </p:sld>
 </file>
 
-<file path=ppt/slides/slide15.xml><?xml version="1.0" encoding="utf-8"?>
+<file path=ppt/slides/slide16.xml><?xml version="1.0" encoding="utf-8"?>
 <p:sld xmlns:a="http://schemas.openxmlformats.org/drawingml/2006/main" xmlns:r="http://schemas.openxmlformats.org/officeDocument/2006/relationships" xmlns:p="http://schemas.openxmlformats.org/presentationml/2006/main">
-  <p:cSld name="Slide 15">
+  <p:cSld name="Slide 16">
     <p:spTree>
       <p:nvGrpSpPr>
         <p:cNvPr id="1" name=""/>
@@ -8235,7 +10500,7 @@
             <a:pPr algn="r"/>
             <a:fld id="{F7021451-1387-4CA6-816F-3879F97B5CBC}" type="slidenum">
               <a:rPr b="0" lang="en-US"/>
-              <a:t>15</a:t>
+              <a:t>16</a:t>
             </a:fld>
             <a:endParaRPr lang="en-US"/>
           </a:p>
@@ -8866,7 +11131,7 @@
                 <a:gridCol w="2377440"/>
                 <a:gridCol w="8686800"/>
               </a:tblGrid>
-              <a:tr h="566928">
+              <a:tr h="530352">
                 <a:tc>
                   <a:txBody>
                     <a:bodyPr/>
@@ -8942,7 +11207,7 @@
                   </a:tcPr>
                 </a:tc>
               </a:tr>
-              <a:tr h="566928">
+              <a:tr h="530352">
                 <a:tc>
                   <a:txBody>
                     <a:bodyPr/>
@@ -9018,7 +11283,7 @@
                   </a:tcPr>
                 </a:tc>
               </a:tr>
-              <a:tr h="566928">
+              <a:tr h="530352">
                 <a:tc>
                   <a:txBody>
                     <a:bodyPr/>
@@ -9094,7 +11359,7 @@
                   </a:tcPr>
                 </a:tc>
               </a:tr>
-              <a:tr h="566928">
+              <a:tr h="530352">
                 <a:tc>
                   <a:txBody>
                     <a:bodyPr/>
@@ -9170,7 +11435,7 @@
                   </a:tcPr>
                 </a:tc>
               </a:tr>
-              <a:tr h="566928">
+              <a:tr h="530352">
                 <a:tc>
                   <a:txBody>
                     <a:bodyPr/>
@@ -9246,7 +11511,7 @@
                   </a:tcPr>
                 </a:tc>
               </a:tr>
-              <a:tr h="566928">
+              <a:tr h="530352">
                 <a:tc>
                   <a:txBody>
                     <a:bodyPr/>
@@ -9322,7 +11587,7 @@
                   </a:tcPr>
                 </a:tc>
               </a:tr>
-              <a:tr h="566928">
+              <a:tr h="530352">
                 <a:tc>
                   <a:txBody>
                     <a:bodyPr/>
@@ -9337,7 +11602,7 @@
                             <a:schemeClr val="tx1"/>
                           </a:solidFill>
                         </a:rPr>
-                        <a:t>Extra check</a:t>
+                        <a:t>World Bank</a:t>
                       </a:r>
                       <a:endParaRPr lang="en-US" sz="1600" dirty="0"/>
                     </a:p>
@@ -9374,6 +11639,82 @@
                             <a:schemeClr val="tx1"/>
                           </a:solidFill>
                         </a:rPr>
+                        <a:t>Six WDI series from the paper (GDP, GDP per capita, growth, population, land area), year before each Games</a:t>
+                      </a:r>
+                      <a:endParaRPr lang="en-US" sz="1600" dirty="0"/>
+                    </a:p>
+                  </a:txBody>
+                  <a:tcPr marL="137160" marR="137160" marT="0" marB="0" anchor="ctr">
+                    <a:lnL w="0" cap="flat" cmpd="sng" algn="ctr">
+                      <a:noFill/>
+                    </a:lnL>
+                    <a:lnR w="0" cap="flat" cmpd="sng" algn="ctr">
+                      <a:noFill/>
+                    </a:lnR>
+                    <a:lnT w="0" cap="flat" cmpd="sng" algn="ctr">
+                      <a:noFill/>
+                    </a:lnT>
+                    <a:lnB w="0" cap="flat" cmpd="sng" algn="ctr">
+                      <a:noFill/>
+                    </a:lnB>
+                    <a:solidFill>
+                      <a:srgbClr val="EDF0F3"/>
+                    </a:solidFill>
+                  </a:tcPr>
+                </a:tc>
+              </a:tr>
+              <a:tr h="530352">
+                <a:tc>
+                  <a:txBody>
+                    <a:bodyPr/>
+                    <a:lstStyle/>
+                    <a:p>
+                      <a:pPr indent="0" marL="0">
+                        <a:buNone/>
+                      </a:pPr>
+                      <a:r>
+                        <a:rPr lang="en-US" sz="1600" b="1" dirty="0">
+                          <a:solidFill>
+                            <a:schemeClr val="tx1"/>
+                          </a:solidFill>
+                        </a:rPr>
+                        <a:t>Extra check</a:t>
+                      </a:r>
+                      <a:endParaRPr lang="en-US" sz="1600" dirty="0"/>
+                    </a:p>
+                  </a:txBody>
+                  <a:tcPr marL="137160" marR="137160" marT="0" marB="0" anchor="ctr">
+                    <a:lnL w="0" cap="flat" cmpd="sng" algn="ctr">
+                      <a:noFill/>
+                    </a:lnL>
+                    <a:lnR w="0" cap="flat" cmpd="sng" algn="ctr">
+                      <a:noFill/>
+                    </a:lnR>
+                    <a:lnT w="0" cap="flat" cmpd="sng" algn="ctr">
+                      <a:noFill/>
+                    </a:lnT>
+                    <a:lnB w="0" cap="flat" cmpd="sng" algn="ctr">
+                      <a:noFill/>
+                    </a:lnB>
+                    <a:solidFill>
+                      <a:srgbClr val="FFFFFF"/>
+                    </a:solidFill>
+                  </a:tcPr>
+                </a:tc>
+                <a:tc>
+                  <a:txBody>
+                    <a:bodyPr/>
+                    <a:lstStyle/>
+                    <a:p>
+                      <a:pPr indent="0" marL="0">
+                        <a:buNone/>
+                      </a:pPr>
+                      <a:r>
+                        <a:rPr lang="en-US" sz="1600" dirty="0">
+                          <a:solidFill>
+                            <a:schemeClr val="tx1"/>
+                          </a:solidFill>
+                        </a:rPr>
                         <a:t>Real Tokyo 2020 medal table, used only to score our 2020 forecast</a:t>
                       </a:r>
                       <a:endParaRPr lang="en-US" sz="1600" dirty="0"/>
@@ -9393,7 +11734,7 @@
                       <a:noFill/>
                     </a:lnB>
                     <a:solidFill>
-                      <a:srgbClr val="EDF0F3"/>
+                      <a:srgbClr val="FFFFFF"/>
                     </a:solidFill>
                   </a:tcPr>
                 </a:tc>
@@ -9812,7 +12153,7 @@
                   <a:schemeClr val="tx1"/>
                 </a:solidFill>
               </a:rPr>
-              <a:t>Olympic history only: fully reproducible from one public dataset</a:t>
+              <a:t>Same World Bank indicators, plus Olympic history, all from before the Games</a:t>
             </a:r>
             <a:endParaRPr lang="en-US" sz="1700" dirty="0"/>
           </a:p>
@@ -9830,7 +12171,7 @@
                   <a:schemeClr val="tx1"/>
                 </a:solidFill>
               </a:rPr>
-              <a:t>Same Random Forest for all six models; only features and target change</a:t>
+              <a:t>Same Random Forest for all eight models; the paper's model types re-run too</a:t>
             </a:r>
             <a:endParaRPr lang="en-US" sz="1700" dirty="0"/>
           </a:p>
@@ -11387,7 +13728,7 @@
                   <a:schemeClr val="accent6"/>
                 </a:solidFill>
               </a:rPr>
-              <a:t>Medal_Efficiency, Medal_Growth and Athlete_Growth are also the three components of the Performance Momentum score.</a:t>
+              <a:t>Plus eight World Bank features from the year before: log GDP, log GDP per capita, GDP growth, log population, population growth, log land area, and shares of world GDP and population.</a:t>
             </a:r>
             <a:endParaRPr lang="en-US" sz="1500" dirty="0"/>
           </a:p>
@@ -12470,7 +14811,7 @@
                   <a:schemeClr val="tx1"/>
                 </a:solidFill>
               </a:rPr>
-              <a:t>Six models, one forest</a:t>
+              <a:t>Eight models, one forest</a:t>
             </a:r>
             <a:endParaRPr lang="en-US" sz="1800" dirty="0"/>
           </a:p>
@@ -12506,7 +14847,7 @@
                   <a:schemeClr val="accent6"/>
                 </a:solidFill>
               </a:rPr>
-              <a:t>Baseline, Historical, Historical + Score, Paper Two-Stage, Momentum Target, Momentum Target + Score</a:t>
+              <a:t>Count target: Baseline, Historical, + Score, + Economic, Paper Two-Stage. Momentum target: alone, + Score, + Economic</a:t>
             </a:r>
             <a:endParaRPr lang="en-US" sz="1500" dirty="0"/>
           </a:p>
@@ -12857,7 +15198,7 @@
                 <a:gridCol w="685800"/>
                 <a:gridCol w="685800"/>
               </a:tblGrid>
-              <a:tr h="384048">
+              <a:tr h="329184">
                 <a:tc>
                   <a:txBody>
                     <a:bodyPr/>
@@ -12867,14 +15208,14 @@
                         <a:buNone/>
                       </a:pPr>
                       <a:r>
-                        <a:rPr lang="en-US" sz="1200" b="1" dirty="0">
+                        <a:rPr lang="en-US" sz="1100" b="1" dirty="0">
                           <a:solidFill>
                             <a:schemeClr val="bg1"/>
                           </a:solidFill>
                         </a:rPr>
                         <a:t>Model</a:t>
                       </a:r>
-                      <a:endParaRPr lang="en-US" sz="1200" dirty="0"/>
+                      <a:endParaRPr lang="en-US" sz="1100" dirty="0"/>
                     </a:p>
                   </a:txBody>
                   <a:tcPr marL="54864" marR="54864" marT="0" marB="0" anchor="ctr">
@@ -12928,14 +15269,14 @@
                         <a:buNone/>
                       </a:pPr>
                       <a:r>
-                        <a:rPr lang="en-US" sz="1200" b="1" dirty="0">
+                        <a:rPr lang="en-US" sz="1100" b="1" dirty="0">
                           <a:solidFill>
                             <a:schemeClr val="bg1"/>
                           </a:solidFill>
                         </a:rPr>
                         <a:t>MAE</a:t>
                       </a:r>
-                      <a:endParaRPr lang="en-US" sz="1200" dirty="0"/>
+                      <a:endParaRPr lang="en-US" sz="1100" dirty="0"/>
                     </a:p>
                   </a:txBody>
                   <a:tcPr marL="54864" marR="54864" marT="0" marB="0" anchor="ctr">
@@ -12989,14 +15330,14 @@
                         <a:buNone/>
                       </a:pPr>
                       <a:r>
-                        <a:rPr lang="en-US" sz="1200" b="1" dirty="0">
+                        <a:rPr lang="en-US" sz="1100" b="1" dirty="0">
                           <a:solidFill>
                             <a:schemeClr val="bg1"/>
                           </a:solidFill>
                         </a:rPr>
                         <a:t>RMSE</a:t>
                       </a:r>
-                      <a:endParaRPr lang="en-US" sz="1200" dirty="0"/>
+                      <a:endParaRPr lang="en-US" sz="1100" dirty="0"/>
                     </a:p>
                   </a:txBody>
                   <a:tcPr marL="54864" marR="54864" marT="0" marB="0" anchor="ctr">
@@ -13050,14 +15391,14 @@
                         <a:buNone/>
                       </a:pPr>
                       <a:r>
-                        <a:rPr lang="en-US" sz="1200" b="1" dirty="0">
+                        <a:rPr lang="en-US" sz="1100" b="1" dirty="0">
                           <a:solidFill>
                             <a:schemeClr val="bg1"/>
                           </a:solidFill>
                         </a:rPr>
                         <a:t>R²</a:t>
                       </a:r>
-                      <a:endParaRPr lang="en-US" sz="1200" dirty="0"/>
+                      <a:endParaRPr lang="en-US" sz="1100" dirty="0"/>
                     </a:p>
                   </a:txBody>
                   <a:tcPr marL="54864" marR="54864" marT="0" marB="0" anchor="ctr">
@@ -13111,14 +15452,14 @@
                         <a:buNone/>
                       </a:pPr>
                       <a:r>
-                        <a:rPr lang="en-US" sz="1200" b="1" dirty="0">
+                        <a:rPr lang="en-US" sz="1100" b="1" dirty="0">
                           <a:solidFill>
                             <a:schemeClr val="bg1"/>
                           </a:solidFill>
                         </a:rPr>
                         <a:t>Top-10</a:t>
                       </a:r>
-                      <a:endParaRPr lang="en-US" sz="1200" dirty="0"/>
+                      <a:endParaRPr lang="en-US" sz="1100" dirty="0"/>
                     </a:p>
                   </a:txBody>
                   <a:tcPr marL="54864" marR="54864" marT="0" marB="0" anchor="ctr">
@@ -13164,7 +15505,7 @@
                   </a:tcPr>
                 </a:tc>
               </a:tr>
-              <a:tr h="384048">
+              <a:tr h="329184">
                 <a:tc>
                   <a:txBody>
                     <a:bodyPr/>
@@ -13174,14 +15515,14 @@
                         <a:buNone/>
                       </a:pPr>
                       <a:r>
-                        <a:rPr lang="en-US" sz="1200" dirty="0">
+                        <a:rPr lang="en-US" sz="1100" dirty="0">
                           <a:solidFill>
                             <a:schemeClr val="tx1"/>
                           </a:solidFill>
                         </a:rPr>
                         <a:t>Baseline</a:t>
                       </a:r>
-                      <a:endParaRPr lang="en-US" sz="1200" dirty="0"/>
+                      <a:endParaRPr lang="en-US" sz="1100" dirty="0"/>
                     </a:p>
                   </a:txBody>
                   <a:tcPr marL="54864" marR="54864" marT="0" marB="0" anchor="ctr">
@@ -13235,14 +15576,14 @@
                         <a:buNone/>
                       </a:pPr>
                       <a:r>
-                        <a:rPr lang="en-US" sz="1200" dirty="0">
+                        <a:rPr lang="en-US" sz="1100" dirty="0">
                           <a:solidFill>
                             <a:schemeClr val="tx1"/>
                           </a:solidFill>
                         </a:rPr>
                         <a:t>1.606</a:t>
                       </a:r>
-                      <a:endParaRPr lang="en-US" sz="1200" dirty="0"/>
+                      <a:endParaRPr lang="en-US" sz="1100" dirty="0"/>
                     </a:p>
                   </a:txBody>
                   <a:tcPr marL="54864" marR="54864" marT="0" marB="0" anchor="ctr">
@@ -13296,14 +15637,14 @@
                         <a:buNone/>
                       </a:pPr>
                       <a:r>
-                        <a:rPr lang="en-US" sz="1200" dirty="0">
+                        <a:rPr lang="en-US" sz="1100" dirty="0">
                           <a:solidFill>
                             <a:schemeClr val="tx1"/>
                           </a:solidFill>
                         </a:rPr>
                         <a:t>3.85</a:t>
                       </a:r>
-                      <a:endParaRPr lang="en-US" sz="1200" dirty="0"/>
+                      <a:endParaRPr lang="en-US" sz="1100" dirty="0"/>
                     </a:p>
                   </a:txBody>
                   <a:tcPr marL="54864" marR="54864" marT="0" marB="0" anchor="ctr">
@@ -13357,14 +15698,14 @@
                         <a:buNone/>
                       </a:pPr>
                       <a:r>
-                        <a:rPr lang="en-US" sz="1200" dirty="0">
+                        <a:rPr lang="en-US" sz="1100" dirty="0">
                           <a:solidFill>
                             <a:schemeClr val="tx1"/>
                           </a:solidFill>
                         </a:rPr>
                         <a:t>0.913</a:t>
                       </a:r>
-                      <a:endParaRPr lang="en-US" sz="1200" dirty="0"/>
+                      <a:endParaRPr lang="en-US" sz="1100" dirty="0"/>
                     </a:p>
                   </a:txBody>
                   <a:tcPr marL="54864" marR="54864" marT="0" marB="0" anchor="ctr">
@@ -13418,14 +15759,14 @@
                         <a:buNone/>
                       </a:pPr>
                       <a:r>
-                        <a:rPr lang="en-US" sz="1200" dirty="0">
+                        <a:rPr lang="en-US" sz="1100" dirty="0">
                           <a:solidFill>
                             <a:schemeClr val="tx1"/>
                           </a:solidFill>
                         </a:rPr>
                         <a:t>12.26</a:t>
                       </a:r>
-                      <a:endParaRPr lang="en-US" sz="1200" dirty="0"/>
+                      <a:endParaRPr lang="en-US" sz="1100" dirty="0"/>
                     </a:p>
                   </a:txBody>
                   <a:tcPr marL="54864" marR="54864" marT="0" marB="0" anchor="ctr">
@@ -13471,7 +15812,7 @@
                   </a:tcPr>
                 </a:tc>
               </a:tr>
-              <a:tr h="384048">
+              <a:tr h="329184">
                 <a:tc>
                   <a:txBody>
                     <a:bodyPr/>
@@ -13481,14 +15822,14 @@
                         <a:buNone/>
                       </a:pPr>
                       <a:r>
-                        <a:rPr lang="en-US" sz="1200" dirty="0">
+                        <a:rPr lang="en-US" sz="1100" dirty="0">
                           <a:solidFill>
                             <a:schemeClr val="tx1"/>
                           </a:solidFill>
                         </a:rPr>
                         <a:t>Historical</a:t>
                       </a:r>
-                      <a:endParaRPr lang="en-US" sz="1200" dirty="0"/>
+                      <a:endParaRPr lang="en-US" sz="1100" dirty="0"/>
                     </a:p>
                   </a:txBody>
                   <a:tcPr marL="54864" marR="54864" marT="0" marB="0" anchor="ctr">
@@ -13542,14 +15883,14 @@
                         <a:buNone/>
                       </a:pPr>
                       <a:r>
-                        <a:rPr lang="en-US" sz="1200" dirty="0">
+                        <a:rPr lang="en-US" sz="1100" dirty="0">
                           <a:solidFill>
                             <a:schemeClr val="tx1"/>
                           </a:solidFill>
                         </a:rPr>
                         <a:t>1.474</a:t>
                       </a:r>
-                      <a:endParaRPr lang="en-US" sz="1200" dirty="0"/>
+                      <a:endParaRPr lang="en-US" sz="1100" dirty="0"/>
                     </a:p>
                   </a:txBody>
                   <a:tcPr marL="54864" marR="54864" marT="0" marB="0" anchor="ctr">
@@ -13603,14 +15944,14 @@
                         <a:buNone/>
                       </a:pPr>
                       <a:r>
-                        <a:rPr lang="en-US" sz="1200" dirty="0">
+                        <a:rPr lang="en-US" sz="1100" dirty="0">
                           <a:solidFill>
                             <a:schemeClr val="tx1"/>
                           </a:solidFill>
                         </a:rPr>
                         <a:t>3.76</a:t>
                       </a:r>
-                      <a:endParaRPr lang="en-US" sz="1200" dirty="0"/>
+                      <a:endParaRPr lang="en-US" sz="1100" dirty="0"/>
                     </a:p>
                   </a:txBody>
                   <a:tcPr marL="54864" marR="54864" marT="0" marB="0" anchor="ctr">
@@ -13664,14 +16005,14 @@
                         <a:buNone/>
                       </a:pPr>
                       <a:r>
-                        <a:rPr lang="en-US" sz="1200" dirty="0">
+                        <a:rPr lang="en-US" sz="1100" dirty="0">
                           <a:solidFill>
                             <a:schemeClr val="tx1"/>
                           </a:solidFill>
                         </a:rPr>
                         <a:t>0.916</a:t>
                       </a:r>
-                      <a:endParaRPr lang="en-US" sz="1200" dirty="0"/>
+                      <a:endParaRPr lang="en-US" sz="1100" dirty="0"/>
                     </a:p>
                   </a:txBody>
                   <a:tcPr marL="54864" marR="54864" marT="0" marB="0" anchor="ctr">
@@ -13725,14 +16066,14 @@
                         <a:buNone/>
                       </a:pPr>
                       <a:r>
-                        <a:rPr lang="en-US" sz="1200" dirty="0">
+                        <a:rPr lang="en-US" sz="1100" dirty="0">
                           <a:solidFill>
                             <a:schemeClr val="tx1"/>
                           </a:solidFill>
                         </a:rPr>
                         <a:t>11.91</a:t>
                       </a:r>
-                      <a:endParaRPr lang="en-US" sz="1200" dirty="0"/>
+                      <a:endParaRPr lang="en-US" sz="1100" dirty="0"/>
                     </a:p>
                   </a:txBody>
                   <a:tcPr marL="54864" marR="54864" marT="0" marB="0" anchor="ctr">
@@ -13778,7 +16119,7 @@
                   </a:tcPr>
                 </a:tc>
               </a:tr>
-              <a:tr h="384048">
+              <a:tr h="329184">
                 <a:tc>
                   <a:txBody>
                     <a:bodyPr/>
@@ -13788,14 +16129,14 @@
                         <a:buNone/>
                       </a:pPr>
                       <a:r>
-                        <a:rPr lang="en-US" sz="1200" dirty="0">
+                        <a:rPr lang="en-US" sz="1100" dirty="0">
                           <a:solidFill>
                             <a:schemeClr val="tx1"/>
                           </a:solidFill>
                         </a:rPr>
                         <a:t>Hist. + Score</a:t>
                       </a:r>
-                      <a:endParaRPr lang="en-US" sz="1200" dirty="0"/>
+                      <a:endParaRPr lang="en-US" sz="1100" dirty="0"/>
                     </a:p>
                   </a:txBody>
                   <a:tcPr marL="54864" marR="54864" marT="0" marB="0" anchor="ctr">
@@ -13849,14 +16190,14 @@
                         <a:buNone/>
                       </a:pPr>
                       <a:r>
-                        <a:rPr lang="en-US" sz="1200" dirty="0">
+                        <a:rPr lang="en-US" sz="1100" dirty="0">
                           <a:solidFill>
                             <a:schemeClr val="tx1"/>
                           </a:solidFill>
                         </a:rPr>
                         <a:t>1.501</a:t>
                       </a:r>
-                      <a:endParaRPr lang="en-US" sz="1200" dirty="0"/>
+                      <a:endParaRPr lang="en-US" sz="1100" dirty="0"/>
                     </a:p>
                   </a:txBody>
                   <a:tcPr marL="54864" marR="54864" marT="0" marB="0" anchor="ctr">
@@ -13910,14 +16251,14 @@
                         <a:buNone/>
                       </a:pPr>
                       <a:r>
-                        <a:rPr lang="en-US" sz="1200" dirty="0">
+                        <a:rPr lang="en-US" sz="1100" dirty="0">
                           <a:solidFill>
                             <a:schemeClr val="tx1"/>
                           </a:solidFill>
                         </a:rPr>
                         <a:t>3.81</a:t>
                       </a:r>
-                      <a:endParaRPr lang="en-US" sz="1200" dirty="0"/>
+                      <a:endParaRPr lang="en-US" sz="1100" dirty="0"/>
                     </a:p>
                   </a:txBody>
                   <a:tcPr marL="54864" marR="54864" marT="0" marB="0" anchor="ctr">
@@ -13971,14 +16312,14 @@
                         <a:buNone/>
                       </a:pPr>
                       <a:r>
-                        <a:rPr lang="en-US" sz="1200" dirty="0">
+                        <a:rPr lang="en-US" sz="1100" dirty="0">
                           <a:solidFill>
                             <a:schemeClr val="tx1"/>
                           </a:solidFill>
                         </a:rPr>
                         <a:t>0.914</a:t>
                       </a:r>
-                      <a:endParaRPr lang="en-US" sz="1200" dirty="0"/>
+                      <a:endParaRPr lang="en-US" sz="1100" dirty="0"/>
                     </a:p>
                   </a:txBody>
                   <a:tcPr marL="54864" marR="54864" marT="0" marB="0" anchor="ctr">
@@ -14032,14 +16373,14 @@
                         <a:buNone/>
                       </a:pPr>
                       <a:r>
-                        <a:rPr lang="en-US" sz="1200" dirty="0">
+                        <a:rPr lang="en-US" sz="1100" dirty="0">
                           <a:solidFill>
                             <a:schemeClr val="tx1"/>
                           </a:solidFill>
                         </a:rPr>
                         <a:t>12.26</a:t>
                       </a:r>
-                      <a:endParaRPr lang="en-US" sz="1200" dirty="0"/>
+                      <a:endParaRPr lang="en-US" sz="1100" dirty="0"/>
                     </a:p>
                   </a:txBody>
                   <a:tcPr marL="54864" marR="54864" marT="0" marB="0" anchor="ctr">
@@ -14085,7 +16426,7 @@
                   </a:tcPr>
                 </a:tc>
               </a:tr>
-              <a:tr h="384048">
+              <a:tr h="329184">
                 <a:tc>
                   <a:txBody>
                     <a:bodyPr/>
@@ -14095,14 +16436,14 @@
                         <a:buNone/>
                       </a:pPr>
                       <a:r>
-                        <a:rPr lang="en-US" sz="1200" dirty="0">
+                        <a:rPr lang="en-US" sz="1100" dirty="0">
                           <a:solidFill>
                             <a:schemeClr val="tx1"/>
                           </a:solidFill>
                         </a:rPr>
-                        <a:t>Two-Stage</a:t>
+                        <a:t>Hist. + Economic</a:t>
                       </a:r>
-                      <a:endParaRPr lang="en-US" sz="1200" dirty="0"/>
+                      <a:endParaRPr lang="en-US" sz="1100" dirty="0"/>
                     </a:p>
                   </a:txBody>
                   <a:tcPr marL="54864" marR="54864" marT="0" marB="0" anchor="ctr">
@@ -14156,14 +16497,14 @@
                         <a:buNone/>
                       </a:pPr>
                       <a:r>
-                        <a:rPr lang="en-US" sz="1200" dirty="0">
+                        <a:rPr lang="en-US" sz="1100" dirty="0">
                           <a:solidFill>
                             <a:schemeClr val="tx1"/>
                           </a:solidFill>
                         </a:rPr>
-                        <a:t>1.490</a:t>
+                        <a:t>1.461</a:t>
                       </a:r>
-                      <a:endParaRPr lang="en-US" sz="1200" dirty="0"/>
+                      <a:endParaRPr lang="en-US" sz="1100" dirty="0"/>
                     </a:p>
                   </a:txBody>
                   <a:tcPr marL="54864" marR="54864" marT="0" marB="0" anchor="ctr">
@@ -14217,14 +16558,14 @@
                         <a:buNone/>
                       </a:pPr>
                       <a:r>
-                        <a:rPr lang="en-US" sz="1200" dirty="0">
+                        <a:rPr lang="en-US" sz="1100" dirty="0">
                           <a:solidFill>
                             <a:schemeClr val="tx1"/>
                           </a:solidFill>
                         </a:rPr>
-                        <a:t>3.92</a:t>
+                        <a:t>3.68</a:t>
                       </a:r>
-                      <a:endParaRPr lang="en-US" sz="1200" dirty="0"/>
+                      <a:endParaRPr lang="en-US" sz="1100" dirty="0"/>
                     </a:p>
                   </a:txBody>
                   <a:tcPr marL="54864" marR="54864" marT="0" marB="0" anchor="ctr">
@@ -14278,14 +16619,14 @@
                         <a:buNone/>
                       </a:pPr>
                       <a:r>
-                        <a:rPr lang="en-US" sz="1200" dirty="0">
+                        <a:rPr lang="en-US" sz="1100" dirty="0">
                           <a:solidFill>
                             <a:schemeClr val="tx1"/>
                           </a:solidFill>
                         </a:rPr>
-                        <a:t>0.909</a:t>
+                        <a:t>0.920</a:t>
                       </a:r>
-                      <a:endParaRPr lang="en-US" sz="1200" dirty="0"/>
+                      <a:endParaRPr lang="en-US" sz="1100" dirty="0"/>
                     </a:p>
                   </a:txBody>
                   <a:tcPr marL="54864" marR="54864" marT="0" marB="0" anchor="ctr">
@@ -14339,14 +16680,14 @@
                         <a:buNone/>
                       </a:pPr>
                       <a:r>
-                        <a:rPr lang="en-US" sz="1200" dirty="0">
+                        <a:rPr lang="en-US" sz="1100" dirty="0">
                           <a:solidFill>
                             <a:schemeClr val="tx1"/>
                           </a:solidFill>
                         </a:rPr>
-                        <a:t>12.29</a:t>
+                        <a:t>11.07</a:t>
                       </a:r>
-                      <a:endParaRPr lang="en-US" sz="1200" dirty="0"/>
+                      <a:endParaRPr lang="en-US" sz="1100" dirty="0"/>
                     </a:p>
                   </a:txBody>
                   <a:tcPr marL="54864" marR="54864" marT="0" marB="0" anchor="ctr">
@@ -14392,7 +16733,7 @@
                   </a:tcPr>
                 </a:tc>
               </a:tr>
-              <a:tr h="384048">
+              <a:tr h="329184">
                 <a:tc>
                   <a:txBody>
                     <a:bodyPr/>
@@ -14402,14 +16743,321 @@
                         <a:buNone/>
                       </a:pPr>
                       <a:r>
-                        <a:rPr lang="en-US" sz="1200" b="1" dirty="0">
+                        <a:rPr lang="en-US" sz="1100" dirty="0">
+                          <a:solidFill>
+                            <a:schemeClr val="tx1"/>
+                          </a:solidFill>
+                        </a:rPr>
+                        <a:t>Two-Stage</a:t>
+                      </a:r>
+                      <a:endParaRPr lang="en-US" sz="1100" dirty="0"/>
+                    </a:p>
+                  </a:txBody>
+                  <a:tcPr marL="54864" marR="54864" marT="0" marB="0" anchor="ctr">
+                    <a:lnL w="6350" cap="flat" cmpd="sng" algn="ctr">
+                      <a:solidFill>
+                        <a:srgbClr val="D3DAE3"/>
+                      </a:solidFill>
+                      <a:prstDash val="solid"/>
+                      <a:round/>
+                      <a:headEnd type="none" w="med" len="med"/>
+                      <a:tailEnd type="none" w="med" len="med"/>
+                    </a:lnL>
+                    <a:lnR w="6350" cap="flat" cmpd="sng" algn="ctr">
+                      <a:solidFill>
+                        <a:srgbClr val="D3DAE3"/>
+                      </a:solidFill>
+                      <a:prstDash val="solid"/>
+                      <a:round/>
+                      <a:headEnd type="none" w="med" len="med"/>
+                      <a:tailEnd type="none" w="med" len="med"/>
+                    </a:lnR>
+                    <a:lnT w="6350" cap="flat" cmpd="sng" algn="ctr">
+                      <a:solidFill>
+                        <a:srgbClr val="D3DAE3"/>
+                      </a:solidFill>
+                      <a:prstDash val="solid"/>
+                      <a:round/>
+                      <a:headEnd type="none" w="med" len="med"/>
+                      <a:tailEnd type="none" w="med" len="med"/>
+                    </a:lnT>
+                    <a:lnB w="6350" cap="flat" cmpd="sng" algn="ctr">
+                      <a:solidFill>
+                        <a:srgbClr val="D3DAE3"/>
+                      </a:solidFill>
+                      <a:prstDash val="solid"/>
+                      <a:round/>
+                      <a:headEnd type="none" w="med" len="med"/>
+                      <a:tailEnd type="none" w="med" len="med"/>
+                    </a:lnB>
+                    <a:solidFill>
+                      <a:srgbClr val="FFFFFF"/>
+                    </a:solidFill>
+                  </a:tcPr>
+                </a:tc>
+                <a:tc>
+                  <a:txBody>
+                    <a:bodyPr/>
+                    <a:lstStyle/>
+                    <a:p>
+                      <a:pPr algn="l" indent="0" marL="0">
+                        <a:buNone/>
+                      </a:pPr>
+                      <a:r>
+                        <a:rPr lang="en-US" sz="1100" dirty="0">
+                          <a:solidFill>
+                            <a:schemeClr val="tx1"/>
+                          </a:solidFill>
+                        </a:rPr>
+                        <a:t>1.442</a:t>
+                      </a:r>
+                      <a:endParaRPr lang="en-US" sz="1100" dirty="0"/>
+                    </a:p>
+                  </a:txBody>
+                  <a:tcPr marL="54864" marR="54864" marT="0" marB="0" anchor="ctr">
+                    <a:lnL w="6350" cap="flat" cmpd="sng" algn="ctr">
+                      <a:solidFill>
+                        <a:srgbClr val="D3DAE3"/>
+                      </a:solidFill>
+                      <a:prstDash val="solid"/>
+                      <a:round/>
+                      <a:headEnd type="none" w="med" len="med"/>
+                      <a:tailEnd type="none" w="med" len="med"/>
+                    </a:lnL>
+                    <a:lnR w="6350" cap="flat" cmpd="sng" algn="ctr">
+                      <a:solidFill>
+                        <a:srgbClr val="D3DAE3"/>
+                      </a:solidFill>
+                      <a:prstDash val="solid"/>
+                      <a:round/>
+                      <a:headEnd type="none" w="med" len="med"/>
+                      <a:tailEnd type="none" w="med" len="med"/>
+                    </a:lnR>
+                    <a:lnT w="6350" cap="flat" cmpd="sng" algn="ctr">
+                      <a:solidFill>
+                        <a:srgbClr val="D3DAE3"/>
+                      </a:solidFill>
+                      <a:prstDash val="solid"/>
+                      <a:round/>
+                      <a:headEnd type="none" w="med" len="med"/>
+                      <a:tailEnd type="none" w="med" len="med"/>
+                    </a:lnT>
+                    <a:lnB w="6350" cap="flat" cmpd="sng" algn="ctr">
+                      <a:solidFill>
+                        <a:srgbClr val="D3DAE3"/>
+                      </a:solidFill>
+                      <a:prstDash val="solid"/>
+                      <a:round/>
+                      <a:headEnd type="none" w="med" len="med"/>
+                      <a:tailEnd type="none" w="med" len="med"/>
+                    </a:lnB>
+                    <a:solidFill>
+                      <a:srgbClr val="FFFFFF"/>
+                    </a:solidFill>
+                  </a:tcPr>
+                </a:tc>
+                <a:tc>
+                  <a:txBody>
+                    <a:bodyPr/>
+                    <a:lstStyle/>
+                    <a:p>
+                      <a:pPr algn="l" indent="0" marL="0">
+                        <a:buNone/>
+                      </a:pPr>
+                      <a:r>
+                        <a:rPr lang="en-US" sz="1100" dirty="0">
+                          <a:solidFill>
+                            <a:schemeClr val="tx1"/>
+                          </a:solidFill>
+                        </a:rPr>
+                        <a:t>3.75</a:t>
+                      </a:r>
+                      <a:endParaRPr lang="en-US" sz="1100" dirty="0"/>
+                    </a:p>
+                  </a:txBody>
+                  <a:tcPr marL="54864" marR="54864" marT="0" marB="0" anchor="ctr">
+                    <a:lnL w="6350" cap="flat" cmpd="sng" algn="ctr">
+                      <a:solidFill>
+                        <a:srgbClr val="D3DAE3"/>
+                      </a:solidFill>
+                      <a:prstDash val="solid"/>
+                      <a:round/>
+                      <a:headEnd type="none" w="med" len="med"/>
+                      <a:tailEnd type="none" w="med" len="med"/>
+                    </a:lnL>
+                    <a:lnR w="6350" cap="flat" cmpd="sng" algn="ctr">
+                      <a:solidFill>
+                        <a:srgbClr val="D3DAE3"/>
+                      </a:solidFill>
+                      <a:prstDash val="solid"/>
+                      <a:round/>
+                      <a:headEnd type="none" w="med" len="med"/>
+                      <a:tailEnd type="none" w="med" len="med"/>
+                    </a:lnR>
+                    <a:lnT w="6350" cap="flat" cmpd="sng" algn="ctr">
+                      <a:solidFill>
+                        <a:srgbClr val="D3DAE3"/>
+                      </a:solidFill>
+                      <a:prstDash val="solid"/>
+                      <a:round/>
+                      <a:headEnd type="none" w="med" len="med"/>
+                      <a:tailEnd type="none" w="med" len="med"/>
+                    </a:lnT>
+                    <a:lnB w="6350" cap="flat" cmpd="sng" algn="ctr">
+                      <a:solidFill>
+                        <a:srgbClr val="D3DAE3"/>
+                      </a:solidFill>
+                      <a:prstDash val="solid"/>
+                      <a:round/>
+                      <a:headEnd type="none" w="med" len="med"/>
+                      <a:tailEnd type="none" w="med" len="med"/>
+                    </a:lnB>
+                    <a:solidFill>
+                      <a:srgbClr val="FFFFFF"/>
+                    </a:solidFill>
+                  </a:tcPr>
+                </a:tc>
+                <a:tc>
+                  <a:txBody>
+                    <a:bodyPr/>
+                    <a:lstStyle/>
+                    <a:p>
+                      <a:pPr algn="l" indent="0" marL="0">
+                        <a:buNone/>
+                      </a:pPr>
+                      <a:r>
+                        <a:rPr lang="en-US" sz="1100" dirty="0">
+                          <a:solidFill>
+                            <a:schemeClr val="tx1"/>
+                          </a:solidFill>
+                        </a:rPr>
+                        <a:t>0.917</a:t>
+                      </a:r>
+                      <a:endParaRPr lang="en-US" sz="1100" dirty="0"/>
+                    </a:p>
+                  </a:txBody>
+                  <a:tcPr marL="54864" marR="54864" marT="0" marB="0" anchor="ctr">
+                    <a:lnL w="6350" cap="flat" cmpd="sng" algn="ctr">
+                      <a:solidFill>
+                        <a:srgbClr val="D3DAE3"/>
+                      </a:solidFill>
+                      <a:prstDash val="solid"/>
+                      <a:round/>
+                      <a:headEnd type="none" w="med" len="med"/>
+                      <a:tailEnd type="none" w="med" len="med"/>
+                    </a:lnL>
+                    <a:lnR w="6350" cap="flat" cmpd="sng" algn="ctr">
+                      <a:solidFill>
+                        <a:srgbClr val="D3DAE3"/>
+                      </a:solidFill>
+                      <a:prstDash val="solid"/>
+                      <a:round/>
+                      <a:headEnd type="none" w="med" len="med"/>
+                      <a:tailEnd type="none" w="med" len="med"/>
+                    </a:lnR>
+                    <a:lnT w="6350" cap="flat" cmpd="sng" algn="ctr">
+                      <a:solidFill>
+                        <a:srgbClr val="D3DAE3"/>
+                      </a:solidFill>
+                      <a:prstDash val="solid"/>
+                      <a:round/>
+                      <a:headEnd type="none" w="med" len="med"/>
+                      <a:tailEnd type="none" w="med" len="med"/>
+                    </a:lnT>
+                    <a:lnB w="6350" cap="flat" cmpd="sng" algn="ctr">
+                      <a:solidFill>
+                        <a:srgbClr val="D3DAE3"/>
+                      </a:solidFill>
+                      <a:prstDash val="solid"/>
+                      <a:round/>
+                      <a:headEnd type="none" w="med" len="med"/>
+                      <a:tailEnd type="none" w="med" len="med"/>
+                    </a:lnB>
+                    <a:solidFill>
+                      <a:srgbClr val="FFFFFF"/>
+                    </a:solidFill>
+                  </a:tcPr>
+                </a:tc>
+                <a:tc>
+                  <a:txBody>
+                    <a:bodyPr/>
+                    <a:lstStyle/>
+                    <a:p>
+                      <a:pPr algn="l" indent="0" marL="0">
+                        <a:buNone/>
+                      </a:pPr>
+                      <a:r>
+                        <a:rPr lang="en-US" sz="1100" dirty="0">
+                          <a:solidFill>
+                            <a:schemeClr val="tx1"/>
+                          </a:solidFill>
+                        </a:rPr>
+                        <a:t>11.34</a:t>
+                      </a:r>
+                      <a:endParaRPr lang="en-US" sz="1100" dirty="0"/>
+                    </a:p>
+                  </a:txBody>
+                  <a:tcPr marL="54864" marR="54864" marT="0" marB="0" anchor="ctr">
+                    <a:lnL w="6350" cap="flat" cmpd="sng" algn="ctr">
+                      <a:solidFill>
+                        <a:srgbClr val="D3DAE3"/>
+                      </a:solidFill>
+                      <a:prstDash val="solid"/>
+                      <a:round/>
+                      <a:headEnd type="none" w="med" len="med"/>
+                      <a:tailEnd type="none" w="med" len="med"/>
+                    </a:lnL>
+                    <a:lnR w="6350" cap="flat" cmpd="sng" algn="ctr">
+                      <a:solidFill>
+                        <a:srgbClr val="D3DAE3"/>
+                      </a:solidFill>
+                      <a:prstDash val="solid"/>
+                      <a:round/>
+                      <a:headEnd type="none" w="med" len="med"/>
+                      <a:tailEnd type="none" w="med" len="med"/>
+                    </a:lnR>
+                    <a:lnT w="6350" cap="flat" cmpd="sng" algn="ctr">
+                      <a:solidFill>
+                        <a:srgbClr val="D3DAE3"/>
+                      </a:solidFill>
+                      <a:prstDash val="solid"/>
+                      <a:round/>
+                      <a:headEnd type="none" w="med" len="med"/>
+                      <a:tailEnd type="none" w="med" len="med"/>
+                    </a:lnT>
+                    <a:lnB w="6350" cap="flat" cmpd="sng" algn="ctr">
+                      <a:solidFill>
+                        <a:srgbClr val="D3DAE3"/>
+                      </a:solidFill>
+                      <a:prstDash val="solid"/>
+                      <a:round/>
+                      <a:headEnd type="none" w="med" len="med"/>
+                      <a:tailEnd type="none" w="med" len="med"/>
+                    </a:lnB>
+                    <a:solidFill>
+                      <a:srgbClr val="FFFFFF"/>
+                    </a:solidFill>
+                  </a:tcPr>
+                </a:tc>
+              </a:tr>
+              <a:tr h="329184">
+                <a:tc>
+                  <a:txBody>
+                    <a:bodyPr/>
+                    <a:lstStyle/>
+                    <a:p>
+                      <a:pPr algn="l" indent="0" marL="0">
+                        <a:buNone/>
+                      </a:pPr>
+                      <a:r>
+                        <a:rPr lang="en-US" sz="1100" b="1" dirty="0">
                           <a:solidFill>
                             <a:schemeClr val="tx1"/>
                           </a:solidFill>
                         </a:rPr>
                         <a:t>Momentum Target</a:t>
                       </a:r>
-                      <a:endParaRPr lang="en-US" sz="1200" dirty="0"/>
+                      <a:endParaRPr lang="en-US" sz="1100" dirty="0"/>
                     </a:p>
                   </a:txBody>
                   <a:tcPr marL="54864" marR="54864" marT="0" marB="0" anchor="ctr">
@@ -14463,14 +17111,14 @@
                         <a:buNone/>
                       </a:pPr>
                       <a:r>
-                        <a:rPr lang="en-US" sz="1200" b="1" dirty="0">
+                        <a:rPr lang="en-US" sz="1100" b="1" dirty="0">
                           <a:solidFill>
                             <a:schemeClr val="tx1"/>
                           </a:solidFill>
                         </a:rPr>
                         <a:t>1.298</a:t>
                       </a:r>
-                      <a:endParaRPr lang="en-US" sz="1200" dirty="0"/>
+                      <a:endParaRPr lang="en-US" sz="1100" dirty="0"/>
                     </a:p>
                   </a:txBody>
                   <a:tcPr marL="54864" marR="54864" marT="0" marB="0" anchor="ctr">
@@ -14524,14 +17172,14 @@
                         <a:buNone/>
                       </a:pPr>
                       <a:r>
-                        <a:rPr lang="en-US" sz="1200" b="1" dirty="0">
+                        <a:rPr lang="en-US" sz="1100" b="1" dirty="0">
                           <a:solidFill>
                             <a:schemeClr val="tx1"/>
                           </a:solidFill>
                         </a:rPr>
                         <a:t>3.37</a:t>
                       </a:r>
-                      <a:endParaRPr lang="en-US" sz="1200" dirty="0"/>
+                      <a:endParaRPr lang="en-US" sz="1100" dirty="0"/>
                     </a:p>
                   </a:txBody>
                   <a:tcPr marL="54864" marR="54864" marT="0" marB="0" anchor="ctr">
@@ -14585,14 +17233,14 @@
                         <a:buNone/>
                       </a:pPr>
                       <a:r>
-                        <a:rPr lang="en-US" sz="1200" b="1" dirty="0">
+                        <a:rPr lang="en-US" sz="1100" b="1" dirty="0">
                           <a:solidFill>
                             <a:schemeClr val="tx1"/>
                           </a:solidFill>
                         </a:rPr>
                         <a:t>0.933</a:t>
                       </a:r>
-                      <a:endParaRPr lang="en-US" sz="1200" dirty="0"/>
+                      <a:endParaRPr lang="en-US" sz="1100" dirty="0"/>
                     </a:p>
                   </a:txBody>
                   <a:tcPr marL="54864" marR="54864" marT="0" marB="0" anchor="ctr">
@@ -14646,14 +17294,14 @@
                         <a:buNone/>
                       </a:pPr>
                       <a:r>
-                        <a:rPr lang="en-US" sz="1200" b="1" dirty="0">
+                        <a:rPr lang="en-US" sz="1100" b="1" dirty="0">
                           <a:solidFill>
                             <a:schemeClr val="tx1"/>
                           </a:solidFill>
                         </a:rPr>
                         <a:t>10.14</a:t>
                       </a:r>
-                      <a:endParaRPr lang="en-US" sz="1200" dirty="0"/>
+                      <a:endParaRPr lang="en-US" sz="1100" dirty="0"/>
                     </a:p>
                   </a:txBody>
                   <a:tcPr marL="54864" marR="54864" marT="0" marB="0" anchor="ctr">
@@ -14699,7 +17347,7 @@
                   </a:tcPr>
                 </a:tc>
               </a:tr>
-              <a:tr h="384048">
+              <a:tr h="329184">
                 <a:tc>
                   <a:txBody>
                     <a:bodyPr/>
@@ -14709,14 +17357,14 @@
                         <a:buNone/>
                       </a:pPr>
                       <a:r>
-                        <a:rPr lang="en-US" sz="1200" dirty="0">
+                        <a:rPr lang="en-US" sz="1100" dirty="0">
                           <a:solidFill>
                             <a:schemeClr val="tx1"/>
                           </a:solidFill>
                         </a:rPr>
-                        <a:t>Mom. Target + Score</a:t>
+                        <a:t>Mom. + Score</a:t>
                       </a:r>
-                      <a:endParaRPr lang="en-US" sz="1200" dirty="0"/>
+                      <a:endParaRPr lang="en-US" sz="1100" dirty="0"/>
                     </a:p>
                   </a:txBody>
                   <a:tcPr marL="54864" marR="54864" marT="0" marB="0" anchor="ctr">
@@ -14770,14 +17418,14 @@
                         <a:buNone/>
                       </a:pPr>
                       <a:r>
-                        <a:rPr lang="en-US" sz="1200" dirty="0">
+                        <a:rPr lang="en-US" sz="1100" dirty="0">
                           <a:solidFill>
                             <a:schemeClr val="tx1"/>
                           </a:solidFill>
                         </a:rPr>
                         <a:t>1.296</a:t>
                       </a:r>
-                      <a:endParaRPr lang="en-US" sz="1200" dirty="0"/>
+                      <a:endParaRPr lang="en-US" sz="1100" dirty="0"/>
                     </a:p>
                   </a:txBody>
                   <a:tcPr marL="54864" marR="54864" marT="0" marB="0" anchor="ctr">
@@ -14831,14 +17479,14 @@
                         <a:buNone/>
                       </a:pPr>
                       <a:r>
-                        <a:rPr lang="en-US" sz="1200" dirty="0">
+                        <a:rPr lang="en-US" sz="1100" dirty="0">
                           <a:solidFill>
                             <a:schemeClr val="tx1"/>
                           </a:solidFill>
                         </a:rPr>
                         <a:t>3.39</a:t>
                       </a:r>
-                      <a:endParaRPr lang="en-US" sz="1200" dirty="0"/>
+                      <a:endParaRPr lang="en-US" sz="1100" dirty="0"/>
                     </a:p>
                   </a:txBody>
                   <a:tcPr marL="54864" marR="54864" marT="0" marB="0" anchor="ctr">
@@ -14892,14 +17540,14 @@
                         <a:buNone/>
                       </a:pPr>
                       <a:r>
-                        <a:rPr lang="en-US" sz="1200" dirty="0">
+                        <a:rPr lang="en-US" sz="1100" dirty="0">
                           <a:solidFill>
                             <a:schemeClr val="tx1"/>
                           </a:solidFill>
                         </a:rPr>
                         <a:t>0.932</a:t>
                       </a:r>
-                      <a:endParaRPr lang="en-US" sz="1200" dirty="0"/>
+                      <a:endParaRPr lang="en-US" sz="1100" dirty="0"/>
                     </a:p>
                   </a:txBody>
                   <a:tcPr marL="54864" marR="54864" marT="0" marB="0" anchor="ctr">
@@ -14953,14 +17601,321 @@
                         <a:buNone/>
                       </a:pPr>
                       <a:r>
-                        <a:rPr lang="en-US" sz="1200" dirty="0">
+                        <a:rPr lang="en-US" sz="1100" dirty="0">
                           <a:solidFill>
                             <a:schemeClr val="tx1"/>
                           </a:solidFill>
                         </a:rPr>
                         <a:t>10.16</a:t>
                       </a:r>
-                      <a:endParaRPr lang="en-US" sz="1200" dirty="0"/>
+                      <a:endParaRPr lang="en-US" sz="1100" dirty="0"/>
+                    </a:p>
+                  </a:txBody>
+                  <a:tcPr marL="54864" marR="54864" marT="0" marB="0" anchor="ctr">
+                    <a:lnL w="6350" cap="flat" cmpd="sng" algn="ctr">
+                      <a:solidFill>
+                        <a:srgbClr val="D3DAE3"/>
+                      </a:solidFill>
+                      <a:prstDash val="solid"/>
+                      <a:round/>
+                      <a:headEnd type="none" w="med" len="med"/>
+                      <a:tailEnd type="none" w="med" len="med"/>
+                    </a:lnL>
+                    <a:lnR w="6350" cap="flat" cmpd="sng" algn="ctr">
+                      <a:solidFill>
+                        <a:srgbClr val="D3DAE3"/>
+                      </a:solidFill>
+                      <a:prstDash val="solid"/>
+                      <a:round/>
+                      <a:headEnd type="none" w="med" len="med"/>
+                      <a:tailEnd type="none" w="med" len="med"/>
+                    </a:lnR>
+                    <a:lnT w="6350" cap="flat" cmpd="sng" algn="ctr">
+                      <a:solidFill>
+                        <a:srgbClr val="D3DAE3"/>
+                      </a:solidFill>
+                      <a:prstDash val="solid"/>
+                      <a:round/>
+                      <a:headEnd type="none" w="med" len="med"/>
+                      <a:tailEnd type="none" w="med" len="med"/>
+                    </a:lnT>
+                    <a:lnB w="6350" cap="flat" cmpd="sng" algn="ctr">
+                      <a:solidFill>
+                        <a:srgbClr val="D3DAE3"/>
+                      </a:solidFill>
+                      <a:prstDash val="solid"/>
+                      <a:round/>
+                      <a:headEnd type="none" w="med" len="med"/>
+                      <a:tailEnd type="none" w="med" len="med"/>
+                    </a:lnB>
+                    <a:solidFill>
+                      <a:srgbClr val="FFFFFF"/>
+                    </a:solidFill>
+                  </a:tcPr>
+                </a:tc>
+              </a:tr>
+              <a:tr h="329184">
+                <a:tc>
+                  <a:txBody>
+                    <a:bodyPr/>
+                    <a:lstStyle/>
+                    <a:p>
+                      <a:pPr algn="l" indent="0" marL="0">
+                        <a:buNone/>
+                      </a:pPr>
+                      <a:r>
+                        <a:rPr lang="en-US" sz="1100" dirty="0">
+                          <a:solidFill>
+                            <a:schemeClr val="tx1"/>
+                          </a:solidFill>
+                        </a:rPr>
+                        <a:t>Mom. + Economic</a:t>
+                      </a:r>
+                      <a:endParaRPr lang="en-US" sz="1100" dirty="0"/>
+                    </a:p>
+                  </a:txBody>
+                  <a:tcPr marL="54864" marR="54864" marT="0" marB="0" anchor="ctr">
+                    <a:lnL w="6350" cap="flat" cmpd="sng" algn="ctr">
+                      <a:solidFill>
+                        <a:srgbClr val="D3DAE3"/>
+                      </a:solidFill>
+                      <a:prstDash val="solid"/>
+                      <a:round/>
+                      <a:headEnd type="none" w="med" len="med"/>
+                      <a:tailEnd type="none" w="med" len="med"/>
+                    </a:lnL>
+                    <a:lnR w="6350" cap="flat" cmpd="sng" algn="ctr">
+                      <a:solidFill>
+                        <a:srgbClr val="D3DAE3"/>
+                      </a:solidFill>
+                      <a:prstDash val="solid"/>
+                      <a:round/>
+                      <a:headEnd type="none" w="med" len="med"/>
+                      <a:tailEnd type="none" w="med" len="med"/>
+                    </a:lnR>
+                    <a:lnT w="6350" cap="flat" cmpd="sng" algn="ctr">
+                      <a:solidFill>
+                        <a:srgbClr val="D3DAE3"/>
+                      </a:solidFill>
+                      <a:prstDash val="solid"/>
+                      <a:round/>
+                      <a:headEnd type="none" w="med" len="med"/>
+                      <a:tailEnd type="none" w="med" len="med"/>
+                    </a:lnT>
+                    <a:lnB w="6350" cap="flat" cmpd="sng" algn="ctr">
+                      <a:solidFill>
+                        <a:srgbClr val="D3DAE3"/>
+                      </a:solidFill>
+                      <a:prstDash val="solid"/>
+                      <a:round/>
+                      <a:headEnd type="none" w="med" len="med"/>
+                      <a:tailEnd type="none" w="med" len="med"/>
+                    </a:lnB>
+                    <a:solidFill>
+                      <a:srgbClr val="FFFFFF"/>
+                    </a:solidFill>
+                  </a:tcPr>
+                </a:tc>
+                <a:tc>
+                  <a:txBody>
+                    <a:bodyPr/>
+                    <a:lstStyle/>
+                    <a:p>
+                      <a:pPr algn="l" indent="0" marL="0">
+                        <a:buNone/>
+                      </a:pPr>
+                      <a:r>
+                        <a:rPr lang="en-US" sz="1100" dirty="0">
+                          <a:solidFill>
+                            <a:schemeClr val="tx1"/>
+                          </a:solidFill>
+                        </a:rPr>
+                        <a:t>1.307</a:t>
+                      </a:r>
+                      <a:endParaRPr lang="en-US" sz="1100" dirty="0"/>
+                    </a:p>
+                  </a:txBody>
+                  <a:tcPr marL="54864" marR="54864" marT="0" marB="0" anchor="ctr">
+                    <a:lnL w="6350" cap="flat" cmpd="sng" algn="ctr">
+                      <a:solidFill>
+                        <a:srgbClr val="D3DAE3"/>
+                      </a:solidFill>
+                      <a:prstDash val="solid"/>
+                      <a:round/>
+                      <a:headEnd type="none" w="med" len="med"/>
+                      <a:tailEnd type="none" w="med" len="med"/>
+                    </a:lnL>
+                    <a:lnR w="6350" cap="flat" cmpd="sng" algn="ctr">
+                      <a:solidFill>
+                        <a:srgbClr val="D3DAE3"/>
+                      </a:solidFill>
+                      <a:prstDash val="solid"/>
+                      <a:round/>
+                      <a:headEnd type="none" w="med" len="med"/>
+                      <a:tailEnd type="none" w="med" len="med"/>
+                    </a:lnR>
+                    <a:lnT w="6350" cap="flat" cmpd="sng" algn="ctr">
+                      <a:solidFill>
+                        <a:srgbClr val="D3DAE3"/>
+                      </a:solidFill>
+                      <a:prstDash val="solid"/>
+                      <a:round/>
+                      <a:headEnd type="none" w="med" len="med"/>
+                      <a:tailEnd type="none" w="med" len="med"/>
+                    </a:lnT>
+                    <a:lnB w="6350" cap="flat" cmpd="sng" algn="ctr">
+                      <a:solidFill>
+                        <a:srgbClr val="D3DAE3"/>
+                      </a:solidFill>
+                      <a:prstDash val="solid"/>
+                      <a:round/>
+                      <a:headEnd type="none" w="med" len="med"/>
+                      <a:tailEnd type="none" w="med" len="med"/>
+                    </a:lnB>
+                    <a:solidFill>
+                      <a:srgbClr val="FFFFFF"/>
+                    </a:solidFill>
+                  </a:tcPr>
+                </a:tc>
+                <a:tc>
+                  <a:txBody>
+                    <a:bodyPr/>
+                    <a:lstStyle/>
+                    <a:p>
+                      <a:pPr algn="l" indent="0" marL="0">
+                        <a:buNone/>
+                      </a:pPr>
+                      <a:r>
+                        <a:rPr lang="en-US" sz="1100" dirty="0">
+                          <a:solidFill>
+                            <a:schemeClr val="tx1"/>
+                          </a:solidFill>
+                        </a:rPr>
+                        <a:t>3.38</a:t>
+                      </a:r>
+                      <a:endParaRPr lang="en-US" sz="1100" dirty="0"/>
+                    </a:p>
+                  </a:txBody>
+                  <a:tcPr marL="54864" marR="54864" marT="0" marB="0" anchor="ctr">
+                    <a:lnL w="6350" cap="flat" cmpd="sng" algn="ctr">
+                      <a:solidFill>
+                        <a:srgbClr val="D3DAE3"/>
+                      </a:solidFill>
+                      <a:prstDash val="solid"/>
+                      <a:round/>
+                      <a:headEnd type="none" w="med" len="med"/>
+                      <a:tailEnd type="none" w="med" len="med"/>
+                    </a:lnL>
+                    <a:lnR w="6350" cap="flat" cmpd="sng" algn="ctr">
+                      <a:solidFill>
+                        <a:srgbClr val="D3DAE3"/>
+                      </a:solidFill>
+                      <a:prstDash val="solid"/>
+                      <a:round/>
+                      <a:headEnd type="none" w="med" len="med"/>
+                      <a:tailEnd type="none" w="med" len="med"/>
+                    </a:lnR>
+                    <a:lnT w="6350" cap="flat" cmpd="sng" algn="ctr">
+                      <a:solidFill>
+                        <a:srgbClr val="D3DAE3"/>
+                      </a:solidFill>
+                      <a:prstDash val="solid"/>
+                      <a:round/>
+                      <a:headEnd type="none" w="med" len="med"/>
+                      <a:tailEnd type="none" w="med" len="med"/>
+                    </a:lnT>
+                    <a:lnB w="6350" cap="flat" cmpd="sng" algn="ctr">
+                      <a:solidFill>
+                        <a:srgbClr val="D3DAE3"/>
+                      </a:solidFill>
+                      <a:prstDash val="solid"/>
+                      <a:round/>
+                      <a:headEnd type="none" w="med" len="med"/>
+                      <a:tailEnd type="none" w="med" len="med"/>
+                    </a:lnB>
+                    <a:solidFill>
+                      <a:srgbClr val="FFFFFF"/>
+                    </a:solidFill>
+                  </a:tcPr>
+                </a:tc>
+                <a:tc>
+                  <a:txBody>
+                    <a:bodyPr/>
+                    <a:lstStyle/>
+                    <a:p>
+                      <a:pPr algn="l" indent="0" marL="0">
+                        <a:buNone/>
+                      </a:pPr>
+                      <a:r>
+                        <a:rPr lang="en-US" sz="1100" dirty="0">
+                          <a:solidFill>
+                            <a:schemeClr val="tx1"/>
+                          </a:solidFill>
+                        </a:rPr>
+                        <a:t>0.932</a:t>
+                      </a:r>
+                      <a:endParaRPr lang="en-US" sz="1100" dirty="0"/>
+                    </a:p>
+                  </a:txBody>
+                  <a:tcPr marL="54864" marR="54864" marT="0" marB="0" anchor="ctr">
+                    <a:lnL w="6350" cap="flat" cmpd="sng" algn="ctr">
+                      <a:solidFill>
+                        <a:srgbClr val="D3DAE3"/>
+                      </a:solidFill>
+                      <a:prstDash val="solid"/>
+                      <a:round/>
+                      <a:headEnd type="none" w="med" len="med"/>
+                      <a:tailEnd type="none" w="med" len="med"/>
+                    </a:lnL>
+                    <a:lnR w="6350" cap="flat" cmpd="sng" algn="ctr">
+                      <a:solidFill>
+                        <a:srgbClr val="D3DAE3"/>
+                      </a:solidFill>
+                      <a:prstDash val="solid"/>
+                      <a:round/>
+                      <a:headEnd type="none" w="med" len="med"/>
+                      <a:tailEnd type="none" w="med" len="med"/>
+                    </a:lnR>
+                    <a:lnT w="6350" cap="flat" cmpd="sng" algn="ctr">
+                      <a:solidFill>
+                        <a:srgbClr val="D3DAE3"/>
+                      </a:solidFill>
+                      <a:prstDash val="solid"/>
+                      <a:round/>
+                      <a:headEnd type="none" w="med" len="med"/>
+                      <a:tailEnd type="none" w="med" len="med"/>
+                    </a:lnT>
+                    <a:lnB w="6350" cap="flat" cmpd="sng" algn="ctr">
+                      <a:solidFill>
+                        <a:srgbClr val="D3DAE3"/>
+                      </a:solidFill>
+                      <a:prstDash val="solid"/>
+                      <a:round/>
+                      <a:headEnd type="none" w="med" len="med"/>
+                      <a:tailEnd type="none" w="med" len="med"/>
+                    </a:lnB>
+                    <a:solidFill>
+                      <a:srgbClr val="FFFFFF"/>
+                    </a:solidFill>
+                  </a:tcPr>
+                </a:tc>
+                <a:tc>
+                  <a:txBody>
+                    <a:bodyPr/>
+                    <a:lstStyle/>
+                    <a:p>
+                      <a:pPr algn="l" indent="0" marL="0">
+                        <a:buNone/>
+                      </a:pPr>
+                      <a:r>
+                        <a:rPr lang="en-US" sz="1100" dirty="0">
+                          <a:solidFill>
+                            <a:schemeClr val="tx1"/>
+                          </a:solidFill>
+                        </a:rPr>
+                        <a:t>9.83</a:t>
+                      </a:r>
+                      <a:endParaRPr lang="en-US" sz="1100" dirty="0"/>
                     </a:p>
                   </a:txBody>
                   <a:tcPr marL="54864" marR="54864" marT="0" marB="0" anchor="ctr">
@@ -15018,8 +17973,8 @@
         </p:nvSpPr>
         <p:spPr>
           <a:xfrm>
-            <a:off x="7406640" y="4343400"/>
-            <a:ext cx="4251960" cy="1645920"/>
+            <a:off x="7406640" y="4709160"/>
+            <a:ext cx="4251960" cy="1371600"/>
           </a:xfrm>
           <a:prstGeom prst="rect">
             <a:avLst/>
@@ -15035,56 +17990,56 @@
               <a:buNone/>
             </a:pPr>
             <a:r>
-              <a:rPr lang="en-US" sz="1600" b="1" dirty="0">
+              <a:rPr lang="en-US" sz="1500" b="1" dirty="0">
                 <a:solidFill>
                   <a:schemeClr val="tx1"/>
                 </a:solidFill>
               </a:rPr>
               <a:t>12% lower MAE</a:t>
             </a:r>
-            <a:endParaRPr lang="en-US" sz="1600" dirty="0"/>
+            <a:endParaRPr lang="en-US" sz="1500" dirty="0"/>
           </a:p>
           <a:p>
             <a:pPr indent="0" marL="0">
               <a:buNone/>
             </a:pPr>
             <a:r>
-              <a:rPr lang="en-US" sz="1600" dirty="0">
+              <a:rPr lang="en-US" sz="1500" dirty="0">
                 <a:solidFill>
                   <a:schemeClr val="accent6"/>
                 </a:solidFill>
               </a:rPr>
               <a:t>than the same nine features predicting the count</a:t>
             </a:r>
-            <a:endParaRPr lang="en-US" sz="1600" dirty="0"/>
+            <a:endParaRPr lang="en-US" sz="1500" dirty="0"/>
           </a:p>
           <a:p>
             <a:pPr indent="0" marL="0">
               <a:buNone/>
             </a:pPr>
             <a:r>
-              <a:rPr lang="en-US" sz="1600" b="1" dirty="0">
+              <a:rPr lang="en-US" sz="1500" b="1" dirty="0">
                 <a:solidFill>
                   <a:schemeClr val="tx1"/>
                 </a:solidFill>
               </a:rPr>
               <a:t>12% lower RMSE</a:t>
             </a:r>
-            <a:endParaRPr lang="en-US" sz="1600" dirty="0"/>
+            <a:endParaRPr lang="en-US" sz="1500" dirty="0"/>
           </a:p>
           <a:p>
             <a:pPr indent="0" marL="0">
               <a:buNone/>
             </a:pPr>
             <a:r>
-              <a:rPr lang="en-US" sz="1600" dirty="0">
+              <a:rPr lang="en-US" sz="1500" dirty="0">
                 <a:solidFill>
                   <a:schemeClr val="accent6"/>
                 </a:solidFill>
               </a:rPr>
               <a:t>than the previous-medals baseline</a:t>
             </a:r>
-            <a:endParaRPr lang="en-US" sz="1600" dirty="0"/>
+            <a:endParaRPr lang="en-US" sz="1500" dirty="0"/>
           </a:p>
         </p:txBody>
       </p:sp>

</xml_diff>

<commit_message>
Update website, notebook, report, slides and README for the paper's best model
</commit_message>
<xml_diff>
--- a/deliverables/Olympic_Medal_Momentum_Slides.pptx
+++ b/deliverables/Olympic_Medal_Momentum_Slides.pptx
@@ -122,13 +122,13 @@
   <p:extLst>
     <p:ext uri="{521415D9-36F7-43E2-AB2F-B90AF26B5E84}">
       <p14:sectionLst xmlns:p14="http://schemas.microsoft.com/office/powerpoint/2010/main">
-        <p14:section name="Introduction" id="{12b5dc41-7222-9d0e-f0b3-78748c1d72e6}">
+        <p14:section name="Introduction" id="{51e84f3f-8a82-9b81-f2a1-2c2174d53442}">
           <p14:sldIdLst>
             <p14:sldId id="256"/>
             <p14:sldId id="257"/>
           </p14:sldIdLst>
         </p14:section>
-        <p14:section name="Data and method" id="{43f382e0-772b-6274-545e-4ac914da8b4c}">
+        <p14:section name="Data and method" id="{502a6920-3a41-41bf-0456-72a0ee74f284}">
           <p14:sldIdLst>
             <p14:sldId id="258"/>
             <p14:sldId id="259"/>
@@ -136,13 +136,13 @@
             <p14:sldId id="261"/>
           </p14:sldIdLst>
         </p14:section>
-        <p14:section name="Novelty" id="{c7ab8d55-6342-9713-661f-af745313a0f4}">
+        <p14:section name="Novelty" id="{6e3f49a0-aa14-e278-206b-0fc86e9f9a48}">
           <p14:sldIdLst>
             <p14:sldId id="262"/>
             <p14:sldId id="263"/>
           </p14:sldIdLst>
         </p14:section>
-        <p14:section name="Results" id="{6a0d89e2-90bc-8fa8-544f-ed971772c9c5}">
+        <p14:section name="Results" id="{da1f75a2-a20e-a9b5-2219-396b9c20ec6e}">
           <p14:sldIdLst>
             <p14:sldId id="264"/>
             <p14:sldId id="265"/>
@@ -151,7 +151,7 @@
             <p14:sldId id="268"/>
           </p14:sldIdLst>
         </p14:section>
-        <p14:section name="Conclusion" id="{af2bb3c6-bb71-4985-7f5c-f6121afb754a}">
+        <p14:section name="Conclusion" id="{6f08ff34-1dcf-e432-9126-863752ece3f2}">
           <p14:sldIdLst>
             <p14:sldId id="269"/>
             <p14:sldId id="270"/>
@@ -1355,9 +1355,9 @@
           </c:dLbls>
           <c:cat>
             <c:multiLvlStrRef>
-              <c:f>Sheet1!$A$2:$A$7</c:f>
+              <c:f>Sheet1!$A$2:$A$8</c:f>
               <c:multiLvlStrCache>
-                <c:ptCount val="6"/>
+                <c:ptCount val="7"/>
                 <c:lvl>
                   <c:pt idx="0">
                     <c:v>Linear Regression</c:v>
@@ -1377,16 +1377,19 @@
                   <c:pt idx="5">
                     <c:v>Random Forest</c:v>
                   </c:pt>
+                  <c:pt idx="6">
+                    <c:v>Paper best: Naive Bayes + Ridge</c:v>
+                  </c:pt>
                 </c:lvl>
               </c:multiLvlStrCache>
             </c:multiLvlStrRef>
           </c:cat>
           <c:val>
             <c:numRef>
-              <c:f>Sheet1!$B$2:$B$7</c:f>
+              <c:f>Sheet1!$B$2:$B$8</c:f>
               <c:numCache>
                 <c:formatCode>General</c:formatCode>
-                <c:ptCount val="6"/>
+                <c:ptCount val="7"/>
                 <c:pt idx="0">
                   <c:v>2.22</c:v>
                 </c:pt>
@@ -1404,6 +1407,9 @@
                 </c:pt>
                 <c:pt idx="5">
                   <c:v>1.48</c:v>
+                </c:pt>
+                <c:pt idx="6">
+                  <c:v>2.12</c:v>
                 </c:pt>
               </c:numCache>
             </c:numRef>
@@ -1456,9 +1462,9 @@
           </c:dLbls>
           <c:cat>
             <c:multiLvlStrRef>
-              <c:f>Sheet1!$A$2:$A$7</c:f>
+              <c:f>Sheet1!$A$2:$A$8</c:f>
               <c:multiLvlStrCache>
-                <c:ptCount val="6"/>
+                <c:ptCount val="7"/>
                 <c:lvl>
                   <c:pt idx="0">
                     <c:v>Linear Regression</c:v>
@@ -1478,16 +1484,19 @@
                   <c:pt idx="5">
                     <c:v>Random Forest</c:v>
                   </c:pt>
+                  <c:pt idx="6">
+                    <c:v>Paper best: Naive Bayes + Ridge</c:v>
+                  </c:pt>
                 </c:lvl>
               </c:multiLvlStrCache>
             </c:multiLvlStrRef>
           </c:cat>
           <c:val>
             <c:numRef>
-              <c:f>Sheet1!$C$2:$C$7</c:f>
+              <c:f>Sheet1!$C$2:$C$8</c:f>
               <c:numCache>
                 <c:formatCode>General</c:formatCode>
-                <c:ptCount val="6"/>
+                <c:ptCount val="7"/>
                 <c:pt idx="0">
                   <c:v>1.38</c:v>
                 </c:pt>
@@ -1505,6 +1514,9 @@
                 </c:pt>
                 <c:pt idx="5">
                   <c:v>1.31</c:v>
+                </c:pt>
+                <c:pt idx="6">
+                  <c:v>1.34</c:v>
                 </c:pt>
               </c:numCache>
             </c:numRef>
@@ -2975,7 +2987,7 @@
           <a:p>
             <a:r>
               <a:rPr lang="en-US" dirty="0"/>
-              <a:t>Each regressor uses history plus World Bank features, is tuned on 2012 (trained 1964-2008), refitted on 1964-2012 and tested once on Rio 2016. Poisson needs a count target so it has no momentum version. SVR predicting the count is the exception: it has the best RMSE and top-10 error, but this is one test year. The classifier accuracies match the paper's own table (85.5-89.1%).</a:t>
+              <a:t>Each regressor uses history plus World Bank features, is tuned on 2012 (trained 1964-2008), refitted on 1964-2012 and tested once on Rio 2016. Poisson needs a count target so it has no momentum version. 'Paper best' is the paper's own Naive Bayes classifier + Ridge regressor pairing. SVR predicting the count is the exception: it has the best RMSE and top-10 error, but this is one test year. The classifier accuracies match the paper's own table (85.5-89.1%).</a:t>
             </a:r>
             <a:endParaRPr lang="en-US" dirty="0"/>
           </a:p>
@@ -5600,7 +5612,7 @@
                   <a:schemeClr val="tx1"/>
                 </a:solidFill>
               </a:rPr>
-              <a:t>The paper’s models, re-run: momentum helps four of five</a:t>
+              <a:t>The paper’s models, re-run: momentum helps five of six</a:t>
             </a:r>
             <a:endParaRPr lang="en-US" sz="3400" dirty="0"/>
           </a:p>
@@ -9951,7 +9963,7 @@
                   <a:schemeClr val="bg1"/>
                 </a:solidFill>
               </a:rPr>
-              <a:t>Predicting momentum also helps Linear, Ridge, Lasso and Random Forest models. The momentum score alone adds nothing, and on Tokyo 2020 the paper’s World Bank models win. The contribution is the target design.</a:t>
+              <a:t>Predicting momentum also helps Linear, Ridge, Lasso, Random Forest and the paper’s best Naive Bayes + Ridge model. The momentum score alone adds nothing, and on Tokyo 2020 the paper’s World Bank models win. The contribution is the target design.</a:t>
             </a:r>
             <a:endParaRPr lang="en-US" sz="1900" dirty="0"/>
           </a:p>

</xml_diff>

<commit_message>
Redesign website with live predictor, stadium hero and Olympic colour accents
</commit_message>
<xml_diff>
--- a/deliverables/Olympic_Medal_Momentum_Slides.pptx
+++ b/deliverables/Olympic_Medal_Momentum_Slides.pptx
@@ -122,13 +122,13 @@
   <p:extLst>
     <p:ext uri="{521415D9-36F7-43E2-AB2F-B90AF26B5E84}">
       <p14:sectionLst xmlns:p14="http://schemas.microsoft.com/office/powerpoint/2010/main">
-        <p14:section name="Introduction" id="{51e84f3f-8a82-9b81-f2a1-2c2174d53442}">
+        <p14:section name="Introduction" id="{946f7c05-29b8-7bfe-65f4-a6ccdd292361}">
           <p14:sldIdLst>
             <p14:sldId id="256"/>
             <p14:sldId id="257"/>
           </p14:sldIdLst>
         </p14:section>
-        <p14:section name="Data and method" id="{502a6920-3a41-41bf-0456-72a0ee74f284}">
+        <p14:section name="Data and method" id="{90a0c6ec-72e7-24f3-fddb-10e647f7e82b}">
           <p14:sldIdLst>
             <p14:sldId id="258"/>
             <p14:sldId id="259"/>
@@ -136,13 +136,13 @@
             <p14:sldId id="261"/>
           </p14:sldIdLst>
         </p14:section>
-        <p14:section name="Novelty" id="{6e3f49a0-aa14-e278-206b-0fc86e9f9a48}">
+        <p14:section name="Novelty" id="{bfdcd973-103e-c98f-f5dd-8b1e464e220e}">
           <p14:sldIdLst>
             <p14:sldId id="262"/>
             <p14:sldId id="263"/>
           </p14:sldIdLst>
         </p14:section>
-        <p14:section name="Results" id="{da1f75a2-a20e-a9b5-2219-396b9c20ec6e}">
+        <p14:section name="Results" id="{7156f0a9-9678-542a-b61e-154e5bfdc5c0}">
           <p14:sldIdLst>
             <p14:sldId id="264"/>
             <p14:sldId id="265"/>
@@ -151,7 +151,7 @@
             <p14:sldId id="268"/>
           </p14:sldIdLst>
         </p14:section>
-        <p14:section name="Conclusion" id="{6f08ff34-1dcf-e432-9126-863752ece3f2}">
+        <p14:section name="Conclusion" id="{8257f7e7-65a1-00d8-16e9-0484b15a8c29}">
           <p14:sldIdLst>
             <p14:sldId id="269"/>
             <p14:sldId id="270"/>
@@ -10431,7 +10431,7 @@
                   <a:schemeClr val="accent6"/>
                 </a:solidFill>
               </a:rPr>
-              <a:t>Race view, model comparison, backtest and a country explorer</a:t>
+              <a:t>Live predictor running our forest, medal race view, model comparison and a country explorer</a:t>
             </a:r>
             <a:endParaRPr lang="en-US" sz="1500" dirty="0"/>
           </a:p>

</xml_diff>